<commit_message>
Add Concept Note PDF deliverable for project submission
</commit_message>
<xml_diff>
--- a/Pitch_Deck.pptx
+++ b/Pitch_Deck.pptx
@@ -5,20 +5,20 @@
     <p:sldMasterId id="2147483648" r:id="rId1"/>
   </p:sldMasterIdLst>
   <p:sldIdLst>
-    <p:sldId id="256" r:id="rId7"/>
-    <p:sldId id="257" r:id="rId8"/>
-    <p:sldId id="258" r:id="rId9"/>
-    <p:sldId id="259" r:id="rId10"/>
-    <p:sldId id="260" r:id="rId11"/>
-    <p:sldId id="261" r:id="rId12"/>
-    <p:sldId id="262" r:id="rId13"/>
-    <p:sldId id="263" r:id="rId14"/>
-    <p:sldId id="264" r:id="rId15"/>
-    <p:sldId id="265" r:id="rId16"/>
-    <p:sldId id="266" r:id="rId17"/>
-    <p:sldId id="267" r:id="rId18"/>
+    <p:sldId id="256" r:id="rId2"/>
+    <p:sldId id="257" r:id="rId3"/>
+    <p:sldId id="258" r:id="rId4"/>
+    <p:sldId id="259" r:id="rId5"/>
+    <p:sldId id="260" r:id="rId6"/>
+    <p:sldId id="261" r:id="rId7"/>
+    <p:sldId id="262" r:id="rId8"/>
+    <p:sldId id="263" r:id="rId9"/>
+    <p:sldId id="264" r:id="rId10"/>
+    <p:sldId id="265" r:id="rId11"/>
+    <p:sldId id="266" r:id="rId12"/>
+    <p:sldId id="267" r:id="rId13"/>
   </p:sldIdLst>
-  <p:sldSz cx="12191695" cy="6858000" type="screen4x3"/>
+  <p:sldSz cx="12192000" cy="6858000"/>
   <p:notesSz cx="6858000" cy="9144000"/>
   <p:defaultTextStyle>
     <a:defPPr>
@@ -115,7 +115,114 @@
       </a:defRPr>
     </a:lvl9pPr>
   </p:defaultTextStyle>
+  <p:extLst>
+    <p:ext uri="{EFAFB233-063F-42B5-8137-9DF3F51BA10A}">
+      <p15:sldGuideLst xmlns:p15="http://schemas.microsoft.com/office/powerpoint/2012/main">
+        <p15:guide id="1" orient="horz" pos="2160">
+          <p15:clr>
+            <a:srgbClr val="A4A3A4"/>
+          </p15:clr>
+        </p15:guide>
+        <p15:guide id="2" pos="2880">
+          <p15:clr>
+            <a:srgbClr val="A4A3A4"/>
+          </p15:clr>
+        </p15:guide>
+      </p15:sldGuideLst>
+    </p:ext>
+  </p:extLst>
 </p:presentation>
+</file>
+
+<file path=ppt/revisionInfo.xml><?xml version="1.0" encoding="utf-8"?>
+<p1510:revInfo xmlns:a="http://schemas.openxmlformats.org/drawingml/2006/main" xmlns:r="http://schemas.openxmlformats.org/officeDocument/2006/relationships" xmlns:p1510="http://schemas.microsoft.com/office/powerpoint/2015/10/main">
+  <p1510:revLst>
+    <p1510:client id="{E4859A45-D5CB-456D-87D3-1DAFC14A0D54}" v="11" dt="2026-07-25T14:14:57.947"/>
+  </p1510:revLst>
+</p1510:revInfo>
+</file>
+
+<file path=ppt/changesInfos/changesInfo1.xml><?xml version="1.0" encoding="utf-8"?>
+<pc:chgInfo xmlns:a="http://schemas.openxmlformats.org/drawingml/2006/main" xmlns:r="http://schemas.openxmlformats.org/officeDocument/2006/relationships" xmlns:ac="http://schemas.microsoft.com/office/drawing/2013/main/command" xmlns:pc="http://schemas.microsoft.com/office/powerpoint/2013/main/command">
+  <pc:docChgLst>
+    <pc:chgData name="soujanya hegde" userId="f77445fcd24c4716" providerId="LiveId" clId="{19ACCCFD-CE44-4D36-9959-419B71920180}"/>
+    <pc:docChg chg="undo custSel modSld">
+      <pc:chgData name="soujanya hegde" userId="f77445fcd24c4716" providerId="LiveId" clId="{19ACCCFD-CE44-4D36-9959-419B71920180}" dt="2026-07-25T14:15:12.877" v="99" actId="20577"/>
+      <pc:docMkLst>
+        <pc:docMk/>
+      </pc:docMkLst>
+      <pc:sldChg chg="modSp mod">
+        <pc:chgData name="soujanya hegde" userId="f77445fcd24c4716" providerId="LiveId" clId="{19ACCCFD-CE44-4D36-9959-419B71920180}" dt="2026-07-25T14:15:12.877" v="99" actId="20577"/>
+        <pc:sldMkLst>
+          <pc:docMk/>
+          <pc:sldMk cId="0" sldId="256"/>
+        </pc:sldMkLst>
+        <pc:spChg chg="mod">
+          <ac:chgData name="soujanya hegde" userId="f77445fcd24c4716" providerId="LiveId" clId="{19ACCCFD-CE44-4D36-9959-419B71920180}" dt="2026-07-25T14:15:12.877" v="99" actId="20577"/>
+          <ac:spMkLst>
+            <pc:docMk/>
+            <pc:sldMk cId="0" sldId="256"/>
+            <ac:spMk id="3" creationId="{00000000-0000-0000-0000-000000000000}"/>
+          </ac:spMkLst>
+        </pc:spChg>
+        <pc:spChg chg="mod">
+          <ac:chgData name="soujanya hegde" userId="f77445fcd24c4716" providerId="LiveId" clId="{19ACCCFD-CE44-4D36-9959-419B71920180}" dt="2026-07-25T14:12:47.889" v="60"/>
+          <ac:spMkLst>
+            <pc:docMk/>
+            <pc:sldMk cId="0" sldId="256"/>
+            <ac:spMk id="4" creationId="{00000000-0000-0000-0000-000000000000}"/>
+          </ac:spMkLst>
+        </pc:spChg>
+      </pc:sldChg>
+      <pc:sldChg chg="modSp mod">
+        <pc:chgData name="soujanya hegde" userId="f77445fcd24c4716" providerId="LiveId" clId="{19ACCCFD-CE44-4D36-9959-419B71920180}" dt="2026-07-25T14:02:05.145" v="0" actId="1076"/>
+        <pc:sldMkLst>
+          <pc:docMk/>
+          <pc:sldMk cId="0" sldId="257"/>
+        </pc:sldMkLst>
+        <pc:spChg chg="mod">
+          <ac:chgData name="soujanya hegde" userId="f77445fcd24c4716" providerId="LiveId" clId="{19ACCCFD-CE44-4D36-9959-419B71920180}" dt="2026-07-25T14:02:05.145" v="0" actId="1076"/>
+          <ac:spMkLst>
+            <pc:docMk/>
+            <pc:sldMk cId="0" sldId="257"/>
+            <ac:spMk id="4" creationId="{00000000-0000-0000-0000-000000000000}"/>
+          </ac:spMkLst>
+        </pc:spChg>
+      </pc:sldChg>
+      <pc:sldChg chg="addSp delSp modSp mod">
+        <pc:chgData name="soujanya hegde" userId="f77445fcd24c4716" providerId="LiveId" clId="{19ACCCFD-CE44-4D36-9959-419B71920180}" dt="2026-07-25T14:10:16.412" v="36" actId="14100"/>
+        <pc:sldMkLst>
+          <pc:docMk/>
+          <pc:sldMk cId="0" sldId="265"/>
+        </pc:sldMkLst>
+        <pc:picChg chg="add mod">
+          <ac:chgData name="soujanya hegde" userId="f77445fcd24c4716" providerId="LiveId" clId="{19ACCCFD-CE44-4D36-9959-419B71920180}" dt="2026-07-25T14:10:10.163" v="35" actId="14100"/>
+          <ac:picMkLst>
+            <pc:docMk/>
+            <pc:sldMk cId="0" sldId="265"/>
+            <ac:picMk id="6" creationId="{4CB529A3-191C-DA00-B61E-9802DC0E744F}"/>
+          </ac:picMkLst>
+        </pc:picChg>
+        <pc:picChg chg="add del mod">
+          <ac:chgData name="soujanya hegde" userId="f77445fcd24c4716" providerId="LiveId" clId="{19ACCCFD-CE44-4D36-9959-419B71920180}" dt="2026-07-25T14:09:38.323" v="26" actId="478"/>
+          <ac:picMkLst>
+            <pc:docMk/>
+            <pc:sldMk cId="0" sldId="265"/>
+            <ac:picMk id="8" creationId="{9860DE7D-A750-0343-68F5-A8DED4579729}"/>
+          </ac:picMkLst>
+        </pc:picChg>
+        <pc:picChg chg="add mod">
+          <ac:chgData name="soujanya hegde" userId="f77445fcd24c4716" providerId="LiveId" clId="{19ACCCFD-CE44-4D36-9959-419B71920180}" dt="2026-07-25T14:10:16.412" v="36" actId="14100"/>
+          <ac:picMkLst>
+            <pc:docMk/>
+            <pc:sldMk cId="0" sldId="265"/>
+            <ac:picMk id="10" creationId="{6E660052-1500-34F0-7040-BDBC74E8F69C}"/>
+          </ac:picMkLst>
+        </pc:picChg>
+      </pc:sldChg>
+    </pc:docChg>
+  </pc:docChgLst>
+</pc:chgInfo>
 </file>
 
 <file path=ppt/slideLayouts/slideLayout1.xml><?xml version="1.0" encoding="utf-8"?>
@@ -156,10 +263,9 @@
           <a:lstStyle/>
           <a:p>
             <a:r>
-              <a:rPr lang="en-US" smtClean="0"/>
+              <a:rPr lang="en-US"/>
               <a:t>Click to edit Master title style</a:t>
             </a:r>
-            <a:endParaRPr lang="en-US"/>
           </a:p>
         </p:txBody>
       </p:sp>
@@ -275,10 +381,9 @@
           </a:lstStyle>
           <a:p>
             <a:r>
-              <a:rPr lang="en-US" smtClean="0"/>
+              <a:rPr lang="en-US"/>
               <a:t>Click to edit Master subtitle style</a:t>
             </a:r>
-            <a:endParaRPr lang="en-US"/>
           </a:p>
         </p:txBody>
       </p:sp>
@@ -299,7 +404,7 @@
           <a:p>
             <a:fld id="{5BCAD085-E8A6-8845-BD4E-CB4CCA059FC4}" type="datetimeFigureOut">
               <a:rPr lang="en-US" smtClean="0"/>
-              <a:t>1/27/13</a:t>
+              <a:t>7/25/2026</a:t>
             </a:fld>
             <a:endParaRPr lang="en-US"/>
           </a:p>
@@ -393,10 +498,9 @@
           <a:lstStyle/>
           <a:p>
             <a:r>
-              <a:rPr lang="en-US" smtClean="0"/>
+              <a:rPr lang="en-US"/>
               <a:t>Click to edit Master title style</a:t>
             </a:r>
-            <a:endParaRPr lang="en-US"/>
           </a:p>
         </p:txBody>
       </p:sp>
@@ -417,38 +521,37 @@
           <a:p>
             <a:pPr lvl="0"/>
             <a:r>
-              <a:rPr lang="en-US" smtClean="0"/>
+              <a:rPr lang="en-US"/>
               <a:t>Click to edit Master text styles</a:t>
             </a:r>
           </a:p>
           <a:p>
             <a:pPr lvl="1"/>
             <a:r>
-              <a:rPr lang="en-US" smtClean="0"/>
+              <a:rPr lang="en-US"/>
               <a:t>Second level</a:t>
             </a:r>
           </a:p>
           <a:p>
             <a:pPr lvl="2"/>
             <a:r>
-              <a:rPr lang="en-US" smtClean="0"/>
+              <a:rPr lang="en-US"/>
               <a:t>Third level</a:t>
             </a:r>
           </a:p>
           <a:p>
             <a:pPr lvl="3"/>
             <a:r>
-              <a:rPr lang="en-US" smtClean="0"/>
+              <a:rPr lang="en-US"/>
               <a:t>Fourth level</a:t>
             </a:r>
           </a:p>
           <a:p>
             <a:pPr lvl="4"/>
             <a:r>
-              <a:rPr lang="en-US" smtClean="0"/>
+              <a:rPr lang="en-US"/>
               <a:t>Fifth level</a:t>
             </a:r>
-            <a:endParaRPr lang="en-US"/>
           </a:p>
         </p:txBody>
       </p:sp>
@@ -469,7 +572,7 @@
           <a:p>
             <a:fld id="{5BCAD085-E8A6-8845-BD4E-CB4CCA059FC4}" type="datetimeFigureOut">
               <a:rPr lang="en-US" smtClean="0"/>
-              <a:t>1/27/13</a:t>
+              <a:t>7/25/2026</a:t>
             </a:fld>
             <a:endParaRPr lang="en-US"/>
           </a:p>
@@ -568,10 +671,9 @@
           <a:lstStyle/>
           <a:p>
             <a:r>
-              <a:rPr lang="en-US" smtClean="0"/>
+              <a:rPr lang="en-US"/>
               <a:t>Click to edit Master title style</a:t>
             </a:r>
-            <a:endParaRPr lang="en-US"/>
           </a:p>
         </p:txBody>
       </p:sp>
@@ -597,38 +699,37 @@
           <a:p>
             <a:pPr lvl="0"/>
             <a:r>
-              <a:rPr lang="en-US" smtClean="0"/>
+              <a:rPr lang="en-US"/>
               <a:t>Click to edit Master text styles</a:t>
             </a:r>
           </a:p>
           <a:p>
             <a:pPr lvl="1"/>
             <a:r>
-              <a:rPr lang="en-US" smtClean="0"/>
+              <a:rPr lang="en-US"/>
               <a:t>Second level</a:t>
             </a:r>
           </a:p>
           <a:p>
             <a:pPr lvl="2"/>
             <a:r>
-              <a:rPr lang="en-US" smtClean="0"/>
+              <a:rPr lang="en-US"/>
               <a:t>Third level</a:t>
             </a:r>
           </a:p>
           <a:p>
             <a:pPr lvl="3"/>
             <a:r>
-              <a:rPr lang="en-US" smtClean="0"/>
+              <a:rPr lang="en-US"/>
               <a:t>Fourth level</a:t>
             </a:r>
           </a:p>
           <a:p>
             <a:pPr lvl="4"/>
             <a:r>
-              <a:rPr lang="en-US" smtClean="0"/>
+              <a:rPr lang="en-US"/>
               <a:t>Fifth level</a:t>
             </a:r>
-            <a:endParaRPr lang="en-US"/>
           </a:p>
         </p:txBody>
       </p:sp>
@@ -649,7 +750,7 @@
           <a:p>
             <a:fld id="{5BCAD085-E8A6-8845-BD4E-CB4CCA059FC4}" type="datetimeFigureOut">
               <a:rPr lang="en-US" smtClean="0"/>
-              <a:t>1/27/13</a:t>
+              <a:t>7/25/2026</a:t>
             </a:fld>
             <a:endParaRPr lang="en-US"/>
           </a:p>
@@ -743,10 +844,9 @@
           <a:lstStyle/>
           <a:p>
             <a:r>
-              <a:rPr lang="en-US" smtClean="0"/>
+              <a:rPr lang="en-US"/>
               <a:t>Click to edit Master title style</a:t>
             </a:r>
-            <a:endParaRPr lang="en-US"/>
           </a:p>
         </p:txBody>
       </p:sp>
@@ -767,38 +867,37 @@
           <a:p>
             <a:pPr lvl="0"/>
             <a:r>
-              <a:rPr lang="en-US" smtClean="0"/>
+              <a:rPr lang="en-US"/>
               <a:t>Click to edit Master text styles</a:t>
             </a:r>
           </a:p>
           <a:p>
             <a:pPr lvl="1"/>
             <a:r>
-              <a:rPr lang="en-US" smtClean="0"/>
+              <a:rPr lang="en-US"/>
               <a:t>Second level</a:t>
             </a:r>
           </a:p>
           <a:p>
             <a:pPr lvl="2"/>
             <a:r>
-              <a:rPr lang="en-US" smtClean="0"/>
+              <a:rPr lang="en-US"/>
               <a:t>Third level</a:t>
             </a:r>
           </a:p>
           <a:p>
             <a:pPr lvl="3"/>
             <a:r>
-              <a:rPr lang="en-US" smtClean="0"/>
+              <a:rPr lang="en-US"/>
               <a:t>Fourth level</a:t>
             </a:r>
           </a:p>
           <a:p>
             <a:pPr lvl="4"/>
             <a:r>
-              <a:rPr lang="en-US" smtClean="0"/>
+              <a:rPr lang="en-US"/>
               <a:t>Fifth level</a:t>
             </a:r>
-            <a:endParaRPr lang="en-US"/>
           </a:p>
         </p:txBody>
       </p:sp>
@@ -819,7 +918,7 @@
           <a:p>
             <a:fld id="{5BCAD085-E8A6-8845-BD4E-CB4CCA059FC4}" type="datetimeFigureOut">
               <a:rPr lang="en-US" smtClean="0"/>
-              <a:t>1/27/13</a:t>
+              <a:t>7/25/2026</a:t>
             </a:fld>
             <a:endParaRPr lang="en-US"/>
           </a:p>
@@ -922,10 +1021,9 @@
           </a:lstStyle>
           <a:p>
             <a:r>
-              <a:rPr lang="en-US" smtClean="0"/>
+              <a:rPr lang="en-US"/>
               <a:t>Click to edit Master title style</a:t>
             </a:r>
-            <a:endParaRPr lang="en-US"/>
           </a:p>
         </p:txBody>
       </p:sp>
@@ -1042,7 +1140,7 @@
           <a:p>
             <a:pPr lvl="0"/>
             <a:r>
-              <a:rPr lang="en-US" smtClean="0"/>
+              <a:rPr lang="en-US"/>
               <a:t>Click to edit Master text styles</a:t>
             </a:r>
           </a:p>
@@ -1065,7 +1163,7 @@
           <a:p>
             <a:fld id="{5BCAD085-E8A6-8845-BD4E-CB4CCA059FC4}" type="datetimeFigureOut">
               <a:rPr lang="en-US" smtClean="0"/>
-              <a:t>1/27/13</a:t>
+              <a:t>7/25/2026</a:t>
             </a:fld>
             <a:endParaRPr lang="en-US"/>
           </a:p>
@@ -1159,10 +1257,9 @@
           <a:lstStyle/>
           <a:p>
             <a:r>
-              <a:rPr lang="en-US" smtClean="0"/>
+              <a:rPr lang="en-US"/>
               <a:t>Click to edit Master title style</a:t>
             </a:r>
-            <a:endParaRPr lang="en-US"/>
           </a:p>
         </p:txBody>
       </p:sp>
@@ -1216,38 +1313,37 @@
           <a:p>
             <a:pPr lvl="0"/>
             <a:r>
-              <a:rPr lang="en-US" smtClean="0"/>
+              <a:rPr lang="en-US"/>
               <a:t>Click to edit Master text styles</a:t>
             </a:r>
           </a:p>
           <a:p>
             <a:pPr lvl="1"/>
             <a:r>
-              <a:rPr lang="en-US" smtClean="0"/>
+              <a:rPr lang="en-US"/>
               <a:t>Second level</a:t>
             </a:r>
           </a:p>
           <a:p>
             <a:pPr lvl="2"/>
             <a:r>
-              <a:rPr lang="en-US" smtClean="0"/>
+              <a:rPr lang="en-US"/>
               <a:t>Third level</a:t>
             </a:r>
           </a:p>
           <a:p>
             <a:pPr lvl="3"/>
             <a:r>
-              <a:rPr lang="en-US" smtClean="0"/>
+              <a:rPr lang="en-US"/>
               <a:t>Fourth level</a:t>
             </a:r>
           </a:p>
           <a:p>
             <a:pPr lvl="4"/>
             <a:r>
-              <a:rPr lang="en-US" smtClean="0"/>
+              <a:rPr lang="en-US"/>
               <a:t>Fifth level</a:t>
             </a:r>
-            <a:endParaRPr lang="en-US"/>
           </a:p>
         </p:txBody>
       </p:sp>
@@ -1301,38 +1397,37 @@
           <a:p>
             <a:pPr lvl="0"/>
             <a:r>
-              <a:rPr lang="en-US" smtClean="0"/>
+              <a:rPr lang="en-US"/>
               <a:t>Click to edit Master text styles</a:t>
             </a:r>
           </a:p>
           <a:p>
             <a:pPr lvl="1"/>
             <a:r>
-              <a:rPr lang="en-US" smtClean="0"/>
+              <a:rPr lang="en-US"/>
               <a:t>Second level</a:t>
             </a:r>
           </a:p>
           <a:p>
             <a:pPr lvl="2"/>
             <a:r>
-              <a:rPr lang="en-US" smtClean="0"/>
+              <a:rPr lang="en-US"/>
               <a:t>Third level</a:t>
             </a:r>
           </a:p>
           <a:p>
             <a:pPr lvl="3"/>
             <a:r>
-              <a:rPr lang="en-US" smtClean="0"/>
+              <a:rPr lang="en-US"/>
               <a:t>Fourth level</a:t>
             </a:r>
           </a:p>
           <a:p>
             <a:pPr lvl="4"/>
             <a:r>
-              <a:rPr lang="en-US" smtClean="0"/>
+              <a:rPr lang="en-US"/>
               <a:t>Fifth level</a:t>
             </a:r>
-            <a:endParaRPr lang="en-US"/>
           </a:p>
         </p:txBody>
       </p:sp>
@@ -1353,7 +1448,7 @@
           <a:p>
             <a:fld id="{5BCAD085-E8A6-8845-BD4E-CB4CCA059FC4}" type="datetimeFigureOut">
               <a:rPr lang="en-US" smtClean="0"/>
-              <a:t>1/27/13</a:t>
+              <a:t>7/25/2026</a:t>
             </a:fld>
             <a:endParaRPr lang="en-US"/>
           </a:p>
@@ -1451,10 +1546,9 @@
           </a:lstStyle>
           <a:p>
             <a:r>
-              <a:rPr lang="en-US" smtClean="0"/>
+              <a:rPr lang="en-US"/>
               <a:t>Click to edit Master title style</a:t>
             </a:r>
-            <a:endParaRPr lang="en-US"/>
           </a:p>
         </p:txBody>
       </p:sp>
@@ -1517,7 +1611,7 @@
           <a:p>
             <a:pPr lvl="0"/>
             <a:r>
-              <a:rPr lang="en-US" smtClean="0"/>
+              <a:rPr lang="en-US"/>
               <a:t>Click to edit Master text styles</a:t>
             </a:r>
           </a:p>
@@ -1573,38 +1667,37 @@
           <a:p>
             <a:pPr lvl="0"/>
             <a:r>
-              <a:rPr lang="en-US" smtClean="0"/>
+              <a:rPr lang="en-US"/>
               <a:t>Click to edit Master text styles</a:t>
             </a:r>
           </a:p>
           <a:p>
             <a:pPr lvl="1"/>
             <a:r>
-              <a:rPr lang="en-US" smtClean="0"/>
+              <a:rPr lang="en-US"/>
               <a:t>Second level</a:t>
             </a:r>
           </a:p>
           <a:p>
             <a:pPr lvl="2"/>
             <a:r>
-              <a:rPr lang="en-US" smtClean="0"/>
+              <a:rPr lang="en-US"/>
               <a:t>Third level</a:t>
             </a:r>
           </a:p>
           <a:p>
             <a:pPr lvl="3"/>
             <a:r>
-              <a:rPr lang="en-US" smtClean="0"/>
+              <a:rPr lang="en-US"/>
               <a:t>Fourth level</a:t>
             </a:r>
           </a:p>
           <a:p>
             <a:pPr lvl="4"/>
             <a:r>
-              <a:rPr lang="en-US" smtClean="0"/>
+              <a:rPr lang="en-US"/>
               <a:t>Fifth level</a:t>
             </a:r>
-            <a:endParaRPr lang="en-US"/>
           </a:p>
         </p:txBody>
       </p:sp>
@@ -1667,7 +1760,7 @@
           <a:p>
             <a:pPr lvl="0"/>
             <a:r>
-              <a:rPr lang="en-US" smtClean="0"/>
+              <a:rPr lang="en-US"/>
               <a:t>Click to edit Master text styles</a:t>
             </a:r>
           </a:p>
@@ -1723,38 +1816,37 @@
           <a:p>
             <a:pPr lvl="0"/>
             <a:r>
-              <a:rPr lang="en-US" smtClean="0"/>
+              <a:rPr lang="en-US"/>
               <a:t>Click to edit Master text styles</a:t>
             </a:r>
           </a:p>
           <a:p>
             <a:pPr lvl="1"/>
             <a:r>
-              <a:rPr lang="en-US" smtClean="0"/>
+              <a:rPr lang="en-US"/>
               <a:t>Second level</a:t>
             </a:r>
           </a:p>
           <a:p>
             <a:pPr lvl="2"/>
             <a:r>
-              <a:rPr lang="en-US" smtClean="0"/>
+              <a:rPr lang="en-US"/>
               <a:t>Third level</a:t>
             </a:r>
           </a:p>
           <a:p>
             <a:pPr lvl="3"/>
             <a:r>
-              <a:rPr lang="en-US" smtClean="0"/>
+              <a:rPr lang="en-US"/>
               <a:t>Fourth level</a:t>
             </a:r>
           </a:p>
           <a:p>
             <a:pPr lvl="4"/>
             <a:r>
-              <a:rPr lang="en-US" smtClean="0"/>
+              <a:rPr lang="en-US"/>
               <a:t>Fifth level</a:t>
             </a:r>
-            <a:endParaRPr lang="en-US"/>
           </a:p>
         </p:txBody>
       </p:sp>
@@ -1775,7 +1867,7 @@
           <a:p>
             <a:fld id="{5BCAD085-E8A6-8845-BD4E-CB4CCA059FC4}" type="datetimeFigureOut">
               <a:rPr lang="en-US" smtClean="0"/>
-              <a:t>1/27/13</a:t>
+              <a:t>7/25/2026</a:t>
             </a:fld>
             <a:endParaRPr lang="en-US"/>
           </a:p>
@@ -1869,10 +1961,9 @@
           <a:lstStyle/>
           <a:p>
             <a:r>
-              <a:rPr lang="en-US" smtClean="0"/>
+              <a:rPr lang="en-US"/>
               <a:t>Click to edit Master title style</a:t>
             </a:r>
-            <a:endParaRPr lang="en-US"/>
           </a:p>
         </p:txBody>
       </p:sp>
@@ -1893,7 +1984,7 @@
           <a:p>
             <a:fld id="{5BCAD085-E8A6-8845-BD4E-CB4CCA059FC4}" type="datetimeFigureOut">
               <a:rPr lang="en-US" smtClean="0"/>
-              <a:t>1/27/13</a:t>
+              <a:t>7/25/2026</a:t>
             </a:fld>
             <a:endParaRPr lang="en-US"/>
           </a:p>
@@ -1988,7 +2079,7 @@
           <a:p>
             <a:fld id="{5BCAD085-E8A6-8845-BD4E-CB4CCA059FC4}" type="datetimeFigureOut">
               <a:rPr lang="en-US" smtClean="0"/>
-              <a:t>1/27/13</a:t>
+              <a:t>7/25/2026</a:t>
             </a:fld>
             <a:endParaRPr lang="en-US"/>
           </a:p>
@@ -2091,10 +2182,9 @@
           </a:lstStyle>
           <a:p>
             <a:r>
-              <a:rPr lang="en-US" smtClean="0"/>
+              <a:rPr lang="en-US"/>
               <a:t>Click to edit Master title style</a:t>
             </a:r>
-            <a:endParaRPr lang="en-US"/>
           </a:p>
         </p:txBody>
       </p:sp>
@@ -2148,38 +2238,37 @@
           <a:p>
             <a:pPr lvl="0"/>
             <a:r>
-              <a:rPr lang="en-US" smtClean="0"/>
+              <a:rPr lang="en-US"/>
               <a:t>Click to edit Master text styles</a:t>
             </a:r>
           </a:p>
           <a:p>
             <a:pPr lvl="1"/>
             <a:r>
-              <a:rPr lang="en-US" smtClean="0"/>
+              <a:rPr lang="en-US"/>
               <a:t>Second level</a:t>
             </a:r>
           </a:p>
           <a:p>
             <a:pPr lvl="2"/>
             <a:r>
-              <a:rPr lang="en-US" smtClean="0"/>
+              <a:rPr lang="en-US"/>
               <a:t>Third level</a:t>
             </a:r>
           </a:p>
           <a:p>
             <a:pPr lvl="3"/>
             <a:r>
-              <a:rPr lang="en-US" smtClean="0"/>
+              <a:rPr lang="en-US"/>
               <a:t>Fourth level</a:t>
             </a:r>
           </a:p>
           <a:p>
             <a:pPr lvl="4"/>
             <a:r>
-              <a:rPr lang="en-US" smtClean="0"/>
+              <a:rPr lang="en-US"/>
               <a:t>Fifth level</a:t>
             </a:r>
-            <a:endParaRPr lang="en-US"/>
           </a:p>
         </p:txBody>
       </p:sp>
@@ -2242,7 +2331,7 @@
           <a:p>
             <a:pPr lvl="0"/>
             <a:r>
-              <a:rPr lang="en-US" smtClean="0"/>
+              <a:rPr lang="en-US"/>
               <a:t>Click to edit Master text styles</a:t>
             </a:r>
           </a:p>
@@ -2265,7 +2354,7 @@
           <a:p>
             <a:fld id="{5BCAD085-E8A6-8845-BD4E-CB4CCA059FC4}" type="datetimeFigureOut">
               <a:rPr lang="en-US" smtClean="0"/>
-              <a:t>1/27/13</a:t>
+              <a:t>7/25/2026</a:t>
             </a:fld>
             <a:endParaRPr lang="en-US"/>
           </a:p>
@@ -2368,10 +2457,9 @@
           </a:lstStyle>
           <a:p>
             <a:r>
-              <a:rPr lang="en-US" smtClean="0"/>
+              <a:rPr lang="en-US"/>
               <a:t>Click to edit Master title style</a:t>
             </a:r>
-            <a:endParaRPr lang="en-US"/>
           </a:p>
         </p:txBody>
       </p:sp>
@@ -2495,7 +2583,7 @@
           <a:p>
             <a:pPr lvl="0"/>
             <a:r>
-              <a:rPr lang="en-US" smtClean="0"/>
+              <a:rPr lang="en-US"/>
               <a:t>Click to edit Master text styles</a:t>
             </a:r>
           </a:p>
@@ -2518,7 +2606,7 @@
           <a:p>
             <a:fld id="{5BCAD085-E8A6-8845-BD4E-CB4CCA059FC4}" type="datetimeFigureOut">
               <a:rPr lang="en-US" smtClean="0"/>
-              <a:t>1/27/13</a:t>
+              <a:t>7/25/2026</a:t>
             </a:fld>
             <a:endParaRPr lang="en-US"/>
           </a:p>
@@ -2627,10 +2715,9 @@
           <a:lstStyle/>
           <a:p>
             <a:r>
-              <a:rPr lang="en-US" smtClean="0"/>
+              <a:rPr lang="en-US"/>
               <a:t>Click to edit Master title style</a:t>
             </a:r>
-            <a:endParaRPr lang="en-US"/>
           </a:p>
         </p:txBody>
       </p:sp>
@@ -2661,38 +2748,37 @@
           <a:p>
             <a:pPr lvl="0"/>
             <a:r>
-              <a:rPr lang="en-US" smtClean="0"/>
+              <a:rPr lang="en-US"/>
               <a:t>Click to edit Master text styles</a:t>
             </a:r>
           </a:p>
           <a:p>
             <a:pPr lvl="1"/>
             <a:r>
-              <a:rPr lang="en-US" smtClean="0"/>
+              <a:rPr lang="en-US"/>
               <a:t>Second level</a:t>
             </a:r>
           </a:p>
           <a:p>
             <a:pPr lvl="2"/>
             <a:r>
-              <a:rPr lang="en-US" smtClean="0"/>
+              <a:rPr lang="en-US"/>
               <a:t>Third level</a:t>
             </a:r>
           </a:p>
           <a:p>
             <a:pPr lvl="3"/>
             <a:r>
-              <a:rPr lang="en-US" smtClean="0"/>
+              <a:rPr lang="en-US"/>
               <a:t>Fourth level</a:t>
             </a:r>
           </a:p>
           <a:p>
             <a:pPr lvl="4"/>
             <a:r>
-              <a:rPr lang="en-US" smtClean="0"/>
+              <a:rPr lang="en-US"/>
               <a:t>Fifth level</a:t>
             </a:r>
-            <a:endParaRPr lang="en-US"/>
           </a:p>
         </p:txBody>
       </p:sp>
@@ -2731,7 +2817,7 @@
           <a:p>
             <a:fld id="{5BCAD085-E8A6-8845-BD4E-CB4CCA059FC4}" type="datetimeFigureOut">
               <a:rPr lang="en-US" smtClean="0"/>
-              <a:t>1/27/13</a:t>
+              <a:t>7/25/2026</a:t>
             </a:fld>
             <a:endParaRPr lang="en-US"/>
           </a:p>
@@ -3090,7 +3176,7 @@
 </file>
 
 <file path=ppt/slides/slide1.xml><?xml version="1.0" encoding="utf-8"?>
-<p:sld xmlns:a="http://schemas.openxmlformats.org/drawingml/2006/main" xmlns:p="http://schemas.openxmlformats.org/presentationml/2006/main" xmlns:r="http://schemas.openxmlformats.org/officeDocument/2006/relationships">
+<p:sld xmlns:a="http://schemas.openxmlformats.org/drawingml/2006/main" xmlns:r="http://schemas.openxmlformats.org/officeDocument/2006/relationships" xmlns:p="http://schemas.openxmlformats.org/presentationml/2006/main">
   <p:cSld>
     <p:bg>
       <p:bgPr>
@@ -3106,7 +3192,14 @@
         <p:cNvGrpSpPr/>
         <p:nvPr/>
       </p:nvGrpSpPr>
-      <p:grpSpPr/>
+      <p:grpSpPr>
+        <a:xfrm>
+          <a:off x="0" y="0"/>
+          <a:ext cx="0" cy="0"/>
+          <a:chOff x="0" y="0"/>
+          <a:chExt cx="0" cy="0"/>
+        </a:xfrm>
+      </p:grpSpPr>
       <p:sp>
         <p:nvSpPr>
           <p:cNvPr id="2" name="Rectangle 1"/>
@@ -3149,6 +3242,7 @@
           <a:lstStyle/>
           <a:p>
             <a:pPr algn="ctr"/>
+            <a:endParaRPr/>
           </a:p>
         </p:txBody>
       </p:sp>
@@ -3161,7 +3255,7 @@
         <p:spPr>
           <a:xfrm>
             <a:off x="914400" y="1097280"/>
-            <a:ext cx="10332720" cy="1645920"/>
+            <a:ext cx="10332720" cy="923330"/>
           </a:xfrm>
           <a:prstGeom prst="rect">
             <a:avLst/>
@@ -3183,8 +3277,34 @@
               </a:defRPr>
             </a:pPr>
             <a:r>
-              <a:t>Nutritional AI Agent</a:t>
-            </a:r>
+              <a:rPr lang="en-GB" sz="3200" b="1" dirty="0"/>
+              <a:t>PROJECT TITLE  </a:t>
+            </a:r>
+            <a:r>
+              <a:rPr lang="en-GB" sz="3600" b="1" dirty="0"/>
+              <a:t>: </a:t>
+            </a:r>
+            <a:r>
+              <a:rPr sz="3600" dirty="0"/>
+              <a:t>Nutritional </a:t>
+            </a:r>
+            <a:r>
+              <a:rPr sz="3600"/>
+              <a:t>AI Agent</a:t>
+            </a:r>
+            <a:r>
+              <a:rPr lang="en-IN" sz="3600"/>
+              <a:t> </a:t>
+            </a:r>
+            <a:r>
+              <a:rPr lang="en-IN" sz="2000"/>
+              <a:t>(</a:t>
+            </a:r>
+            <a:r>
+              <a:rPr lang="en-IN" sz="2000" dirty="0"/>
+              <a:t>AI Automation)</a:t>
+            </a:r>
+            <a:endParaRPr sz="3600" dirty="0"/>
           </a:p>
           <a:p>
             <a:pPr>
@@ -3196,7 +3316,16 @@
               </a:defRPr>
             </a:pPr>
             <a:r>
-              <a:t>IBM SkillsBuild Project Submission | UN SDG 3 (Good Health and Well-being)</a:t>
+              <a:rPr dirty="0"/>
+              <a:t>IBM </a:t>
+            </a:r>
+            <a:r>
+              <a:rPr dirty="0" err="1"/>
+              <a:t>SkillsBuild</a:t>
+            </a:r>
+            <a:r>
+              <a:rPr dirty="0"/>
+              <a:t> Project Submission | UN SDG 3 (Good Health and Well-being)</a:t>
             </a:r>
           </a:p>
         </p:txBody>
@@ -3209,8 +3338,8 @@
         </p:nvSpPr>
         <p:spPr>
           <a:xfrm>
-            <a:off x="914400" y="2926080"/>
-            <a:ext cx="10332720" cy="3200400"/>
+            <a:off x="914399" y="2497394"/>
+            <a:ext cx="10332721" cy="2308324"/>
           </a:xfrm>
           <a:prstGeom prst="rect">
             <a:avLst/>
@@ -3223,128 +3352,81 @@
           </a:bodyPr>
           <a:lstStyle/>
           <a:p>
-            <a:pPr>
-              <a:spcAft>
-                <a:spcPts val="800"/>
-              </a:spcAft>
-            </a:pPr>
-            <a:r>
-              <a:rPr sz="1600" b="1">
-                <a:solidFill>
-                  <a:srgbClr val="0F172A"/>
-                </a:solidFill>
-                <a:latin typeface="Arial"/>
+            <a:r>
+              <a:rPr lang="en-IN" sz="2400" b="1" dirty="0"/>
+              <a:t>Full Name:</a:t>
+            </a:r>
+            <a:r>
+              <a:rPr lang="en-IN" sz="2400" dirty="0"/>
+              <a:t> Soujanya K Hegde and Mohammed Umar F</a:t>
+            </a:r>
+          </a:p>
+          <a:p>
+            <a:r>
+              <a:rPr lang="en-IN" sz="2400" b="1" dirty="0"/>
+              <a:t>Registered Mail ID:</a:t>
+            </a:r>
+            <a:r>
+              <a:rPr lang="en-IN" sz="2400" dirty="0"/>
+              <a:t> </a:t>
+            </a:r>
+            <a:r>
+              <a:rPr lang="en-IN" sz="2400" dirty="0">
+                <a:hlinkClick r:id="rId2"/>
               </a:rPr>
-              <a:t>Full Name: </a:t>
-            </a:r>
-            <a:r>
-              <a:rPr sz="1600">
-                <a:solidFill>
-                  <a:srgbClr val="475569"/>
-                </a:solidFill>
-                <a:latin typeface="Arial"/>
+              <a:t>shegde092@gmail.com</a:t>
+            </a:r>
+            <a:r>
+              <a:rPr lang="en-IN" sz="2400" dirty="0"/>
+              <a:t> and mdumr4@gamil.com</a:t>
+            </a:r>
+          </a:p>
+          <a:p>
+            <a:r>
+              <a:rPr lang="en-IN" sz="2400" b="1" dirty="0"/>
+              <a:t>College Name:</a:t>
+            </a:r>
+            <a:r>
+              <a:rPr lang="en-IN" sz="2400" dirty="0"/>
+              <a:t> Cambridge Institute of Technology</a:t>
+            </a:r>
+          </a:p>
+          <a:p>
+            <a:r>
+              <a:rPr lang="en-IN" sz="2400" b="1" dirty="0"/>
+              <a:t>Mob No.:</a:t>
+            </a:r>
+            <a:r>
+              <a:rPr lang="en-IN" sz="2400" dirty="0"/>
+              <a:t> 9148165856 and 8892574137</a:t>
+            </a:r>
+          </a:p>
+          <a:p>
+            <a:r>
+              <a:rPr lang="en-IN" sz="2400" b="1" dirty="0"/>
+              <a:t>IBM </a:t>
+            </a:r>
+            <a:r>
+              <a:rPr lang="en-IN" sz="2400" b="1" dirty="0" err="1"/>
+              <a:t>SkillsBuild</a:t>
+            </a:r>
+            <a:r>
+              <a:rPr lang="en-IN" sz="2400" b="1" dirty="0"/>
+              <a:t> Platform Mail ID:</a:t>
+            </a:r>
+            <a:r>
+              <a:rPr lang="en-IN" sz="2400" dirty="0"/>
+              <a:t> </a:t>
+            </a:r>
+            <a:r>
+              <a:rPr lang="en-IN" sz="2400" dirty="0">
+                <a:hlinkClick r:id="rId2"/>
               </a:rPr>
-              <a:t>[Your Full Name Here]</a:t>
-            </a:r>
-          </a:p>
-          <a:p>
-            <a:pPr>
-              <a:spcAft>
-                <a:spcPts val="800"/>
-              </a:spcAft>
-            </a:pPr>
-            <a:r>
-              <a:rPr sz="1600" b="1">
-                <a:solidFill>
-                  <a:srgbClr val="0F172A"/>
-                </a:solidFill>
-                <a:latin typeface="Arial"/>
-              </a:rPr>
-              <a:t>Registered Mail ID: </a:t>
-            </a:r>
-            <a:r>
-              <a:rPr sz="1600">
-                <a:solidFill>
-                  <a:srgbClr val="475569"/>
-                </a:solidFill>
-                <a:latin typeface="Arial"/>
-              </a:rPr>
-              <a:t>[Your Registered Mail ID Here]</a:t>
-            </a:r>
-          </a:p>
-          <a:p>
-            <a:pPr>
-              <a:spcAft>
-                <a:spcPts val="800"/>
-              </a:spcAft>
-            </a:pPr>
-            <a:r>
-              <a:rPr sz="1600" b="1">
-                <a:solidFill>
-                  <a:srgbClr val="0F172A"/>
-                </a:solidFill>
-                <a:latin typeface="Arial"/>
-              </a:rPr>
-              <a:t>College Name: </a:t>
-            </a:r>
-            <a:r>
-              <a:rPr sz="1600">
-                <a:solidFill>
-                  <a:srgbClr val="475569"/>
-                </a:solidFill>
-                <a:latin typeface="Arial"/>
-              </a:rPr>
-              <a:t>[Your College Name Here]</a:t>
-            </a:r>
-          </a:p>
-          <a:p>
-            <a:pPr>
-              <a:spcAft>
-                <a:spcPts val="800"/>
-              </a:spcAft>
-            </a:pPr>
-            <a:r>
-              <a:rPr sz="1600" b="1">
-                <a:solidFill>
-                  <a:srgbClr val="0F172A"/>
-                </a:solidFill>
-                <a:latin typeface="Arial"/>
-              </a:rPr>
-              <a:t>Mob No.: </a:t>
-            </a:r>
-            <a:r>
-              <a:rPr sz="1600">
-                <a:solidFill>
-                  <a:srgbClr val="475569"/>
-                </a:solidFill>
-                <a:latin typeface="Arial"/>
-              </a:rPr>
-              <a:t>[Your Mobile Number Here]</a:t>
-            </a:r>
-          </a:p>
-          <a:p>
-            <a:pPr>
-              <a:spcAft>
-                <a:spcPts val="800"/>
-              </a:spcAft>
-            </a:pPr>
-            <a:r>
-              <a:rPr sz="1600" b="1">
-                <a:solidFill>
-                  <a:srgbClr val="0F172A"/>
-                </a:solidFill>
-                <a:latin typeface="Arial"/>
-              </a:rPr>
-              <a:t>IBM SkillsBuild Platform Mail ID: </a:t>
-            </a:r>
-            <a:r>
-              <a:rPr sz="1600">
-                <a:solidFill>
-                  <a:srgbClr val="475569"/>
-                </a:solidFill>
-                <a:latin typeface="Arial"/>
-              </a:rPr>
-              <a:t>[Your SkillsBuild Platform Mail ID Here]</a:t>
+              <a:t>shegde092@gmail.com</a:t>
+            </a:r>
+            <a:r>
+              <a:rPr lang="en-IN" sz="2400" dirty="0"/>
+              <a:t> and mdumr4@gamil.com</a:t>
             </a:r>
           </a:p>
         </p:txBody>
@@ -3358,7 +3440,7 @@
 </file>
 
 <file path=ppt/slides/slide10.xml><?xml version="1.0" encoding="utf-8"?>
-<p:sld xmlns:a="http://schemas.openxmlformats.org/drawingml/2006/main" xmlns:p="http://schemas.openxmlformats.org/presentationml/2006/main" xmlns:r="http://schemas.openxmlformats.org/officeDocument/2006/relationships">
+<p:sld xmlns:a="http://schemas.openxmlformats.org/drawingml/2006/main" xmlns:r="http://schemas.openxmlformats.org/officeDocument/2006/relationships" xmlns:p="http://schemas.openxmlformats.org/presentationml/2006/main">
   <p:cSld>
     <p:bg>
       <p:bgPr>
@@ -3374,7 +3456,14 @@
         <p:cNvGrpSpPr/>
         <p:nvPr/>
       </p:nvGrpSpPr>
-      <p:grpSpPr/>
+      <p:grpSpPr>
+        <a:xfrm>
+          <a:off x="0" y="0"/>
+          <a:ext cx="0" cy="0"/>
+          <a:chOff x="0" y="0"/>
+          <a:chExt cx="0" cy="0"/>
+        </a:xfrm>
+      </p:grpSpPr>
       <p:sp>
         <p:nvSpPr>
           <p:cNvPr id="2" name="Rectangle 1"/>
@@ -3417,6 +3506,7 @@
           <a:lstStyle/>
           <a:p>
             <a:pPr algn="ctr"/>
+            <a:endParaRPr/>
           </a:p>
         </p:txBody>
       </p:sp>
@@ -3494,7 +3584,7 @@
           </a:fontRef>
         </p:style>
         <p:txBody>
-          <a:bodyPr rtlCol="0" anchor="ctr" wrap="square"/>
+          <a:bodyPr wrap="square" rtlCol="0" anchor="ctr"/>
           <a:lstStyle/>
           <a:p>
             <a:pPr algn="ctr">
@@ -3511,20 +3601,72 @@
           </a:p>
           <a:p>
             <a:br/>
-            <a:pPr algn="ctr">
-              <a:defRPr sz="1400">
-                <a:solidFill>
-                  <a:srgbClr val="475569"/>
-                </a:solidFill>
-                <a:latin typeface="Arial"/>
-              </a:defRPr>
-            </a:pPr>
             <a:r>
               <a:t>(Take a screenshot of the running Streamlit Nutritional AI Agent UI and paste it here.)</a:t>
             </a:r>
           </a:p>
         </p:txBody>
       </p:sp>
+      <p:pic>
+        <p:nvPicPr>
+          <p:cNvPr id="6" name="Picture 5">
+            <a:extLst>
+              <a:ext uri="{FF2B5EF4-FFF2-40B4-BE49-F238E27FC236}">
+                <a16:creationId xmlns:a16="http://schemas.microsoft.com/office/drawing/2014/main" id="{4CB529A3-191C-DA00-B61E-9802DC0E744F}"/>
+              </a:ext>
+            </a:extLst>
+          </p:cNvPr>
+          <p:cNvPicPr>
+            <a:picLocks noChangeAspect="1"/>
+          </p:cNvPicPr>
+          <p:nvPr/>
+        </p:nvPicPr>
+        <p:blipFill>
+          <a:blip r:embed="rId2"/>
+          <a:stretch>
+            <a:fillRect/>
+          </a:stretch>
+        </p:blipFill>
+        <p:spPr>
+          <a:xfrm>
+            <a:off x="6351638" y="1005840"/>
+            <a:ext cx="5840362" cy="5852160"/>
+          </a:xfrm>
+          <a:prstGeom prst="rect">
+            <a:avLst/>
+          </a:prstGeom>
+        </p:spPr>
+      </p:pic>
+      <p:pic>
+        <p:nvPicPr>
+          <p:cNvPr id="10" name="Picture 9">
+            <a:extLst>
+              <a:ext uri="{FF2B5EF4-FFF2-40B4-BE49-F238E27FC236}">
+                <a16:creationId xmlns:a16="http://schemas.microsoft.com/office/drawing/2014/main" id="{6E660052-1500-34F0-7040-BDBC74E8F69C}"/>
+              </a:ext>
+            </a:extLst>
+          </p:cNvPr>
+          <p:cNvPicPr>
+            <a:picLocks noChangeAspect="1"/>
+          </p:cNvPicPr>
+          <p:nvPr/>
+        </p:nvPicPr>
+        <p:blipFill>
+          <a:blip r:embed="rId3"/>
+          <a:stretch>
+            <a:fillRect/>
+          </a:stretch>
+        </p:blipFill>
+        <p:spPr>
+          <a:xfrm>
+            <a:off x="0" y="1005840"/>
+            <a:ext cx="6351638" cy="5852160"/>
+          </a:xfrm>
+          <a:prstGeom prst="rect">
+            <a:avLst/>
+          </a:prstGeom>
+        </p:spPr>
+      </p:pic>
     </p:spTree>
   </p:cSld>
   <p:clrMapOvr>
@@ -3534,7 +3676,7 @@
 </file>
 
 <file path=ppt/slides/slide11.xml><?xml version="1.0" encoding="utf-8"?>
-<p:sld xmlns:a="http://schemas.openxmlformats.org/drawingml/2006/main" xmlns:p="http://schemas.openxmlformats.org/presentationml/2006/main" xmlns:r="http://schemas.openxmlformats.org/officeDocument/2006/relationships">
+<p:sld xmlns:a="http://schemas.openxmlformats.org/drawingml/2006/main" xmlns:r="http://schemas.openxmlformats.org/officeDocument/2006/relationships" xmlns:p="http://schemas.openxmlformats.org/presentationml/2006/main">
   <p:cSld>
     <p:bg>
       <p:bgPr>
@@ -3550,7 +3692,14 @@
         <p:cNvGrpSpPr/>
         <p:nvPr/>
       </p:nvGrpSpPr>
-      <p:grpSpPr/>
+      <p:grpSpPr>
+        <a:xfrm>
+          <a:off x="0" y="0"/>
+          <a:ext cx="0" cy="0"/>
+          <a:chOff x="0" y="0"/>
+          <a:chExt cx="0" cy="0"/>
+        </a:xfrm>
+      </p:grpSpPr>
       <p:sp>
         <p:nvSpPr>
           <p:cNvPr id="2" name="Rectangle 1"/>
@@ -3593,6 +3742,7 @@
           <a:lstStyle/>
           <a:p>
             <a:pPr algn="ctr"/>
+            <a:endParaRPr/>
           </a:p>
         </p:txBody>
       </p:sp>
@@ -3780,7 +3930,7 @@
 </file>
 
 <file path=ppt/slides/slide12.xml><?xml version="1.0" encoding="utf-8"?>
-<p:sld xmlns:a="http://schemas.openxmlformats.org/drawingml/2006/main" xmlns:p="http://schemas.openxmlformats.org/presentationml/2006/main" xmlns:r="http://schemas.openxmlformats.org/officeDocument/2006/relationships">
+<p:sld xmlns:a="http://schemas.openxmlformats.org/drawingml/2006/main" xmlns:r="http://schemas.openxmlformats.org/officeDocument/2006/relationships" xmlns:p="http://schemas.openxmlformats.org/presentationml/2006/main">
   <p:cSld>
     <p:bg>
       <p:bgPr>
@@ -3796,7 +3946,14 @@
         <p:cNvGrpSpPr/>
         <p:nvPr/>
       </p:nvGrpSpPr>
-      <p:grpSpPr/>
+      <p:grpSpPr>
+        <a:xfrm>
+          <a:off x="0" y="0"/>
+          <a:ext cx="0" cy="0"/>
+          <a:chOff x="0" y="0"/>
+          <a:chExt cx="0" cy="0"/>
+        </a:xfrm>
+      </p:grpSpPr>
       <p:sp>
         <p:nvSpPr>
           <p:cNvPr id="2" name="Rectangle 1"/>
@@ -3839,6 +3996,7 @@
           <a:lstStyle/>
           <a:p>
             <a:pPr algn="ctr"/>
+            <a:endParaRPr/>
           </a:p>
         </p:txBody>
       </p:sp>
@@ -4044,7 +4202,7 @@
 </file>
 
 <file path=ppt/slides/slide2.xml><?xml version="1.0" encoding="utf-8"?>
-<p:sld xmlns:a="http://schemas.openxmlformats.org/drawingml/2006/main" xmlns:p="http://schemas.openxmlformats.org/presentationml/2006/main" xmlns:r="http://schemas.openxmlformats.org/officeDocument/2006/relationships">
+<p:sld xmlns:a="http://schemas.openxmlformats.org/drawingml/2006/main" xmlns:r="http://schemas.openxmlformats.org/officeDocument/2006/relationships" xmlns:p="http://schemas.openxmlformats.org/presentationml/2006/main">
   <p:cSld>
     <p:bg>
       <p:bgPr>
@@ -4060,7 +4218,14 @@
         <p:cNvGrpSpPr/>
         <p:nvPr/>
       </p:nvGrpSpPr>
-      <p:grpSpPr/>
+      <p:grpSpPr>
+        <a:xfrm>
+          <a:off x="0" y="0"/>
+          <a:ext cx="0" cy="0"/>
+          <a:chOff x="0" y="0"/>
+          <a:chExt cx="0" cy="0"/>
+        </a:xfrm>
+      </p:grpSpPr>
       <p:sp>
         <p:nvSpPr>
           <p:cNvPr id="2" name="Rectangle 1"/>
@@ -4103,6 +4268,7 @@
           <a:lstStyle/>
           <a:p>
             <a:pPr algn="ctr"/>
+            <a:endParaRPr/>
           </a:p>
         </p:txBody>
       </p:sp>
@@ -4150,7 +4316,7 @@
         </p:nvSpPr>
         <p:spPr>
           <a:xfrm>
-            <a:off x="731520" y="1371600"/>
+            <a:off x="992778" y="1665514"/>
             <a:ext cx="10728655" cy="4754880"/>
           </a:xfrm>
           <a:prstGeom prst="rect">
@@ -4179,6 +4345,7 @@
               </a:defRPr>
             </a:pPr>
             <a:r>
+              <a:rPr dirty="0"/>
               <a:t>Nutrition &amp; Global Well-being (SDG 3):</a:t>
             </a:r>
           </a:p>
@@ -4195,6 +4362,7 @@
               </a:defRPr>
             </a:pPr>
             <a:r>
+              <a:rPr dirty="0"/>
               <a:t>Good nutrition is the cornerstone of health, vital for immune support and preventing chronic metabolic diseases.</a:t>
             </a:r>
           </a:p>
@@ -4211,6 +4379,7 @@
               </a:defRPr>
             </a:pPr>
             <a:r>
+              <a:rPr dirty="0"/>
               <a:t>Poor dietary choices lead to severe long-term health complications globally, impacting quality of life.</a:t>
             </a:r>
           </a:p>
@@ -4230,6 +4399,7 @@
               </a:defRPr>
             </a:pPr>
             <a:r>
+              <a:rPr dirty="0"/>
               <a:t>Current Challenges in Dietary Tracking:</a:t>
             </a:r>
           </a:p>
@@ -4246,6 +4416,7 @@
               </a:defRPr>
             </a:pPr>
             <a:r>
+              <a:rPr dirty="0"/>
               <a:t>Traditional meal logging relies on manual entry, leading to high friction, under-reporting, and mental fatigue.</a:t>
             </a:r>
           </a:p>
@@ -4262,6 +4433,7 @@
               </a:defRPr>
             </a:pPr>
             <a:r>
+              <a:rPr dirty="0"/>
               <a:t>Static apps track history but fail to offer proactive, customized, and context-aware suggestions.</a:t>
             </a:r>
           </a:p>
@@ -4281,6 +4453,7 @@
               </a:defRPr>
             </a:pPr>
             <a:r>
+              <a:rPr dirty="0"/>
               <a:t>Potential Solution via Agentic AI:</a:t>
             </a:r>
           </a:p>
@@ -4297,6 +4470,7 @@
               </a:defRPr>
             </a:pPr>
             <a:r>
+              <a:rPr dirty="0"/>
               <a:t>Transition from passive logs to active agents that handle metric extraction, recipe design, and scheduling autonomously.</a:t>
             </a:r>
           </a:p>
@@ -4311,7 +4485,7 @@
 </file>
 
 <file path=ppt/slides/slide3.xml><?xml version="1.0" encoding="utf-8"?>
-<p:sld xmlns:a="http://schemas.openxmlformats.org/drawingml/2006/main" xmlns:p="http://schemas.openxmlformats.org/presentationml/2006/main" xmlns:r="http://schemas.openxmlformats.org/officeDocument/2006/relationships">
+<p:sld xmlns:a="http://schemas.openxmlformats.org/drawingml/2006/main" xmlns:r="http://schemas.openxmlformats.org/officeDocument/2006/relationships" xmlns:p="http://schemas.openxmlformats.org/presentationml/2006/main">
   <p:cSld>
     <p:bg>
       <p:bgPr>
@@ -4327,7 +4501,14 @@
         <p:cNvGrpSpPr/>
         <p:nvPr/>
       </p:nvGrpSpPr>
-      <p:grpSpPr/>
+      <p:grpSpPr>
+        <a:xfrm>
+          <a:off x="0" y="0"/>
+          <a:ext cx="0" cy="0"/>
+          <a:chOff x="0" y="0"/>
+          <a:chExt cx="0" cy="0"/>
+        </a:xfrm>
+      </p:grpSpPr>
       <p:sp>
         <p:nvSpPr>
           <p:cNvPr id="2" name="Rectangle 1"/>
@@ -4370,6 +4551,7 @@
           <a:lstStyle/>
           <a:p>
             <a:pPr algn="ctr"/>
+            <a:endParaRPr/>
           </a:p>
         </p:txBody>
       </p:sp>
@@ -4559,7 +4741,7 @@
 </file>
 
 <file path=ppt/slides/slide4.xml><?xml version="1.0" encoding="utf-8"?>
-<p:sld xmlns:a="http://schemas.openxmlformats.org/drawingml/2006/main" xmlns:p="http://schemas.openxmlformats.org/presentationml/2006/main" xmlns:r="http://schemas.openxmlformats.org/officeDocument/2006/relationships">
+<p:sld xmlns:a="http://schemas.openxmlformats.org/drawingml/2006/main" xmlns:r="http://schemas.openxmlformats.org/officeDocument/2006/relationships" xmlns:p="http://schemas.openxmlformats.org/presentationml/2006/main">
   <p:cSld>
     <p:bg>
       <p:bgPr>
@@ -4575,7 +4757,14 @@
         <p:cNvGrpSpPr/>
         <p:nvPr/>
       </p:nvGrpSpPr>
-      <p:grpSpPr/>
+      <p:grpSpPr>
+        <a:xfrm>
+          <a:off x="0" y="0"/>
+          <a:ext cx="0" cy="0"/>
+          <a:chOff x="0" y="0"/>
+          <a:chExt cx="0" cy="0"/>
+        </a:xfrm>
+      </p:grpSpPr>
       <p:sp>
         <p:nvSpPr>
           <p:cNvPr id="2" name="Rectangle 1"/>
@@ -4618,6 +4807,7 @@
           <a:lstStyle/>
           <a:p>
             <a:pPr algn="ctr"/>
+            <a:endParaRPr/>
           </a:p>
         </p:txBody>
       </p:sp>
@@ -4807,7 +4997,7 @@
 </file>
 
 <file path=ppt/slides/slide5.xml><?xml version="1.0" encoding="utf-8"?>
-<p:sld xmlns:a="http://schemas.openxmlformats.org/drawingml/2006/main" xmlns:p="http://schemas.openxmlformats.org/presentationml/2006/main" xmlns:r="http://schemas.openxmlformats.org/officeDocument/2006/relationships">
+<p:sld xmlns:a="http://schemas.openxmlformats.org/drawingml/2006/main" xmlns:r="http://schemas.openxmlformats.org/officeDocument/2006/relationships" xmlns:p="http://schemas.openxmlformats.org/presentationml/2006/main">
   <p:cSld>
     <p:bg>
       <p:bgPr>
@@ -4823,7 +5013,14 @@
         <p:cNvGrpSpPr/>
         <p:nvPr/>
       </p:nvGrpSpPr>
-      <p:grpSpPr/>
+      <p:grpSpPr>
+        <a:xfrm>
+          <a:off x="0" y="0"/>
+          <a:ext cx="0" cy="0"/>
+          <a:chOff x="0" y="0"/>
+          <a:chExt cx="0" cy="0"/>
+        </a:xfrm>
+      </p:grpSpPr>
       <p:sp>
         <p:nvSpPr>
           <p:cNvPr id="2" name="Rectangle 1"/>
@@ -4866,6 +5063,7 @@
           <a:lstStyle/>
           <a:p>
             <a:pPr algn="ctr"/>
+            <a:endParaRPr/>
           </a:p>
         </p:txBody>
       </p:sp>
@@ -5055,7 +5253,7 @@
 </file>
 
 <file path=ppt/slides/slide6.xml><?xml version="1.0" encoding="utf-8"?>
-<p:sld xmlns:a="http://schemas.openxmlformats.org/drawingml/2006/main" xmlns:p="http://schemas.openxmlformats.org/presentationml/2006/main" xmlns:r="http://schemas.openxmlformats.org/officeDocument/2006/relationships">
+<p:sld xmlns:a="http://schemas.openxmlformats.org/drawingml/2006/main" xmlns:r="http://schemas.openxmlformats.org/officeDocument/2006/relationships" xmlns:p="http://schemas.openxmlformats.org/presentationml/2006/main">
   <p:cSld>
     <p:bg>
       <p:bgPr>
@@ -5071,7 +5269,14 @@
         <p:cNvGrpSpPr/>
         <p:nvPr/>
       </p:nvGrpSpPr>
-      <p:grpSpPr/>
+      <p:grpSpPr>
+        <a:xfrm>
+          <a:off x="0" y="0"/>
+          <a:ext cx="0" cy="0"/>
+          <a:chOff x="0" y="0"/>
+          <a:chExt cx="0" cy="0"/>
+        </a:xfrm>
+      </p:grpSpPr>
       <p:sp>
         <p:nvSpPr>
           <p:cNvPr id="2" name="Rectangle 1"/>
@@ -5114,6 +5319,7 @@
           <a:lstStyle/>
           <a:p>
             <a:pPr algn="ctr"/>
+            <a:endParaRPr/>
           </a:p>
         </p:txBody>
       </p:sp>
@@ -5303,7 +5509,7 @@
 </file>
 
 <file path=ppt/slides/slide7.xml><?xml version="1.0" encoding="utf-8"?>
-<p:sld xmlns:a="http://schemas.openxmlformats.org/drawingml/2006/main" xmlns:p="http://schemas.openxmlformats.org/presentationml/2006/main" xmlns:r="http://schemas.openxmlformats.org/officeDocument/2006/relationships">
+<p:sld xmlns:a="http://schemas.openxmlformats.org/drawingml/2006/main" xmlns:r="http://schemas.openxmlformats.org/officeDocument/2006/relationships" xmlns:p="http://schemas.openxmlformats.org/presentationml/2006/main">
   <p:cSld>
     <p:bg>
       <p:bgPr>
@@ -5319,7 +5525,14 @@
         <p:cNvGrpSpPr/>
         <p:nvPr/>
       </p:nvGrpSpPr>
-      <p:grpSpPr/>
+      <p:grpSpPr>
+        <a:xfrm>
+          <a:off x="0" y="0"/>
+          <a:ext cx="0" cy="0"/>
+          <a:chOff x="0" y="0"/>
+          <a:chExt cx="0" cy="0"/>
+        </a:xfrm>
+      </p:grpSpPr>
       <p:sp>
         <p:nvSpPr>
           <p:cNvPr id="2" name="Rectangle 1"/>
@@ -5362,6 +5575,7 @@
           <a:lstStyle/>
           <a:p>
             <a:pPr algn="ctr"/>
+            <a:endParaRPr/>
           </a:p>
         </p:txBody>
       </p:sp>
@@ -5567,7 +5781,7 @@
 </file>
 
 <file path=ppt/slides/slide8.xml><?xml version="1.0" encoding="utf-8"?>
-<p:sld xmlns:a="http://schemas.openxmlformats.org/drawingml/2006/main" xmlns:p="http://schemas.openxmlformats.org/presentationml/2006/main" xmlns:r="http://schemas.openxmlformats.org/officeDocument/2006/relationships">
+<p:sld xmlns:a="http://schemas.openxmlformats.org/drawingml/2006/main" xmlns:r="http://schemas.openxmlformats.org/officeDocument/2006/relationships" xmlns:p="http://schemas.openxmlformats.org/presentationml/2006/main">
   <p:cSld>
     <p:bg>
       <p:bgPr>
@@ -5583,7 +5797,14 @@
         <p:cNvGrpSpPr/>
         <p:nvPr/>
       </p:nvGrpSpPr>
-      <p:grpSpPr/>
+      <p:grpSpPr>
+        <a:xfrm>
+          <a:off x="0" y="0"/>
+          <a:ext cx="0" cy="0"/>
+          <a:chOff x="0" y="0"/>
+          <a:chExt cx="0" cy="0"/>
+        </a:xfrm>
+      </p:grpSpPr>
       <p:sp>
         <p:nvSpPr>
           <p:cNvPr id="2" name="Rectangle 1"/>
@@ -5626,6 +5847,7 @@
           <a:lstStyle/>
           <a:p>
             <a:pPr algn="ctr"/>
+            <a:endParaRPr/>
           </a:p>
         </p:txBody>
       </p:sp>
@@ -5818,7 +6040,7 @@
 </file>
 
 <file path=ppt/slides/slide9.xml><?xml version="1.0" encoding="utf-8"?>
-<p:sld xmlns:a="http://schemas.openxmlformats.org/drawingml/2006/main" xmlns:p="http://schemas.openxmlformats.org/presentationml/2006/main" xmlns:r="http://schemas.openxmlformats.org/officeDocument/2006/relationships">
+<p:sld xmlns:a="http://schemas.openxmlformats.org/drawingml/2006/main" xmlns:r="http://schemas.openxmlformats.org/officeDocument/2006/relationships" xmlns:p="http://schemas.openxmlformats.org/presentationml/2006/main">
   <p:cSld>
     <p:bg>
       <p:bgPr>
@@ -5834,7 +6056,14 @@
         <p:cNvGrpSpPr/>
         <p:nvPr/>
       </p:nvGrpSpPr>
-      <p:grpSpPr/>
+      <p:grpSpPr>
+        <a:xfrm>
+          <a:off x="0" y="0"/>
+          <a:ext cx="0" cy="0"/>
+          <a:chOff x="0" y="0"/>
+          <a:chExt cx="0" cy="0"/>
+        </a:xfrm>
+      </p:grpSpPr>
       <p:sp>
         <p:nvSpPr>
           <p:cNvPr id="2" name="Rectangle 1"/>
@@ -5877,6 +6106,7 @@
           <a:lstStyle/>
           <a:p>
             <a:pPr algn="ctr"/>
+            <a:endParaRPr/>
           </a:p>
         </p:txBody>
       </p:sp>

</xml_diff>

<commit_message>
Add Slide 13 'What to submit' and create Concept Note PDF
</commit_message>
<xml_diff>
--- a/Pitch_Deck.pptx
+++ b/Pitch_Deck.pptx
@@ -5,20 +5,21 @@
     <p:sldMasterId id="2147483648" r:id="rId1"/>
   </p:sldMasterIdLst>
   <p:sldIdLst>
-    <p:sldId id="256" r:id="rId2"/>
-    <p:sldId id="257" r:id="rId3"/>
-    <p:sldId id="258" r:id="rId4"/>
-    <p:sldId id="259" r:id="rId5"/>
-    <p:sldId id="260" r:id="rId6"/>
-    <p:sldId id="261" r:id="rId7"/>
-    <p:sldId id="262" r:id="rId8"/>
-    <p:sldId id="263" r:id="rId9"/>
-    <p:sldId id="264" r:id="rId10"/>
-    <p:sldId id="265" r:id="rId11"/>
-    <p:sldId id="266" r:id="rId12"/>
-    <p:sldId id="267" r:id="rId13"/>
+    <p:sldId id="256" r:id="rId7"/>
+    <p:sldId id="257" r:id="rId8"/>
+    <p:sldId id="258" r:id="rId9"/>
+    <p:sldId id="259" r:id="rId10"/>
+    <p:sldId id="260" r:id="rId11"/>
+    <p:sldId id="261" r:id="rId12"/>
+    <p:sldId id="262" r:id="rId13"/>
+    <p:sldId id="263" r:id="rId14"/>
+    <p:sldId id="264" r:id="rId15"/>
+    <p:sldId id="265" r:id="rId16"/>
+    <p:sldId id="266" r:id="rId17"/>
+    <p:sldId id="267" r:id="rId18"/>
+    <p:sldId id="268" r:id="rId19"/>
   </p:sldIdLst>
-  <p:sldSz cx="12192000" cy="6858000"/>
+  <p:sldSz cx="12191695" cy="6858000" type="screen4x3"/>
   <p:notesSz cx="6858000" cy="9144000"/>
   <p:defaultTextStyle>
     <a:defPPr>
@@ -115,114 +116,7 @@
       </a:defRPr>
     </a:lvl9pPr>
   </p:defaultTextStyle>
-  <p:extLst>
-    <p:ext uri="{EFAFB233-063F-42B5-8137-9DF3F51BA10A}">
-      <p15:sldGuideLst xmlns:p15="http://schemas.microsoft.com/office/powerpoint/2012/main">
-        <p15:guide id="1" orient="horz" pos="2160">
-          <p15:clr>
-            <a:srgbClr val="A4A3A4"/>
-          </p15:clr>
-        </p15:guide>
-        <p15:guide id="2" pos="2880">
-          <p15:clr>
-            <a:srgbClr val="A4A3A4"/>
-          </p15:clr>
-        </p15:guide>
-      </p15:sldGuideLst>
-    </p:ext>
-  </p:extLst>
 </p:presentation>
-</file>
-
-<file path=ppt/revisionInfo.xml><?xml version="1.0" encoding="utf-8"?>
-<p1510:revInfo xmlns:a="http://schemas.openxmlformats.org/drawingml/2006/main" xmlns:r="http://schemas.openxmlformats.org/officeDocument/2006/relationships" xmlns:p1510="http://schemas.microsoft.com/office/powerpoint/2015/10/main">
-  <p1510:revLst>
-    <p1510:client id="{E4859A45-D5CB-456D-87D3-1DAFC14A0D54}" v="11" dt="2026-07-25T14:14:57.947"/>
-  </p1510:revLst>
-</p1510:revInfo>
-</file>
-
-<file path=ppt/changesInfos/changesInfo1.xml><?xml version="1.0" encoding="utf-8"?>
-<pc:chgInfo xmlns:a="http://schemas.openxmlformats.org/drawingml/2006/main" xmlns:r="http://schemas.openxmlformats.org/officeDocument/2006/relationships" xmlns:ac="http://schemas.microsoft.com/office/drawing/2013/main/command" xmlns:pc="http://schemas.microsoft.com/office/powerpoint/2013/main/command">
-  <pc:docChgLst>
-    <pc:chgData name="soujanya hegde" userId="f77445fcd24c4716" providerId="LiveId" clId="{19ACCCFD-CE44-4D36-9959-419B71920180}"/>
-    <pc:docChg chg="undo custSel modSld">
-      <pc:chgData name="soujanya hegde" userId="f77445fcd24c4716" providerId="LiveId" clId="{19ACCCFD-CE44-4D36-9959-419B71920180}" dt="2026-07-25T14:15:12.877" v="99" actId="20577"/>
-      <pc:docMkLst>
-        <pc:docMk/>
-      </pc:docMkLst>
-      <pc:sldChg chg="modSp mod">
-        <pc:chgData name="soujanya hegde" userId="f77445fcd24c4716" providerId="LiveId" clId="{19ACCCFD-CE44-4D36-9959-419B71920180}" dt="2026-07-25T14:15:12.877" v="99" actId="20577"/>
-        <pc:sldMkLst>
-          <pc:docMk/>
-          <pc:sldMk cId="0" sldId="256"/>
-        </pc:sldMkLst>
-        <pc:spChg chg="mod">
-          <ac:chgData name="soujanya hegde" userId="f77445fcd24c4716" providerId="LiveId" clId="{19ACCCFD-CE44-4D36-9959-419B71920180}" dt="2026-07-25T14:15:12.877" v="99" actId="20577"/>
-          <ac:spMkLst>
-            <pc:docMk/>
-            <pc:sldMk cId="0" sldId="256"/>
-            <ac:spMk id="3" creationId="{00000000-0000-0000-0000-000000000000}"/>
-          </ac:spMkLst>
-        </pc:spChg>
-        <pc:spChg chg="mod">
-          <ac:chgData name="soujanya hegde" userId="f77445fcd24c4716" providerId="LiveId" clId="{19ACCCFD-CE44-4D36-9959-419B71920180}" dt="2026-07-25T14:12:47.889" v="60"/>
-          <ac:spMkLst>
-            <pc:docMk/>
-            <pc:sldMk cId="0" sldId="256"/>
-            <ac:spMk id="4" creationId="{00000000-0000-0000-0000-000000000000}"/>
-          </ac:spMkLst>
-        </pc:spChg>
-      </pc:sldChg>
-      <pc:sldChg chg="modSp mod">
-        <pc:chgData name="soujanya hegde" userId="f77445fcd24c4716" providerId="LiveId" clId="{19ACCCFD-CE44-4D36-9959-419B71920180}" dt="2026-07-25T14:02:05.145" v="0" actId="1076"/>
-        <pc:sldMkLst>
-          <pc:docMk/>
-          <pc:sldMk cId="0" sldId="257"/>
-        </pc:sldMkLst>
-        <pc:spChg chg="mod">
-          <ac:chgData name="soujanya hegde" userId="f77445fcd24c4716" providerId="LiveId" clId="{19ACCCFD-CE44-4D36-9959-419B71920180}" dt="2026-07-25T14:02:05.145" v="0" actId="1076"/>
-          <ac:spMkLst>
-            <pc:docMk/>
-            <pc:sldMk cId="0" sldId="257"/>
-            <ac:spMk id="4" creationId="{00000000-0000-0000-0000-000000000000}"/>
-          </ac:spMkLst>
-        </pc:spChg>
-      </pc:sldChg>
-      <pc:sldChg chg="addSp delSp modSp mod">
-        <pc:chgData name="soujanya hegde" userId="f77445fcd24c4716" providerId="LiveId" clId="{19ACCCFD-CE44-4D36-9959-419B71920180}" dt="2026-07-25T14:10:16.412" v="36" actId="14100"/>
-        <pc:sldMkLst>
-          <pc:docMk/>
-          <pc:sldMk cId="0" sldId="265"/>
-        </pc:sldMkLst>
-        <pc:picChg chg="add mod">
-          <ac:chgData name="soujanya hegde" userId="f77445fcd24c4716" providerId="LiveId" clId="{19ACCCFD-CE44-4D36-9959-419B71920180}" dt="2026-07-25T14:10:10.163" v="35" actId="14100"/>
-          <ac:picMkLst>
-            <pc:docMk/>
-            <pc:sldMk cId="0" sldId="265"/>
-            <ac:picMk id="6" creationId="{4CB529A3-191C-DA00-B61E-9802DC0E744F}"/>
-          </ac:picMkLst>
-        </pc:picChg>
-        <pc:picChg chg="add del mod">
-          <ac:chgData name="soujanya hegde" userId="f77445fcd24c4716" providerId="LiveId" clId="{19ACCCFD-CE44-4D36-9959-419B71920180}" dt="2026-07-25T14:09:38.323" v="26" actId="478"/>
-          <ac:picMkLst>
-            <pc:docMk/>
-            <pc:sldMk cId="0" sldId="265"/>
-            <ac:picMk id="8" creationId="{9860DE7D-A750-0343-68F5-A8DED4579729}"/>
-          </ac:picMkLst>
-        </pc:picChg>
-        <pc:picChg chg="add mod">
-          <ac:chgData name="soujanya hegde" userId="f77445fcd24c4716" providerId="LiveId" clId="{19ACCCFD-CE44-4D36-9959-419B71920180}" dt="2026-07-25T14:10:16.412" v="36" actId="14100"/>
-          <ac:picMkLst>
-            <pc:docMk/>
-            <pc:sldMk cId="0" sldId="265"/>
-            <ac:picMk id="10" creationId="{6E660052-1500-34F0-7040-BDBC74E8F69C}"/>
-          </ac:picMkLst>
-        </pc:picChg>
-      </pc:sldChg>
-    </pc:docChg>
-  </pc:docChgLst>
-</pc:chgInfo>
 </file>
 
 <file path=ppt/slideLayouts/slideLayout1.xml><?xml version="1.0" encoding="utf-8"?>
@@ -263,9 +157,10 @@
           <a:lstStyle/>
           <a:p>
             <a:r>
-              <a:rPr lang="en-US"/>
+              <a:rPr lang="en-US" smtClean="0"/>
               <a:t>Click to edit Master title style</a:t>
             </a:r>
+            <a:endParaRPr lang="en-US"/>
           </a:p>
         </p:txBody>
       </p:sp>
@@ -381,9 +276,10 @@
           </a:lstStyle>
           <a:p>
             <a:r>
-              <a:rPr lang="en-US"/>
+              <a:rPr lang="en-US" smtClean="0"/>
               <a:t>Click to edit Master subtitle style</a:t>
             </a:r>
+            <a:endParaRPr lang="en-US"/>
           </a:p>
         </p:txBody>
       </p:sp>
@@ -404,7 +300,7 @@
           <a:p>
             <a:fld id="{5BCAD085-E8A6-8845-BD4E-CB4CCA059FC4}" type="datetimeFigureOut">
               <a:rPr lang="en-US" smtClean="0"/>
-              <a:t>7/25/2026</a:t>
+              <a:t>1/27/13</a:t>
             </a:fld>
             <a:endParaRPr lang="en-US"/>
           </a:p>
@@ -498,9 +394,10 @@
           <a:lstStyle/>
           <a:p>
             <a:r>
-              <a:rPr lang="en-US"/>
+              <a:rPr lang="en-US" smtClean="0"/>
               <a:t>Click to edit Master title style</a:t>
             </a:r>
+            <a:endParaRPr lang="en-US"/>
           </a:p>
         </p:txBody>
       </p:sp>
@@ -521,37 +418,38 @@
           <a:p>
             <a:pPr lvl="0"/>
             <a:r>
-              <a:rPr lang="en-US"/>
+              <a:rPr lang="en-US" smtClean="0"/>
               <a:t>Click to edit Master text styles</a:t>
             </a:r>
           </a:p>
           <a:p>
             <a:pPr lvl="1"/>
             <a:r>
-              <a:rPr lang="en-US"/>
+              <a:rPr lang="en-US" smtClean="0"/>
               <a:t>Second level</a:t>
             </a:r>
           </a:p>
           <a:p>
             <a:pPr lvl="2"/>
             <a:r>
-              <a:rPr lang="en-US"/>
+              <a:rPr lang="en-US" smtClean="0"/>
               <a:t>Third level</a:t>
             </a:r>
           </a:p>
           <a:p>
             <a:pPr lvl="3"/>
             <a:r>
-              <a:rPr lang="en-US"/>
+              <a:rPr lang="en-US" smtClean="0"/>
               <a:t>Fourth level</a:t>
             </a:r>
           </a:p>
           <a:p>
             <a:pPr lvl="4"/>
             <a:r>
-              <a:rPr lang="en-US"/>
+              <a:rPr lang="en-US" smtClean="0"/>
               <a:t>Fifth level</a:t>
             </a:r>
+            <a:endParaRPr lang="en-US"/>
           </a:p>
         </p:txBody>
       </p:sp>
@@ -572,7 +470,7 @@
           <a:p>
             <a:fld id="{5BCAD085-E8A6-8845-BD4E-CB4CCA059FC4}" type="datetimeFigureOut">
               <a:rPr lang="en-US" smtClean="0"/>
-              <a:t>7/25/2026</a:t>
+              <a:t>1/27/13</a:t>
             </a:fld>
             <a:endParaRPr lang="en-US"/>
           </a:p>
@@ -671,9 +569,10 @@
           <a:lstStyle/>
           <a:p>
             <a:r>
-              <a:rPr lang="en-US"/>
+              <a:rPr lang="en-US" smtClean="0"/>
               <a:t>Click to edit Master title style</a:t>
             </a:r>
+            <a:endParaRPr lang="en-US"/>
           </a:p>
         </p:txBody>
       </p:sp>
@@ -699,37 +598,38 @@
           <a:p>
             <a:pPr lvl="0"/>
             <a:r>
-              <a:rPr lang="en-US"/>
+              <a:rPr lang="en-US" smtClean="0"/>
               <a:t>Click to edit Master text styles</a:t>
             </a:r>
           </a:p>
           <a:p>
             <a:pPr lvl="1"/>
             <a:r>
-              <a:rPr lang="en-US"/>
+              <a:rPr lang="en-US" smtClean="0"/>
               <a:t>Second level</a:t>
             </a:r>
           </a:p>
           <a:p>
             <a:pPr lvl="2"/>
             <a:r>
-              <a:rPr lang="en-US"/>
+              <a:rPr lang="en-US" smtClean="0"/>
               <a:t>Third level</a:t>
             </a:r>
           </a:p>
           <a:p>
             <a:pPr lvl="3"/>
             <a:r>
-              <a:rPr lang="en-US"/>
+              <a:rPr lang="en-US" smtClean="0"/>
               <a:t>Fourth level</a:t>
             </a:r>
           </a:p>
           <a:p>
             <a:pPr lvl="4"/>
             <a:r>
-              <a:rPr lang="en-US"/>
+              <a:rPr lang="en-US" smtClean="0"/>
               <a:t>Fifth level</a:t>
             </a:r>
+            <a:endParaRPr lang="en-US"/>
           </a:p>
         </p:txBody>
       </p:sp>
@@ -750,7 +650,7 @@
           <a:p>
             <a:fld id="{5BCAD085-E8A6-8845-BD4E-CB4CCA059FC4}" type="datetimeFigureOut">
               <a:rPr lang="en-US" smtClean="0"/>
-              <a:t>7/25/2026</a:t>
+              <a:t>1/27/13</a:t>
             </a:fld>
             <a:endParaRPr lang="en-US"/>
           </a:p>
@@ -844,9 +744,10 @@
           <a:lstStyle/>
           <a:p>
             <a:r>
-              <a:rPr lang="en-US"/>
+              <a:rPr lang="en-US" smtClean="0"/>
               <a:t>Click to edit Master title style</a:t>
             </a:r>
+            <a:endParaRPr lang="en-US"/>
           </a:p>
         </p:txBody>
       </p:sp>
@@ -867,37 +768,38 @@
           <a:p>
             <a:pPr lvl="0"/>
             <a:r>
-              <a:rPr lang="en-US"/>
+              <a:rPr lang="en-US" smtClean="0"/>
               <a:t>Click to edit Master text styles</a:t>
             </a:r>
           </a:p>
           <a:p>
             <a:pPr lvl="1"/>
             <a:r>
-              <a:rPr lang="en-US"/>
+              <a:rPr lang="en-US" smtClean="0"/>
               <a:t>Second level</a:t>
             </a:r>
           </a:p>
           <a:p>
             <a:pPr lvl="2"/>
             <a:r>
-              <a:rPr lang="en-US"/>
+              <a:rPr lang="en-US" smtClean="0"/>
               <a:t>Third level</a:t>
             </a:r>
           </a:p>
           <a:p>
             <a:pPr lvl="3"/>
             <a:r>
-              <a:rPr lang="en-US"/>
+              <a:rPr lang="en-US" smtClean="0"/>
               <a:t>Fourth level</a:t>
             </a:r>
           </a:p>
           <a:p>
             <a:pPr lvl="4"/>
             <a:r>
-              <a:rPr lang="en-US"/>
+              <a:rPr lang="en-US" smtClean="0"/>
               <a:t>Fifth level</a:t>
             </a:r>
+            <a:endParaRPr lang="en-US"/>
           </a:p>
         </p:txBody>
       </p:sp>
@@ -918,7 +820,7 @@
           <a:p>
             <a:fld id="{5BCAD085-E8A6-8845-BD4E-CB4CCA059FC4}" type="datetimeFigureOut">
               <a:rPr lang="en-US" smtClean="0"/>
-              <a:t>7/25/2026</a:t>
+              <a:t>1/27/13</a:t>
             </a:fld>
             <a:endParaRPr lang="en-US"/>
           </a:p>
@@ -1021,9 +923,10 @@
           </a:lstStyle>
           <a:p>
             <a:r>
-              <a:rPr lang="en-US"/>
+              <a:rPr lang="en-US" smtClean="0"/>
               <a:t>Click to edit Master title style</a:t>
             </a:r>
+            <a:endParaRPr lang="en-US"/>
           </a:p>
         </p:txBody>
       </p:sp>
@@ -1140,7 +1043,7 @@
           <a:p>
             <a:pPr lvl="0"/>
             <a:r>
-              <a:rPr lang="en-US"/>
+              <a:rPr lang="en-US" smtClean="0"/>
               <a:t>Click to edit Master text styles</a:t>
             </a:r>
           </a:p>
@@ -1163,7 +1066,7 @@
           <a:p>
             <a:fld id="{5BCAD085-E8A6-8845-BD4E-CB4CCA059FC4}" type="datetimeFigureOut">
               <a:rPr lang="en-US" smtClean="0"/>
-              <a:t>7/25/2026</a:t>
+              <a:t>1/27/13</a:t>
             </a:fld>
             <a:endParaRPr lang="en-US"/>
           </a:p>
@@ -1257,9 +1160,10 @@
           <a:lstStyle/>
           <a:p>
             <a:r>
-              <a:rPr lang="en-US"/>
+              <a:rPr lang="en-US" smtClean="0"/>
               <a:t>Click to edit Master title style</a:t>
             </a:r>
+            <a:endParaRPr lang="en-US"/>
           </a:p>
         </p:txBody>
       </p:sp>
@@ -1313,37 +1217,38 @@
           <a:p>
             <a:pPr lvl="0"/>
             <a:r>
-              <a:rPr lang="en-US"/>
+              <a:rPr lang="en-US" smtClean="0"/>
               <a:t>Click to edit Master text styles</a:t>
             </a:r>
           </a:p>
           <a:p>
             <a:pPr lvl="1"/>
             <a:r>
-              <a:rPr lang="en-US"/>
+              <a:rPr lang="en-US" smtClean="0"/>
               <a:t>Second level</a:t>
             </a:r>
           </a:p>
           <a:p>
             <a:pPr lvl="2"/>
             <a:r>
-              <a:rPr lang="en-US"/>
+              <a:rPr lang="en-US" smtClean="0"/>
               <a:t>Third level</a:t>
             </a:r>
           </a:p>
           <a:p>
             <a:pPr lvl="3"/>
             <a:r>
-              <a:rPr lang="en-US"/>
+              <a:rPr lang="en-US" smtClean="0"/>
               <a:t>Fourth level</a:t>
             </a:r>
           </a:p>
           <a:p>
             <a:pPr lvl="4"/>
             <a:r>
-              <a:rPr lang="en-US"/>
+              <a:rPr lang="en-US" smtClean="0"/>
               <a:t>Fifth level</a:t>
             </a:r>
+            <a:endParaRPr lang="en-US"/>
           </a:p>
         </p:txBody>
       </p:sp>
@@ -1397,37 +1302,38 @@
           <a:p>
             <a:pPr lvl="0"/>
             <a:r>
-              <a:rPr lang="en-US"/>
+              <a:rPr lang="en-US" smtClean="0"/>
               <a:t>Click to edit Master text styles</a:t>
             </a:r>
           </a:p>
           <a:p>
             <a:pPr lvl="1"/>
             <a:r>
-              <a:rPr lang="en-US"/>
+              <a:rPr lang="en-US" smtClean="0"/>
               <a:t>Second level</a:t>
             </a:r>
           </a:p>
           <a:p>
             <a:pPr lvl="2"/>
             <a:r>
-              <a:rPr lang="en-US"/>
+              <a:rPr lang="en-US" smtClean="0"/>
               <a:t>Third level</a:t>
             </a:r>
           </a:p>
           <a:p>
             <a:pPr lvl="3"/>
             <a:r>
-              <a:rPr lang="en-US"/>
+              <a:rPr lang="en-US" smtClean="0"/>
               <a:t>Fourth level</a:t>
             </a:r>
           </a:p>
           <a:p>
             <a:pPr lvl="4"/>
             <a:r>
-              <a:rPr lang="en-US"/>
+              <a:rPr lang="en-US" smtClean="0"/>
               <a:t>Fifth level</a:t>
             </a:r>
+            <a:endParaRPr lang="en-US"/>
           </a:p>
         </p:txBody>
       </p:sp>
@@ -1448,7 +1354,7 @@
           <a:p>
             <a:fld id="{5BCAD085-E8A6-8845-BD4E-CB4CCA059FC4}" type="datetimeFigureOut">
               <a:rPr lang="en-US" smtClean="0"/>
-              <a:t>7/25/2026</a:t>
+              <a:t>1/27/13</a:t>
             </a:fld>
             <a:endParaRPr lang="en-US"/>
           </a:p>
@@ -1546,9 +1452,10 @@
           </a:lstStyle>
           <a:p>
             <a:r>
-              <a:rPr lang="en-US"/>
+              <a:rPr lang="en-US" smtClean="0"/>
               <a:t>Click to edit Master title style</a:t>
             </a:r>
+            <a:endParaRPr lang="en-US"/>
           </a:p>
         </p:txBody>
       </p:sp>
@@ -1611,7 +1518,7 @@
           <a:p>
             <a:pPr lvl="0"/>
             <a:r>
-              <a:rPr lang="en-US"/>
+              <a:rPr lang="en-US" smtClean="0"/>
               <a:t>Click to edit Master text styles</a:t>
             </a:r>
           </a:p>
@@ -1667,37 +1574,38 @@
           <a:p>
             <a:pPr lvl="0"/>
             <a:r>
-              <a:rPr lang="en-US"/>
+              <a:rPr lang="en-US" smtClean="0"/>
               <a:t>Click to edit Master text styles</a:t>
             </a:r>
           </a:p>
           <a:p>
             <a:pPr lvl="1"/>
             <a:r>
-              <a:rPr lang="en-US"/>
+              <a:rPr lang="en-US" smtClean="0"/>
               <a:t>Second level</a:t>
             </a:r>
           </a:p>
           <a:p>
             <a:pPr lvl="2"/>
             <a:r>
-              <a:rPr lang="en-US"/>
+              <a:rPr lang="en-US" smtClean="0"/>
               <a:t>Third level</a:t>
             </a:r>
           </a:p>
           <a:p>
             <a:pPr lvl="3"/>
             <a:r>
-              <a:rPr lang="en-US"/>
+              <a:rPr lang="en-US" smtClean="0"/>
               <a:t>Fourth level</a:t>
             </a:r>
           </a:p>
           <a:p>
             <a:pPr lvl="4"/>
             <a:r>
-              <a:rPr lang="en-US"/>
+              <a:rPr lang="en-US" smtClean="0"/>
               <a:t>Fifth level</a:t>
             </a:r>
+            <a:endParaRPr lang="en-US"/>
           </a:p>
         </p:txBody>
       </p:sp>
@@ -1760,7 +1668,7 @@
           <a:p>
             <a:pPr lvl="0"/>
             <a:r>
-              <a:rPr lang="en-US"/>
+              <a:rPr lang="en-US" smtClean="0"/>
               <a:t>Click to edit Master text styles</a:t>
             </a:r>
           </a:p>
@@ -1816,37 +1724,38 @@
           <a:p>
             <a:pPr lvl="0"/>
             <a:r>
-              <a:rPr lang="en-US"/>
+              <a:rPr lang="en-US" smtClean="0"/>
               <a:t>Click to edit Master text styles</a:t>
             </a:r>
           </a:p>
           <a:p>
             <a:pPr lvl="1"/>
             <a:r>
-              <a:rPr lang="en-US"/>
+              <a:rPr lang="en-US" smtClean="0"/>
               <a:t>Second level</a:t>
             </a:r>
           </a:p>
           <a:p>
             <a:pPr lvl="2"/>
             <a:r>
-              <a:rPr lang="en-US"/>
+              <a:rPr lang="en-US" smtClean="0"/>
               <a:t>Third level</a:t>
             </a:r>
           </a:p>
           <a:p>
             <a:pPr lvl="3"/>
             <a:r>
-              <a:rPr lang="en-US"/>
+              <a:rPr lang="en-US" smtClean="0"/>
               <a:t>Fourth level</a:t>
             </a:r>
           </a:p>
           <a:p>
             <a:pPr lvl="4"/>
             <a:r>
-              <a:rPr lang="en-US"/>
+              <a:rPr lang="en-US" smtClean="0"/>
               <a:t>Fifth level</a:t>
             </a:r>
+            <a:endParaRPr lang="en-US"/>
           </a:p>
         </p:txBody>
       </p:sp>
@@ -1867,7 +1776,7 @@
           <a:p>
             <a:fld id="{5BCAD085-E8A6-8845-BD4E-CB4CCA059FC4}" type="datetimeFigureOut">
               <a:rPr lang="en-US" smtClean="0"/>
-              <a:t>7/25/2026</a:t>
+              <a:t>1/27/13</a:t>
             </a:fld>
             <a:endParaRPr lang="en-US"/>
           </a:p>
@@ -1961,9 +1870,10 @@
           <a:lstStyle/>
           <a:p>
             <a:r>
-              <a:rPr lang="en-US"/>
+              <a:rPr lang="en-US" smtClean="0"/>
               <a:t>Click to edit Master title style</a:t>
             </a:r>
+            <a:endParaRPr lang="en-US"/>
           </a:p>
         </p:txBody>
       </p:sp>
@@ -1984,7 +1894,7 @@
           <a:p>
             <a:fld id="{5BCAD085-E8A6-8845-BD4E-CB4CCA059FC4}" type="datetimeFigureOut">
               <a:rPr lang="en-US" smtClean="0"/>
-              <a:t>7/25/2026</a:t>
+              <a:t>1/27/13</a:t>
             </a:fld>
             <a:endParaRPr lang="en-US"/>
           </a:p>
@@ -2079,7 +1989,7 @@
           <a:p>
             <a:fld id="{5BCAD085-E8A6-8845-BD4E-CB4CCA059FC4}" type="datetimeFigureOut">
               <a:rPr lang="en-US" smtClean="0"/>
-              <a:t>7/25/2026</a:t>
+              <a:t>1/27/13</a:t>
             </a:fld>
             <a:endParaRPr lang="en-US"/>
           </a:p>
@@ -2182,9 +2092,10 @@
           </a:lstStyle>
           <a:p>
             <a:r>
-              <a:rPr lang="en-US"/>
+              <a:rPr lang="en-US" smtClean="0"/>
               <a:t>Click to edit Master title style</a:t>
             </a:r>
+            <a:endParaRPr lang="en-US"/>
           </a:p>
         </p:txBody>
       </p:sp>
@@ -2238,37 +2149,38 @@
           <a:p>
             <a:pPr lvl="0"/>
             <a:r>
-              <a:rPr lang="en-US"/>
+              <a:rPr lang="en-US" smtClean="0"/>
               <a:t>Click to edit Master text styles</a:t>
             </a:r>
           </a:p>
           <a:p>
             <a:pPr lvl="1"/>
             <a:r>
-              <a:rPr lang="en-US"/>
+              <a:rPr lang="en-US" smtClean="0"/>
               <a:t>Second level</a:t>
             </a:r>
           </a:p>
           <a:p>
             <a:pPr lvl="2"/>
             <a:r>
-              <a:rPr lang="en-US"/>
+              <a:rPr lang="en-US" smtClean="0"/>
               <a:t>Third level</a:t>
             </a:r>
           </a:p>
           <a:p>
             <a:pPr lvl="3"/>
             <a:r>
-              <a:rPr lang="en-US"/>
+              <a:rPr lang="en-US" smtClean="0"/>
               <a:t>Fourth level</a:t>
             </a:r>
           </a:p>
           <a:p>
             <a:pPr lvl="4"/>
             <a:r>
-              <a:rPr lang="en-US"/>
+              <a:rPr lang="en-US" smtClean="0"/>
               <a:t>Fifth level</a:t>
             </a:r>
+            <a:endParaRPr lang="en-US"/>
           </a:p>
         </p:txBody>
       </p:sp>
@@ -2331,7 +2243,7 @@
           <a:p>
             <a:pPr lvl="0"/>
             <a:r>
-              <a:rPr lang="en-US"/>
+              <a:rPr lang="en-US" smtClean="0"/>
               <a:t>Click to edit Master text styles</a:t>
             </a:r>
           </a:p>
@@ -2354,7 +2266,7 @@
           <a:p>
             <a:fld id="{5BCAD085-E8A6-8845-BD4E-CB4CCA059FC4}" type="datetimeFigureOut">
               <a:rPr lang="en-US" smtClean="0"/>
-              <a:t>7/25/2026</a:t>
+              <a:t>1/27/13</a:t>
             </a:fld>
             <a:endParaRPr lang="en-US"/>
           </a:p>
@@ -2457,9 +2369,10 @@
           </a:lstStyle>
           <a:p>
             <a:r>
-              <a:rPr lang="en-US"/>
+              <a:rPr lang="en-US" smtClean="0"/>
               <a:t>Click to edit Master title style</a:t>
             </a:r>
+            <a:endParaRPr lang="en-US"/>
           </a:p>
         </p:txBody>
       </p:sp>
@@ -2583,7 +2496,7 @@
           <a:p>
             <a:pPr lvl="0"/>
             <a:r>
-              <a:rPr lang="en-US"/>
+              <a:rPr lang="en-US" smtClean="0"/>
               <a:t>Click to edit Master text styles</a:t>
             </a:r>
           </a:p>
@@ -2606,7 +2519,7 @@
           <a:p>
             <a:fld id="{5BCAD085-E8A6-8845-BD4E-CB4CCA059FC4}" type="datetimeFigureOut">
               <a:rPr lang="en-US" smtClean="0"/>
-              <a:t>7/25/2026</a:t>
+              <a:t>1/27/13</a:t>
             </a:fld>
             <a:endParaRPr lang="en-US"/>
           </a:p>
@@ -2715,9 +2628,10 @@
           <a:lstStyle/>
           <a:p>
             <a:r>
-              <a:rPr lang="en-US"/>
+              <a:rPr lang="en-US" smtClean="0"/>
               <a:t>Click to edit Master title style</a:t>
             </a:r>
+            <a:endParaRPr lang="en-US"/>
           </a:p>
         </p:txBody>
       </p:sp>
@@ -2748,37 +2662,38 @@
           <a:p>
             <a:pPr lvl="0"/>
             <a:r>
-              <a:rPr lang="en-US"/>
+              <a:rPr lang="en-US" smtClean="0"/>
               <a:t>Click to edit Master text styles</a:t>
             </a:r>
           </a:p>
           <a:p>
             <a:pPr lvl="1"/>
             <a:r>
-              <a:rPr lang="en-US"/>
+              <a:rPr lang="en-US" smtClean="0"/>
               <a:t>Second level</a:t>
             </a:r>
           </a:p>
           <a:p>
             <a:pPr lvl="2"/>
             <a:r>
-              <a:rPr lang="en-US"/>
+              <a:rPr lang="en-US" smtClean="0"/>
               <a:t>Third level</a:t>
             </a:r>
           </a:p>
           <a:p>
             <a:pPr lvl="3"/>
             <a:r>
-              <a:rPr lang="en-US"/>
+              <a:rPr lang="en-US" smtClean="0"/>
               <a:t>Fourth level</a:t>
             </a:r>
           </a:p>
           <a:p>
             <a:pPr lvl="4"/>
             <a:r>
-              <a:rPr lang="en-US"/>
+              <a:rPr lang="en-US" smtClean="0"/>
               <a:t>Fifth level</a:t>
             </a:r>
+            <a:endParaRPr lang="en-US"/>
           </a:p>
         </p:txBody>
       </p:sp>
@@ -2817,7 +2732,7 @@
           <a:p>
             <a:fld id="{5BCAD085-E8A6-8845-BD4E-CB4CCA059FC4}" type="datetimeFigureOut">
               <a:rPr lang="en-US" smtClean="0"/>
-              <a:t>7/25/2026</a:t>
+              <a:t>1/27/13</a:t>
             </a:fld>
             <a:endParaRPr lang="en-US"/>
           </a:p>
@@ -3176,7 +3091,7 @@
 </file>
 
 <file path=ppt/slides/slide1.xml><?xml version="1.0" encoding="utf-8"?>
-<p:sld xmlns:a="http://schemas.openxmlformats.org/drawingml/2006/main" xmlns:r="http://schemas.openxmlformats.org/officeDocument/2006/relationships" xmlns:p="http://schemas.openxmlformats.org/presentationml/2006/main">
+<p:sld xmlns:a="http://schemas.openxmlformats.org/drawingml/2006/main" xmlns:p="http://schemas.openxmlformats.org/presentationml/2006/main" xmlns:r="http://schemas.openxmlformats.org/officeDocument/2006/relationships">
   <p:cSld>
     <p:bg>
       <p:bgPr>
@@ -3192,14 +3107,7 @@
         <p:cNvGrpSpPr/>
         <p:nvPr/>
       </p:nvGrpSpPr>
-      <p:grpSpPr>
-        <a:xfrm>
-          <a:off x="0" y="0"/>
-          <a:ext cx="0" cy="0"/>
-          <a:chOff x="0" y="0"/>
-          <a:chExt cx="0" cy="0"/>
-        </a:xfrm>
-      </p:grpSpPr>
+      <p:grpSpPr/>
       <p:sp>
         <p:nvSpPr>
           <p:cNvPr id="2" name="Rectangle 1"/>
@@ -3242,7 +3150,6 @@
           <a:lstStyle/>
           <a:p>
             <a:pPr algn="ctr"/>
-            <a:endParaRPr/>
           </a:p>
         </p:txBody>
       </p:sp>
@@ -3255,7 +3162,7 @@
         <p:spPr>
           <a:xfrm>
             <a:off x="914400" y="1097280"/>
-            <a:ext cx="10332720" cy="923330"/>
+            <a:ext cx="10332720" cy="1645920"/>
           </a:xfrm>
           <a:prstGeom prst="rect">
             <a:avLst/>
@@ -3277,34 +3184,8 @@
               </a:defRPr>
             </a:pPr>
             <a:r>
-              <a:rPr lang="en-GB" sz="3200" b="1" dirty="0"/>
-              <a:t>PROJECT TITLE  </a:t>
-            </a:r>
-            <a:r>
-              <a:rPr lang="en-GB" sz="3600" b="1" dirty="0"/>
-              <a:t>: </a:t>
-            </a:r>
-            <a:r>
-              <a:rPr sz="3600" dirty="0"/>
-              <a:t>Nutritional </a:t>
-            </a:r>
-            <a:r>
-              <a:rPr sz="3600"/>
-              <a:t>AI Agent</a:t>
-            </a:r>
-            <a:r>
-              <a:rPr lang="en-IN" sz="3600"/>
-              <a:t> </a:t>
-            </a:r>
-            <a:r>
-              <a:rPr lang="en-IN" sz="2000"/>
-              <a:t>(</a:t>
-            </a:r>
-            <a:r>
-              <a:rPr lang="en-IN" sz="2000" dirty="0"/>
-              <a:t>AI Automation)</a:t>
-            </a:r>
-            <a:endParaRPr sz="3600" dirty="0"/>
+              <a:t>Nutritional AI Agent</a:t>
+            </a:r>
           </a:p>
           <a:p>
             <a:pPr>
@@ -3316,16 +3197,7 @@
               </a:defRPr>
             </a:pPr>
             <a:r>
-              <a:rPr dirty="0"/>
-              <a:t>IBM </a:t>
-            </a:r>
-            <a:r>
-              <a:rPr dirty="0" err="1"/>
-              <a:t>SkillsBuild</a:t>
-            </a:r>
-            <a:r>
-              <a:rPr dirty="0"/>
-              <a:t> Project Submission | UN SDG 3 (Good Health and Well-being)</a:t>
+              <a:t>IBM SkillsBuild Project Submission | UN SDG 3 (Good Health and Well-being)</a:t>
             </a:r>
           </a:p>
         </p:txBody>
@@ -3338,8 +3210,8 @@
         </p:nvSpPr>
         <p:spPr>
           <a:xfrm>
-            <a:off x="914399" y="2497394"/>
-            <a:ext cx="10332721" cy="2308324"/>
+            <a:off x="914400" y="2926080"/>
+            <a:ext cx="10332720" cy="3200400"/>
           </a:xfrm>
           <a:prstGeom prst="rect">
             <a:avLst/>
@@ -3352,81 +3224,128 @@
           </a:bodyPr>
           <a:lstStyle/>
           <a:p>
-            <a:r>
-              <a:rPr lang="en-IN" sz="2400" b="1" dirty="0"/>
-              <a:t>Full Name:</a:t>
-            </a:r>
-            <a:r>
-              <a:rPr lang="en-IN" sz="2400" dirty="0"/>
-              <a:t> Soujanya K Hegde and Mohammed Umar F</a:t>
-            </a:r>
-          </a:p>
-          <a:p>
-            <a:r>
-              <a:rPr lang="en-IN" sz="2400" b="1" dirty="0"/>
-              <a:t>Registered Mail ID:</a:t>
-            </a:r>
-            <a:r>
-              <a:rPr lang="en-IN" sz="2400" dirty="0"/>
-              <a:t> </a:t>
-            </a:r>
-            <a:r>
-              <a:rPr lang="en-IN" sz="2400" dirty="0">
-                <a:hlinkClick r:id="rId2"/>
+            <a:pPr>
+              <a:spcAft>
+                <a:spcPts val="800"/>
+              </a:spcAft>
+            </a:pPr>
+            <a:r>
+              <a:rPr sz="1600" b="1">
+                <a:solidFill>
+                  <a:srgbClr val="0F172A"/>
+                </a:solidFill>
+                <a:latin typeface="Arial"/>
               </a:rPr>
-              <a:t>shegde092@gmail.com</a:t>
-            </a:r>
-            <a:r>
-              <a:rPr lang="en-IN" sz="2400" dirty="0"/>
-              <a:t> and mdumr4@gamil.com</a:t>
-            </a:r>
-          </a:p>
-          <a:p>
-            <a:r>
-              <a:rPr lang="en-IN" sz="2400" b="1" dirty="0"/>
-              <a:t>College Name:</a:t>
-            </a:r>
-            <a:r>
-              <a:rPr lang="en-IN" sz="2400" dirty="0"/>
-              <a:t> Cambridge Institute of Technology</a:t>
-            </a:r>
-          </a:p>
-          <a:p>
-            <a:r>
-              <a:rPr lang="en-IN" sz="2400" b="1" dirty="0"/>
-              <a:t>Mob No.:</a:t>
-            </a:r>
-            <a:r>
-              <a:rPr lang="en-IN" sz="2400" dirty="0"/>
-              <a:t> 9148165856 and 8892574137</a:t>
-            </a:r>
-          </a:p>
-          <a:p>
-            <a:r>
-              <a:rPr lang="en-IN" sz="2400" b="1" dirty="0"/>
-              <a:t>IBM </a:t>
-            </a:r>
-            <a:r>
-              <a:rPr lang="en-IN" sz="2400" b="1" dirty="0" err="1"/>
-              <a:t>SkillsBuild</a:t>
-            </a:r>
-            <a:r>
-              <a:rPr lang="en-IN" sz="2400" b="1" dirty="0"/>
-              <a:t> Platform Mail ID:</a:t>
-            </a:r>
-            <a:r>
-              <a:rPr lang="en-IN" sz="2400" dirty="0"/>
-              <a:t> </a:t>
-            </a:r>
-            <a:r>
-              <a:rPr lang="en-IN" sz="2400" dirty="0">
-                <a:hlinkClick r:id="rId2"/>
+              <a:t>Full Name: </a:t>
+            </a:r>
+            <a:r>
+              <a:rPr sz="1600">
+                <a:solidFill>
+                  <a:srgbClr val="475569"/>
+                </a:solidFill>
+                <a:latin typeface="Arial"/>
               </a:rPr>
-              <a:t>shegde092@gmail.com</a:t>
-            </a:r>
-            <a:r>
-              <a:rPr lang="en-IN" sz="2400" dirty="0"/>
-              <a:t> and mdumr4@gamil.com</a:t>
+              <a:t>[Your Full Name Here]</a:t>
+            </a:r>
+          </a:p>
+          <a:p>
+            <a:pPr>
+              <a:spcAft>
+                <a:spcPts val="800"/>
+              </a:spcAft>
+            </a:pPr>
+            <a:r>
+              <a:rPr sz="1600" b="1">
+                <a:solidFill>
+                  <a:srgbClr val="0F172A"/>
+                </a:solidFill>
+                <a:latin typeface="Arial"/>
+              </a:rPr>
+              <a:t>Registered Mail ID: </a:t>
+            </a:r>
+            <a:r>
+              <a:rPr sz="1600">
+                <a:solidFill>
+                  <a:srgbClr val="475569"/>
+                </a:solidFill>
+                <a:latin typeface="Arial"/>
+              </a:rPr>
+              <a:t>[Your Registered Mail ID Here]</a:t>
+            </a:r>
+          </a:p>
+          <a:p>
+            <a:pPr>
+              <a:spcAft>
+                <a:spcPts val="800"/>
+              </a:spcAft>
+            </a:pPr>
+            <a:r>
+              <a:rPr sz="1600" b="1">
+                <a:solidFill>
+                  <a:srgbClr val="0F172A"/>
+                </a:solidFill>
+                <a:latin typeface="Arial"/>
+              </a:rPr>
+              <a:t>College Name: </a:t>
+            </a:r>
+            <a:r>
+              <a:rPr sz="1600">
+                <a:solidFill>
+                  <a:srgbClr val="475569"/>
+                </a:solidFill>
+                <a:latin typeface="Arial"/>
+              </a:rPr>
+              <a:t>[Your College Name Here]</a:t>
+            </a:r>
+          </a:p>
+          <a:p>
+            <a:pPr>
+              <a:spcAft>
+                <a:spcPts val="800"/>
+              </a:spcAft>
+            </a:pPr>
+            <a:r>
+              <a:rPr sz="1600" b="1">
+                <a:solidFill>
+                  <a:srgbClr val="0F172A"/>
+                </a:solidFill>
+                <a:latin typeface="Arial"/>
+              </a:rPr>
+              <a:t>Mob No.: </a:t>
+            </a:r>
+            <a:r>
+              <a:rPr sz="1600">
+                <a:solidFill>
+                  <a:srgbClr val="475569"/>
+                </a:solidFill>
+                <a:latin typeface="Arial"/>
+              </a:rPr>
+              <a:t>[Your Mobile Number Here]</a:t>
+            </a:r>
+          </a:p>
+          <a:p>
+            <a:pPr>
+              <a:spcAft>
+                <a:spcPts val="800"/>
+              </a:spcAft>
+            </a:pPr>
+            <a:r>
+              <a:rPr sz="1600" b="1">
+                <a:solidFill>
+                  <a:srgbClr val="0F172A"/>
+                </a:solidFill>
+                <a:latin typeface="Arial"/>
+              </a:rPr>
+              <a:t>IBM SkillsBuild Platform Mail ID: </a:t>
+            </a:r>
+            <a:r>
+              <a:rPr sz="1600">
+                <a:solidFill>
+                  <a:srgbClr val="475569"/>
+                </a:solidFill>
+                <a:latin typeface="Arial"/>
+              </a:rPr>
+              <a:t>[Your SkillsBuild Platform Mail ID Here]</a:t>
             </a:r>
           </a:p>
         </p:txBody>
@@ -3440,7 +3359,7 @@
 </file>
 
 <file path=ppt/slides/slide10.xml><?xml version="1.0" encoding="utf-8"?>
-<p:sld xmlns:a="http://schemas.openxmlformats.org/drawingml/2006/main" xmlns:r="http://schemas.openxmlformats.org/officeDocument/2006/relationships" xmlns:p="http://schemas.openxmlformats.org/presentationml/2006/main">
+<p:sld xmlns:a="http://schemas.openxmlformats.org/drawingml/2006/main" xmlns:p="http://schemas.openxmlformats.org/presentationml/2006/main" xmlns:r="http://schemas.openxmlformats.org/officeDocument/2006/relationships">
   <p:cSld>
     <p:bg>
       <p:bgPr>
@@ -3456,14 +3375,7 @@
         <p:cNvGrpSpPr/>
         <p:nvPr/>
       </p:nvGrpSpPr>
-      <p:grpSpPr>
-        <a:xfrm>
-          <a:off x="0" y="0"/>
-          <a:ext cx="0" cy="0"/>
-          <a:chOff x="0" y="0"/>
-          <a:chExt cx="0" cy="0"/>
-        </a:xfrm>
-      </p:grpSpPr>
+      <p:grpSpPr/>
       <p:sp>
         <p:nvSpPr>
           <p:cNvPr id="2" name="Rectangle 1"/>
@@ -3506,7 +3418,6 @@
           <a:lstStyle/>
           <a:p>
             <a:pPr algn="ctr"/>
-            <a:endParaRPr/>
           </a:p>
         </p:txBody>
       </p:sp>
@@ -3584,7 +3495,7 @@
           </a:fontRef>
         </p:style>
         <p:txBody>
-          <a:bodyPr wrap="square" rtlCol="0" anchor="ctr"/>
+          <a:bodyPr rtlCol="0" anchor="ctr" wrap="square"/>
           <a:lstStyle/>
           <a:p>
             <a:pPr algn="ctr">
@@ -3601,72 +3512,20 @@
           </a:p>
           <a:p>
             <a:br/>
+            <a:pPr algn="ctr">
+              <a:defRPr sz="1400">
+                <a:solidFill>
+                  <a:srgbClr val="475569"/>
+                </a:solidFill>
+                <a:latin typeface="Arial"/>
+              </a:defRPr>
+            </a:pPr>
             <a:r>
               <a:t>(Take a screenshot of the running Streamlit Nutritional AI Agent UI and paste it here.)</a:t>
             </a:r>
           </a:p>
         </p:txBody>
       </p:sp>
-      <p:pic>
-        <p:nvPicPr>
-          <p:cNvPr id="6" name="Picture 5">
-            <a:extLst>
-              <a:ext uri="{FF2B5EF4-FFF2-40B4-BE49-F238E27FC236}">
-                <a16:creationId xmlns:a16="http://schemas.microsoft.com/office/drawing/2014/main" id="{4CB529A3-191C-DA00-B61E-9802DC0E744F}"/>
-              </a:ext>
-            </a:extLst>
-          </p:cNvPr>
-          <p:cNvPicPr>
-            <a:picLocks noChangeAspect="1"/>
-          </p:cNvPicPr>
-          <p:nvPr/>
-        </p:nvPicPr>
-        <p:blipFill>
-          <a:blip r:embed="rId2"/>
-          <a:stretch>
-            <a:fillRect/>
-          </a:stretch>
-        </p:blipFill>
-        <p:spPr>
-          <a:xfrm>
-            <a:off x="6351638" y="1005840"/>
-            <a:ext cx="5840362" cy="5852160"/>
-          </a:xfrm>
-          <a:prstGeom prst="rect">
-            <a:avLst/>
-          </a:prstGeom>
-        </p:spPr>
-      </p:pic>
-      <p:pic>
-        <p:nvPicPr>
-          <p:cNvPr id="10" name="Picture 9">
-            <a:extLst>
-              <a:ext uri="{FF2B5EF4-FFF2-40B4-BE49-F238E27FC236}">
-                <a16:creationId xmlns:a16="http://schemas.microsoft.com/office/drawing/2014/main" id="{6E660052-1500-34F0-7040-BDBC74E8F69C}"/>
-              </a:ext>
-            </a:extLst>
-          </p:cNvPr>
-          <p:cNvPicPr>
-            <a:picLocks noChangeAspect="1"/>
-          </p:cNvPicPr>
-          <p:nvPr/>
-        </p:nvPicPr>
-        <p:blipFill>
-          <a:blip r:embed="rId3"/>
-          <a:stretch>
-            <a:fillRect/>
-          </a:stretch>
-        </p:blipFill>
-        <p:spPr>
-          <a:xfrm>
-            <a:off x="0" y="1005840"/>
-            <a:ext cx="6351638" cy="5852160"/>
-          </a:xfrm>
-          <a:prstGeom prst="rect">
-            <a:avLst/>
-          </a:prstGeom>
-        </p:spPr>
-      </p:pic>
     </p:spTree>
   </p:cSld>
   <p:clrMapOvr>
@@ -3676,7 +3535,7 @@
 </file>
 
 <file path=ppt/slides/slide11.xml><?xml version="1.0" encoding="utf-8"?>
-<p:sld xmlns:a="http://schemas.openxmlformats.org/drawingml/2006/main" xmlns:r="http://schemas.openxmlformats.org/officeDocument/2006/relationships" xmlns:p="http://schemas.openxmlformats.org/presentationml/2006/main">
+<p:sld xmlns:a="http://schemas.openxmlformats.org/drawingml/2006/main" xmlns:p="http://schemas.openxmlformats.org/presentationml/2006/main" xmlns:r="http://schemas.openxmlformats.org/officeDocument/2006/relationships">
   <p:cSld>
     <p:bg>
       <p:bgPr>
@@ -3692,14 +3551,7 @@
         <p:cNvGrpSpPr/>
         <p:nvPr/>
       </p:nvGrpSpPr>
-      <p:grpSpPr>
-        <a:xfrm>
-          <a:off x="0" y="0"/>
-          <a:ext cx="0" cy="0"/>
-          <a:chOff x="0" y="0"/>
-          <a:chExt cx="0" cy="0"/>
-        </a:xfrm>
-      </p:grpSpPr>
+      <p:grpSpPr/>
       <p:sp>
         <p:nvSpPr>
           <p:cNvPr id="2" name="Rectangle 1"/>
@@ -3742,7 +3594,6 @@
           <a:lstStyle/>
           <a:p>
             <a:pPr algn="ctr"/>
-            <a:endParaRPr/>
           </a:p>
         </p:txBody>
       </p:sp>
@@ -3930,7 +3781,7 @@
 </file>
 
 <file path=ppt/slides/slide12.xml><?xml version="1.0" encoding="utf-8"?>
-<p:sld xmlns:a="http://schemas.openxmlformats.org/drawingml/2006/main" xmlns:r="http://schemas.openxmlformats.org/officeDocument/2006/relationships" xmlns:p="http://schemas.openxmlformats.org/presentationml/2006/main">
+<p:sld xmlns:a="http://schemas.openxmlformats.org/drawingml/2006/main" xmlns:p="http://schemas.openxmlformats.org/presentationml/2006/main" xmlns:r="http://schemas.openxmlformats.org/officeDocument/2006/relationships">
   <p:cSld>
     <p:bg>
       <p:bgPr>
@@ -3946,14 +3797,7 @@
         <p:cNvGrpSpPr/>
         <p:nvPr/>
       </p:nvGrpSpPr>
-      <p:grpSpPr>
-        <a:xfrm>
-          <a:off x="0" y="0"/>
-          <a:ext cx="0" cy="0"/>
-          <a:chOff x="0" y="0"/>
-          <a:chExt cx="0" cy="0"/>
-        </a:xfrm>
-      </p:grpSpPr>
+      <p:grpSpPr/>
       <p:sp>
         <p:nvSpPr>
           <p:cNvPr id="2" name="Rectangle 1"/>
@@ -3996,7 +3840,6 @@
           <a:lstStyle/>
           <a:p>
             <a:pPr algn="ctr"/>
-            <a:endParaRPr/>
           </a:p>
         </p:txBody>
       </p:sp>
@@ -4201,8 +4044,8 @@
 </p:sld>
 </file>
 
-<file path=ppt/slides/slide2.xml><?xml version="1.0" encoding="utf-8"?>
-<p:sld xmlns:a="http://schemas.openxmlformats.org/drawingml/2006/main" xmlns:r="http://schemas.openxmlformats.org/officeDocument/2006/relationships" xmlns:p="http://schemas.openxmlformats.org/presentationml/2006/main">
+<file path=ppt/slides/slide13.xml><?xml version="1.0" encoding="utf-8"?>
+<p:sld xmlns:a="http://schemas.openxmlformats.org/drawingml/2006/main" xmlns:p="http://schemas.openxmlformats.org/presentationml/2006/main" xmlns:r="http://schemas.openxmlformats.org/officeDocument/2006/relationships">
   <p:cSld>
     <p:bg>
       <p:bgPr>
@@ -4218,14 +4061,7 @@
         <p:cNvGrpSpPr/>
         <p:nvPr/>
       </p:nvGrpSpPr>
-      <p:grpSpPr>
-        <a:xfrm>
-          <a:off x="0" y="0"/>
-          <a:ext cx="0" cy="0"/>
-          <a:chOff x="0" y="0"/>
-          <a:chExt cx="0" cy="0"/>
-        </a:xfrm>
-      </p:grpSpPr>
+      <p:grpSpPr/>
       <p:sp>
         <p:nvSpPr>
           <p:cNvPr id="2" name="Rectangle 1"/>
@@ -4268,7 +4104,6 @@
           <a:lstStyle/>
           <a:p>
             <a:pPr algn="ctr"/>
-            <a:endParaRPr/>
           </a:p>
         </p:txBody>
       </p:sp>
@@ -4303,7 +4138,7 @@
               </a:defRPr>
             </a:pPr>
             <a:r>
-              <a:t>Introduction</a:t>
+              <a:t>What to submit ?</a:t>
             </a:r>
           </a:p>
         </p:txBody>
@@ -4316,8 +4151,8 @@
         </p:nvSpPr>
         <p:spPr>
           <a:xfrm>
-            <a:off x="992778" y="1665514"/>
-            <a:ext cx="10728655" cy="4754880"/>
+            <a:off x="731520" y="2011680"/>
+            <a:ext cx="10728655" cy="4114800"/>
           </a:xfrm>
           <a:prstGeom prst="rect">
             <a:avLst/>
@@ -4325,153 +4160,56 @@
           <a:noFill/>
         </p:spPr>
         <p:txBody>
-          <a:bodyPr wrap="square">
+          <a:bodyPr wrap="square" tIns="91440" bIns="91440">
             <a:spAutoFit/>
           </a:bodyPr>
           <a:lstStyle/>
           <a:p>
             <a:pPr>
-              <a:spcBef>
-                <a:spcPts val="800"/>
-              </a:spcBef>
-              <a:spcAft>
-                <a:spcPts val="400"/>
-              </a:spcAft>
-              <a:defRPr sz="1900" b="1">
-                <a:solidFill>
-                  <a:srgbClr val="10B981"/>
-                </a:solidFill>
-                <a:latin typeface="Arial"/>
-              </a:defRPr>
-            </a:pPr>
-            <a:r>
-              <a:rPr dirty="0"/>
-              <a:t>Nutrition &amp; Global Well-being (SDG 3):</a:t>
-            </a:r>
-          </a:p>
-          <a:p>
-            <a:pPr lvl="1">
-              <a:spcAft>
-                <a:spcPts val="400"/>
-              </a:spcAft>
-              <a:defRPr sz="1500">
-                <a:solidFill>
-                  <a:srgbClr val="475569"/>
-                </a:solidFill>
-                <a:latin typeface="Arial"/>
-              </a:defRPr>
-            </a:pPr>
-            <a:r>
-              <a:rPr dirty="0"/>
-              <a:t>Good nutrition is the cornerstone of health, vital for immune support and preventing chronic metabolic diseases.</a:t>
-            </a:r>
-          </a:p>
-          <a:p>
-            <a:pPr lvl="1">
-              <a:spcAft>
-                <a:spcPts val="400"/>
-              </a:spcAft>
-              <a:defRPr sz="1500">
-                <a:solidFill>
-                  <a:srgbClr val="475569"/>
-                </a:solidFill>
-                <a:latin typeface="Arial"/>
-              </a:defRPr>
-            </a:pPr>
-            <a:r>
-              <a:rPr dirty="0"/>
-              <a:t>Poor dietary choices lead to severe long-term health complications globally, impacting quality of life.</a:t>
+              <a:spcAft>
+                <a:spcPts val="2000"/>
+              </a:spcAft>
+              <a:defRPr sz="2600" b="1">
+                <a:solidFill>
+                  <a:srgbClr val="0F172A"/>
+                </a:solidFill>
+                <a:latin typeface="Arial"/>
+              </a:defRPr>
+            </a:pPr>
+            <a:r>
+              <a:t>• Lean Canvas PDF</a:t>
             </a:r>
           </a:p>
           <a:p>
             <a:pPr>
-              <a:spcBef>
-                <a:spcPts val="800"/>
-              </a:spcBef>
-              <a:spcAft>
-                <a:spcPts val="400"/>
-              </a:spcAft>
-              <a:defRPr sz="1900" b="1">
-                <a:solidFill>
-                  <a:srgbClr val="10B981"/>
-                </a:solidFill>
-                <a:latin typeface="Arial"/>
-              </a:defRPr>
-            </a:pPr>
-            <a:r>
-              <a:rPr dirty="0"/>
-              <a:t>Current Challenges in Dietary Tracking:</a:t>
-            </a:r>
-          </a:p>
-          <a:p>
-            <a:pPr lvl="1">
-              <a:spcAft>
-                <a:spcPts val="400"/>
-              </a:spcAft>
-              <a:defRPr sz="1500">
-                <a:solidFill>
-                  <a:srgbClr val="475569"/>
-                </a:solidFill>
-                <a:latin typeface="Arial"/>
-              </a:defRPr>
-            </a:pPr>
-            <a:r>
-              <a:rPr dirty="0"/>
-              <a:t>Traditional meal logging relies on manual entry, leading to high friction, under-reporting, and mental fatigue.</a:t>
-            </a:r>
-          </a:p>
-          <a:p>
-            <a:pPr lvl="1">
-              <a:spcAft>
-                <a:spcPts val="400"/>
-              </a:spcAft>
-              <a:defRPr sz="1500">
-                <a:solidFill>
-                  <a:srgbClr val="475569"/>
-                </a:solidFill>
-                <a:latin typeface="Arial"/>
-              </a:defRPr>
-            </a:pPr>
-            <a:r>
-              <a:rPr dirty="0"/>
-              <a:t>Static apps track history but fail to offer proactive, customized, and context-aware suggestions.</a:t>
+              <a:spcAft>
+                <a:spcPts val="2000"/>
+              </a:spcAft>
+              <a:defRPr sz="2600" b="1">
+                <a:solidFill>
+                  <a:srgbClr val="0F172A"/>
+                </a:solidFill>
+                <a:latin typeface="Arial"/>
+              </a:defRPr>
+            </a:pPr>
+            <a:r>
+              <a:t>• Concept Note</a:t>
             </a:r>
           </a:p>
           <a:p>
             <a:pPr>
-              <a:spcBef>
-                <a:spcPts val="800"/>
-              </a:spcBef>
-              <a:spcAft>
-                <a:spcPts val="400"/>
-              </a:spcAft>
-              <a:defRPr sz="1900" b="1">
-                <a:solidFill>
-                  <a:srgbClr val="10B981"/>
-                </a:solidFill>
-                <a:latin typeface="Arial"/>
-              </a:defRPr>
-            </a:pPr>
-            <a:r>
-              <a:rPr dirty="0"/>
-              <a:t>Potential Solution via Agentic AI:</a:t>
-            </a:r>
-          </a:p>
-          <a:p>
-            <a:pPr lvl="1">
-              <a:spcAft>
-                <a:spcPts val="400"/>
-              </a:spcAft>
-              <a:defRPr sz="1500">
-                <a:solidFill>
-                  <a:srgbClr val="475569"/>
-                </a:solidFill>
-                <a:latin typeface="Arial"/>
-              </a:defRPr>
-            </a:pPr>
-            <a:r>
-              <a:rPr dirty="0"/>
-              <a:t>Transition from passive logs to active agents that handle metric extraction, recipe design, and scheduling autonomously.</a:t>
+              <a:spcAft>
+                <a:spcPts val="2000"/>
+              </a:spcAft>
+              <a:defRPr sz="2600" b="1">
+                <a:solidFill>
+                  <a:srgbClr val="0F172A"/>
+                </a:solidFill>
+                <a:latin typeface="Arial"/>
+              </a:defRPr>
+            </a:pPr>
+            <a:r>
+              <a:t>• Power point Presentation</a:t>
             </a:r>
           </a:p>
         </p:txBody>
@@ -4484,8 +4222,8 @@
 </p:sld>
 </file>
 
-<file path=ppt/slides/slide3.xml><?xml version="1.0" encoding="utf-8"?>
-<p:sld xmlns:a="http://schemas.openxmlformats.org/drawingml/2006/main" xmlns:r="http://schemas.openxmlformats.org/officeDocument/2006/relationships" xmlns:p="http://schemas.openxmlformats.org/presentationml/2006/main">
+<file path=ppt/slides/slide2.xml><?xml version="1.0" encoding="utf-8"?>
+<p:sld xmlns:a="http://schemas.openxmlformats.org/drawingml/2006/main" xmlns:p="http://schemas.openxmlformats.org/presentationml/2006/main" xmlns:r="http://schemas.openxmlformats.org/officeDocument/2006/relationships">
   <p:cSld>
     <p:bg>
       <p:bgPr>
@@ -4501,14 +4239,7 @@
         <p:cNvGrpSpPr/>
         <p:nvPr/>
       </p:nvGrpSpPr>
-      <p:grpSpPr>
-        <a:xfrm>
-          <a:off x="0" y="0"/>
-          <a:ext cx="0" cy="0"/>
-          <a:chOff x="0" y="0"/>
-          <a:chExt cx="0" cy="0"/>
-        </a:xfrm>
-      </p:grpSpPr>
+      <p:grpSpPr/>
       <p:sp>
         <p:nvSpPr>
           <p:cNvPr id="2" name="Rectangle 1"/>
@@ -4551,7 +4282,6 @@
           <a:lstStyle/>
           <a:p>
             <a:pPr algn="ctr"/>
-            <a:endParaRPr/>
           </a:p>
         </p:txBody>
       </p:sp>
@@ -4586,7 +4316,7 @@
               </a:defRPr>
             </a:pPr>
             <a:r>
-              <a:t>Problem Statement</a:t>
+              <a:t>Introduction</a:t>
             </a:r>
           </a:p>
         </p:txBody>
@@ -4628,7 +4358,7 @@
               </a:defRPr>
             </a:pPr>
             <a:r>
-              <a:t>The Objective:</a:t>
+              <a:t>Nutrition &amp; Global Well-being (SDG 3):</a:t>
             </a:r>
           </a:p>
           <a:p>
@@ -4644,7 +4374,23 @@
               </a:defRPr>
             </a:pPr>
             <a:r>
-              <a:t>Build an autonomous machine learning-driven nutritional agent capable of predicting optimal calorie/macro requirements and planning complete daily meal structures dynamically based on user physical metrics.</a:t>
+              <a:t>Good nutrition is the cornerstone of health, vital for immune support and preventing chronic metabolic diseases.</a:t>
+            </a:r>
+          </a:p>
+          <a:p>
+            <a:pPr lvl="1">
+              <a:spcAft>
+                <a:spcPts val="400"/>
+              </a:spcAft>
+              <a:defRPr sz="1500">
+                <a:solidFill>
+                  <a:srgbClr val="475569"/>
+                </a:solidFill>
+                <a:latin typeface="Arial"/>
+              </a:defRPr>
+            </a:pPr>
+            <a:r>
+              <a:t>Poor dietary choices lead to severe long-term health complications globally, impacting quality of life.</a:t>
             </a:r>
           </a:p>
           <a:p>
@@ -4663,7 +4409,7 @@
               </a:defRPr>
             </a:pPr>
             <a:r>
-              <a:t>Specific Goals &amp; Technical Scopes:</a:t>
+              <a:t>Current Challenges in Dietary Tracking:</a:t>
             </a:r>
           </a:p>
           <a:p>
@@ -4679,7 +4425,7 @@
               </a:defRPr>
             </a:pPr>
             <a:r>
-              <a:t>• Automate user metric data collection (Age, Weight, Goal, Restrictions).</a:t>
+              <a:t>Traditional meal logging relies on manual entry, leading to high friction, under-reporting, and mental fatigue.</a:t>
             </a:r>
           </a:p>
           <a:p>
@@ -4695,7 +4441,26 @@
               </a:defRPr>
             </a:pPr>
             <a:r>
-              <a:t>• Implement a structured state machine using LangGraph to guarantee sequential, reliable outputs.</a:t>
+              <a:t>Static apps track history but fail to offer proactive, customized, and context-aware suggestions.</a:t>
+            </a:r>
+          </a:p>
+          <a:p>
+            <a:pPr>
+              <a:spcBef>
+                <a:spcPts val="800"/>
+              </a:spcBef>
+              <a:spcAft>
+                <a:spcPts val="400"/>
+              </a:spcAft>
+              <a:defRPr sz="1900" b="1">
+                <a:solidFill>
+                  <a:srgbClr val="10B981"/>
+                </a:solidFill>
+                <a:latin typeface="Arial"/>
+              </a:defRPr>
+            </a:pPr>
+            <a:r>
+              <a:t>Potential Solution via Agentic AI:</a:t>
             </a:r>
           </a:p>
           <a:p>
@@ -4711,23 +4476,7 @@
               </a:defRPr>
             </a:pPr>
             <a:r>
-              <a:t>• Design an Extraction Node that translates profile data into nutrient-dense, calorie-appropriate recipes.</a:t>
-            </a:r>
-          </a:p>
-          <a:p>
-            <a:pPr lvl="1">
-              <a:spcAft>
-                <a:spcPts val="400"/>
-              </a:spcAft>
-              <a:defRPr sz="1500">
-                <a:solidFill>
-                  <a:srgbClr val="475569"/>
-                </a:solidFill>
-                <a:latin typeface="Arial"/>
-              </a:defRPr>
-            </a:pPr>
-            <a:r>
-              <a:t>• Design a Formatting Node to parse raw LLM output into readable tables and checklists for end-users.</a:t>
+              <a:t>Transition from passive logs to active agents that handle metric extraction, recipe design, and scheduling autonomously.</a:t>
             </a:r>
           </a:p>
         </p:txBody>
@@ -4740,8 +4489,8 @@
 </p:sld>
 </file>
 
-<file path=ppt/slides/slide4.xml><?xml version="1.0" encoding="utf-8"?>
-<p:sld xmlns:a="http://schemas.openxmlformats.org/drawingml/2006/main" xmlns:r="http://schemas.openxmlformats.org/officeDocument/2006/relationships" xmlns:p="http://schemas.openxmlformats.org/presentationml/2006/main">
+<file path=ppt/slides/slide3.xml><?xml version="1.0" encoding="utf-8"?>
+<p:sld xmlns:a="http://schemas.openxmlformats.org/drawingml/2006/main" xmlns:p="http://schemas.openxmlformats.org/presentationml/2006/main" xmlns:r="http://schemas.openxmlformats.org/officeDocument/2006/relationships">
   <p:cSld>
     <p:bg>
       <p:bgPr>
@@ -4757,14 +4506,7 @@
         <p:cNvGrpSpPr/>
         <p:nvPr/>
       </p:nvGrpSpPr>
-      <p:grpSpPr>
-        <a:xfrm>
-          <a:off x="0" y="0"/>
-          <a:ext cx="0" cy="0"/>
-          <a:chOff x="0" y="0"/>
-          <a:chExt cx="0" cy="0"/>
-        </a:xfrm>
-      </p:grpSpPr>
+      <p:grpSpPr/>
       <p:sp>
         <p:nvSpPr>
           <p:cNvPr id="2" name="Rectangle 1"/>
@@ -4807,7 +4549,6 @@
           <a:lstStyle/>
           <a:p>
             <a:pPr algn="ctr"/>
-            <a:endParaRPr/>
           </a:p>
         </p:txBody>
       </p:sp>
@@ -4842,7 +4583,7 @@
               </a:defRPr>
             </a:pPr>
             <a:r>
-              <a:t>Data Collection &amp; Feature Engineering</a:t>
+              <a:t>Problem Statement</a:t>
             </a:r>
           </a:p>
         </p:txBody>
@@ -4884,7 +4625,7 @@
               </a:defRPr>
             </a:pPr>
             <a:r>
-              <a:t>User Metrics and Profile Data Collection:</a:t>
+              <a:t>The Objective:</a:t>
             </a:r>
           </a:p>
           <a:p>
@@ -4900,23 +4641,7 @@
               </a:defRPr>
             </a:pPr>
             <a:r>
-              <a:t>Physical inputs gathered in real-time from the UI: Age (years), Weight (kg), Fitness Goal, and Dietary Restrictions.</a:t>
-            </a:r>
-          </a:p>
-          <a:p>
-            <a:pPr lvl="1">
-              <a:spcAft>
-                <a:spcPts val="400"/>
-              </a:spcAft>
-              <a:defRPr sz="1500">
-                <a:solidFill>
-                  <a:srgbClr val="475569"/>
-                </a:solidFill>
-                <a:latin typeface="Arial"/>
-              </a:defRPr>
-            </a:pPr>
-            <a:r>
-              <a:t>No personal identifier data is captured, ensuring complete alignment with privacy-by-design guidelines.</a:t>
+              <a:t>Build an autonomous machine learning-driven nutritional agent capable of predicting optimal calorie/macro requirements and planning complete daily meal structures dynamically based on user physical metrics.</a:t>
             </a:r>
           </a:p>
           <a:p>
@@ -4935,7 +4660,7 @@
               </a:defRPr>
             </a:pPr>
             <a:r>
-              <a:t>Feature Preprocessing &amp; Profile Engineering:</a:t>
+              <a:t>Specific Goals &amp; Technical Scopes:</a:t>
             </a:r>
           </a:p>
           <a:p>
@@ -4951,7 +4676,7 @@
               </a:defRPr>
             </a:pPr>
             <a:r>
-              <a:t>Inputs are validated at the frontend (e.g., preventing negative weights or ages).</a:t>
+              <a:t>• Automate user metric data collection (Age, Weight, Goal, Restrictions).</a:t>
             </a:r>
           </a:p>
           <a:p>
@@ -4967,7 +4692,7 @@
               </a:defRPr>
             </a:pPr>
             <a:r>
-              <a:t>Data is parsed and structured into a LangGraph TypedDict (AgentState) representing the feature vector.</a:t>
+              <a:t>• Implement a structured state machine using LangGraph to guarantee sequential, reliable outputs.</a:t>
             </a:r>
           </a:p>
           <a:p>
@@ -4983,7 +4708,23 @@
               </a:defRPr>
             </a:pPr>
             <a:r>
-              <a:t>Dietary restrictions and allergies are engineered into direct system prompts to constrain recipe suggestions.</a:t>
+              <a:t>• Design an Extraction Node that translates profile data into nutrient-dense, calorie-appropriate recipes.</a:t>
+            </a:r>
+          </a:p>
+          <a:p>
+            <a:pPr lvl="1">
+              <a:spcAft>
+                <a:spcPts val="400"/>
+              </a:spcAft>
+              <a:defRPr sz="1500">
+                <a:solidFill>
+                  <a:srgbClr val="475569"/>
+                </a:solidFill>
+                <a:latin typeface="Arial"/>
+              </a:defRPr>
+            </a:pPr>
+            <a:r>
+              <a:t>• Design a Formatting Node to parse raw LLM output into readable tables and checklists for end-users.</a:t>
             </a:r>
           </a:p>
         </p:txBody>
@@ -4996,8 +4737,8 @@
 </p:sld>
 </file>
 
-<file path=ppt/slides/slide5.xml><?xml version="1.0" encoding="utf-8"?>
-<p:sld xmlns:a="http://schemas.openxmlformats.org/drawingml/2006/main" xmlns:r="http://schemas.openxmlformats.org/officeDocument/2006/relationships" xmlns:p="http://schemas.openxmlformats.org/presentationml/2006/main">
+<file path=ppt/slides/slide4.xml><?xml version="1.0" encoding="utf-8"?>
+<p:sld xmlns:a="http://schemas.openxmlformats.org/drawingml/2006/main" xmlns:p="http://schemas.openxmlformats.org/presentationml/2006/main" xmlns:r="http://schemas.openxmlformats.org/officeDocument/2006/relationships">
   <p:cSld>
     <p:bg>
       <p:bgPr>
@@ -5013,14 +4754,7 @@
         <p:cNvGrpSpPr/>
         <p:nvPr/>
       </p:nvGrpSpPr>
-      <p:grpSpPr>
-        <a:xfrm>
-          <a:off x="0" y="0"/>
-          <a:ext cx="0" cy="0"/>
-          <a:chOff x="0" y="0"/>
-          <a:chExt cx="0" cy="0"/>
-        </a:xfrm>
-      </p:grpSpPr>
+      <p:grpSpPr/>
       <p:sp>
         <p:nvSpPr>
           <p:cNvPr id="2" name="Rectangle 1"/>
@@ -5063,7 +4797,6 @@
           <a:lstStyle/>
           <a:p>
             <a:pPr algn="ctr"/>
-            <a:endParaRPr/>
           </a:p>
         </p:txBody>
       </p:sp>
@@ -5098,7 +4831,7 @@
               </a:defRPr>
             </a:pPr>
             <a:r>
-              <a:t>Model Development</a:t>
+              <a:t>Data Collection &amp; Feature Engineering</a:t>
             </a:r>
           </a:p>
         </p:txBody>
@@ -5140,7 +4873,7 @@
               </a:defRPr>
             </a:pPr>
             <a:r>
-              <a:t>Algorithm &amp; Framework Architecture:</a:t>
+              <a:t>User Metrics and Profile Data Collection:</a:t>
             </a:r>
           </a:p>
           <a:p>
@@ -5156,7 +4889,7 @@
               </a:defRPr>
             </a:pPr>
             <a:r>
-              <a:t>• LangGraph Framework: Orchestrates state management via a sequential StateGraph.</a:t>
+              <a:t>Physical inputs gathered in real-time from the UI: Age (years), Weight (kg), Fitness Goal, and Dietary Restrictions.</a:t>
             </a:r>
           </a:p>
           <a:p>
@@ -5172,23 +4905,7 @@
               </a:defRPr>
             </a:pPr>
             <a:r>
-              <a:t>• Extraction Node: Connects LangChain to the Groq API utilizing the llama-3.3-70b-versatile model for clinical-grade diet design.</a:t>
-            </a:r>
-          </a:p>
-          <a:p>
-            <a:pPr lvl="1">
-              <a:spcAft>
-                <a:spcPts val="400"/>
-              </a:spcAft>
-              <a:defRPr sz="1500">
-                <a:solidFill>
-                  <a:srgbClr val="475569"/>
-                </a:solidFill>
-                <a:latin typeface="Arial"/>
-              </a:defRPr>
-            </a:pPr>
-            <a:r>
-              <a:t>• Formatting Node: Employs a low-temperature model configuration (Temp=0.2) to structure outputs reliably.</a:t>
+              <a:t>No personal identifier data is captured, ensuring complete alignment with privacy-by-design guidelines.</a:t>
             </a:r>
           </a:p>
           <a:p>
@@ -5207,7 +4924,7 @@
               </a:defRPr>
             </a:pPr>
             <a:r>
-              <a:t>Parameter Tuning &amp; Constraints:</a:t>
+              <a:t>Feature Preprocessing &amp; Profile Engineering:</a:t>
             </a:r>
           </a:p>
           <a:p>
@@ -5223,7 +4940,7 @@
               </a:defRPr>
             </a:pPr>
             <a:r>
-              <a:t>• Temperature tuning: Extraction Node is set to Temp=0.5 for culinary variety; Formatting Node is set to Temp=0.2 for structure.</a:t>
+              <a:t>Inputs are validated at the frontend (e.g., preventing negative weights or ages).</a:t>
             </a:r>
           </a:p>
           <a:p>
@@ -5239,7 +4956,23 @@
               </a:defRPr>
             </a:pPr>
             <a:r>
-              <a:t>• System prompt optimization dictates strict obedience to calorie constraints and dietary allergy exclusions.</a:t>
+              <a:t>Data is parsed and structured into a LangGraph TypedDict (AgentState) representing the feature vector.</a:t>
+            </a:r>
+          </a:p>
+          <a:p>
+            <a:pPr lvl="1">
+              <a:spcAft>
+                <a:spcPts val="400"/>
+              </a:spcAft>
+              <a:defRPr sz="1500">
+                <a:solidFill>
+                  <a:srgbClr val="475569"/>
+                </a:solidFill>
+                <a:latin typeface="Arial"/>
+              </a:defRPr>
+            </a:pPr>
+            <a:r>
+              <a:t>Dietary restrictions and allergies are engineered into direct system prompts to constrain recipe suggestions.</a:t>
             </a:r>
           </a:p>
         </p:txBody>
@@ -5252,8 +4985,8 @@
 </p:sld>
 </file>
 
-<file path=ppt/slides/slide6.xml><?xml version="1.0" encoding="utf-8"?>
-<p:sld xmlns:a="http://schemas.openxmlformats.org/drawingml/2006/main" xmlns:r="http://schemas.openxmlformats.org/officeDocument/2006/relationships" xmlns:p="http://schemas.openxmlformats.org/presentationml/2006/main">
+<file path=ppt/slides/slide5.xml><?xml version="1.0" encoding="utf-8"?>
+<p:sld xmlns:a="http://schemas.openxmlformats.org/drawingml/2006/main" xmlns:p="http://schemas.openxmlformats.org/presentationml/2006/main" xmlns:r="http://schemas.openxmlformats.org/officeDocument/2006/relationships">
   <p:cSld>
     <p:bg>
       <p:bgPr>
@@ -5269,14 +5002,7 @@
         <p:cNvGrpSpPr/>
         <p:nvPr/>
       </p:nvGrpSpPr>
-      <p:grpSpPr>
-        <a:xfrm>
-          <a:off x="0" y="0"/>
-          <a:ext cx="0" cy="0"/>
-          <a:chOff x="0" y="0"/>
-          <a:chExt cx="0" cy="0"/>
-        </a:xfrm>
-      </p:grpSpPr>
+      <p:grpSpPr/>
       <p:sp>
         <p:nvSpPr>
           <p:cNvPr id="2" name="Rectangle 1"/>
@@ -5319,7 +5045,6 @@
           <a:lstStyle/>
           <a:p>
             <a:pPr algn="ctr"/>
-            <a:endParaRPr/>
           </a:p>
         </p:txBody>
       </p:sp>
@@ -5354,7 +5079,7 @@
               </a:defRPr>
             </a:pPr>
             <a:r>
-              <a:t>Model Evaluation</a:t>
+              <a:t>Model Development</a:t>
             </a:r>
           </a:p>
         </p:txBody>
@@ -5396,7 +5121,7 @@
               </a:defRPr>
             </a:pPr>
             <a:r>
-              <a:t>Key Evaluation Metrics:</a:t>
+              <a:t>Algorithm &amp; Framework Architecture:</a:t>
             </a:r>
           </a:p>
           <a:p>
@@ -5412,7 +5137,7 @@
               </a:defRPr>
             </a:pPr>
             <a:r>
-              <a:t>• Execution Speed (Latency): Assessed using millisecond response times of the LangGraph pipeline via Groq API.</a:t>
+              <a:t>• LangGraph Framework: Orchestrates state management via a sequential StateGraph.</a:t>
             </a:r>
           </a:p>
           <a:p>
@@ -5428,7 +5153,7 @@
               </a:defRPr>
             </a:pPr>
             <a:r>
-              <a:t>• Parsing &amp; Formatting Accuracy: Validating if output tables conform perfectly to Markdown standards.</a:t>
+              <a:t>• Extraction Node: Connects LangChain to the Groq API utilizing the llama-3.3-70b-versatile model for clinical-grade diet design.</a:t>
             </a:r>
           </a:p>
           <a:p>
@@ -5444,7 +5169,7 @@
               </a:defRPr>
             </a:pPr>
             <a:r>
-              <a:t>• Dietary Safety Compliance: Confirming that flagged allergies (e.g. Gluten-Free) are never present in output ingredients.</a:t>
+              <a:t>• Formatting Node: Employs a low-temperature model configuration (Temp=0.2) to structure outputs reliably.</a:t>
             </a:r>
           </a:p>
           <a:p>
@@ -5463,7 +5188,7 @@
               </a:defRPr>
             </a:pPr>
             <a:r>
-              <a:t>Performance Comparison &amp; Robustness:</a:t>
+              <a:t>Parameter Tuning &amp; Constraints:</a:t>
             </a:r>
           </a:p>
           <a:p>
@@ -5479,7 +5204,7 @@
               </a:defRPr>
             </a:pPr>
             <a:r>
-              <a:t>• Evaluated against traditional single-prompt ChatBots; LangGraph shows 100% adherence to Markdown output layouts.</a:t>
+              <a:t>• Temperature tuning: Extraction Node is set to Temp=0.5 for culinary variety; Formatting Node is set to Temp=0.2 for structure.</a:t>
             </a:r>
           </a:p>
           <a:p>
@@ -5495,7 +5220,7 @@
               </a:defRPr>
             </a:pPr>
             <a:r>
-              <a:t>• Demonstrates strong robustness when tested with highly complex allergy profiles (e.g., Vegan + Nut Allergy + Gluten-Free).</a:t>
+              <a:t>• System prompt optimization dictates strict obedience to calorie constraints and dietary allergy exclusions.</a:t>
             </a:r>
           </a:p>
         </p:txBody>
@@ -5508,8 +5233,8 @@
 </p:sld>
 </file>
 
-<file path=ppt/slides/slide7.xml><?xml version="1.0" encoding="utf-8"?>
-<p:sld xmlns:a="http://schemas.openxmlformats.org/drawingml/2006/main" xmlns:r="http://schemas.openxmlformats.org/officeDocument/2006/relationships" xmlns:p="http://schemas.openxmlformats.org/presentationml/2006/main">
+<file path=ppt/slides/slide6.xml><?xml version="1.0" encoding="utf-8"?>
+<p:sld xmlns:a="http://schemas.openxmlformats.org/drawingml/2006/main" xmlns:p="http://schemas.openxmlformats.org/presentationml/2006/main" xmlns:r="http://schemas.openxmlformats.org/officeDocument/2006/relationships">
   <p:cSld>
     <p:bg>
       <p:bgPr>
@@ -5525,14 +5250,7 @@
         <p:cNvGrpSpPr/>
         <p:nvPr/>
       </p:nvGrpSpPr>
-      <p:grpSpPr>
-        <a:xfrm>
-          <a:off x="0" y="0"/>
-          <a:ext cx="0" cy="0"/>
-          <a:chOff x="0" y="0"/>
-          <a:chExt cx="0" cy="0"/>
-        </a:xfrm>
-      </p:grpSpPr>
+      <p:grpSpPr/>
       <p:sp>
         <p:nvSpPr>
           <p:cNvPr id="2" name="Rectangle 1"/>
@@ -5575,7 +5293,6 @@
           <a:lstStyle/>
           <a:p>
             <a:pPr algn="ctr"/>
-            <a:endParaRPr/>
           </a:p>
         </p:txBody>
       </p:sp>
@@ -5610,7 +5327,7 @@
               </a:defRPr>
             </a:pPr>
             <a:r>
-              <a:t>Tools and Resources</a:t>
+              <a:t>Model Evaluation</a:t>
             </a:r>
           </a:p>
         </p:txBody>
@@ -5652,7 +5369,7 @@
               </a:defRPr>
             </a:pPr>
             <a:r>
-              <a:t>Core Development Stack:</a:t>
+              <a:t>Key Evaluation Metrics:</a:t>
             </a:r>
           </a:p>
           <a:p>
@@ -5668,7 +5385,7 @@
               </a:defRPr>
             </a:pPr>
             <a:r>
-              <a:t>Python: Primary programming language for LangGraph state machine, data processing, and asset generation.</a:t>
+              <a:t>• Execution Speed (Latency): Assessed using millisecond response times of the LangGraph pipeline via Groq API.</a:t>
             </a:r>
           </a:p>
           <a:p>
@@ -5684,7 +5401,7 @@
               </a:defRPr>
             </a:pPr>
             <a:r>
-              <a:t>Streamlit: Open-source app framework for building interactive user dashboards.</a:t>
+              <a:t>• Parsing &amp; Formatting Accuracy: Validating if output tables conform perfectly to Markdown standards.</a:t>
             </a:r>
           </a:p>
           <a:p>
@@ -5700,7 +5417,7 @@
               </a:defRPr>
             </a:pPr>
             <a:r>
-              <a:t>LangGraph &amp; LangChain: Core agentic orchestration SDKs.</a:t>
+              <a:t>• Dietary Safety Compliance: Confirming that flagged allergies (e.g. Gluten-Free) are never present in output ingredients.</a:t>
             </a:r>
           </a:p>
           <a:p>
@@ -5719,7 +5436,7 @@
               </a:defRPr>
             </a:pPr>
             <a:r>
-              <a:t>IBM Cloud &amp; Watson Studio Integration Concepts:</a:t>
+              <a:t>Performance Comparison &amp; Robustness:</a:t>
             </a:r>
           </a:p>
           <a:p>
@@ -5735,7 +5452,7 @@
               </a:defRPr>
             </a:pPr>
             <a:r>
-              <a:t>• IBM Cloud Object Storage: Ideal for persisting long-term user logs and recipe history databases.</a:t>
+              <a:t>• Evaluated against traditional single-prompt ChatBots; LangGraph shows 100% adherence to Markdown output layouts.</a:t>
             </a:r>
           </a:p>
           <a:p>
@@ -5751,23 +5468,7 @@
               </a:defRPr>
             </a:pPr>
             <a:r>
-              <a:t>• IBM Watson Studio: Excellent environment to train custom nutrition regression models (predicting exact BMR).</a:t>
-            </a:r>
-          </a:p>
-          <a:p>
-            <a:pPr lvl="1">
-              <a:spcAft>
-                <a:spcPts val="400"/>
-              </a:spcAft>
-              <a:defRPr sz="1500">
-                <a:solidFill>
-                  <a:srgbClr val="475569"/>
-                </a:solidFill>
-                <a:latin typeface="Arial"/>
-              </a:defRPr>
-            </a:pPr>
-            <a:r>
-              <a:t>• IBM Cloud Foundry / Code Engine: Hosting Streamlit application server for high-availability production deployment.</a:t>
+              <a:t>• Demonstrates strong robustness when tested with highly complex allergy profiles (e.g., Vegan + Nut Allergy + Gluten-Free).</a:t>
             </a:r>
           </a:p>
         </p:txBody>
@@ -5780,8 +5481,8 @@
 </p:sld>
 </file>
 
-<file path=ppt/slides/slide8.xml><?xml version="1.0" encoding="utf-8"?>
-<p:sld xmlns:a="http://schemas.openxmlformats.org/drawingml/2006/main" xmlns:r="http://schemas.openxmlformats.org/officeDocument/2006/relationships" xmlns:p="http://schemas.openxmlformats.org/presentationml/2006/main">
+<file path=ppt/slides/slide7.xml><?xml version="1.0" encoding="utf-8"?>
+<p:sld xmlns:a="http://schemas.openxmlformats.org/drawingml/2006/main" xmlns:p="http://schemas.openxmlformats.org/presentationml/2006/main" xmlns:r="http://schemas.openxmlformats.org/officeDocument/2006/relationships">
   <p:cSld>
     <p:bg>
       <p:bgPr>
@@ -5797,14 +5498,7 @@
         <p:cNvGrpSpPr/>
         <p:nvPr/>
       </p:nvGrpSpPr>
-      <p:grpSpPr>
-        <a:xfrm>
-          <a:off x="0" y="0"/>
-          <a:ext cx="0" cy="0"/>
-          <a:chOff x="0" y="0"/>
-          <a:chExt cx="0" cy="0"/>
-        </a:xfrm>
-      </p:grpSpPr>
+      <p:grpSpPr/>
       <p:sp>
         <p:nvSpPr>
           <p:cNvPr id="2" name="Rectangle 1"/>
@@ -5847,7 +5541,6 @@
           <a:lstStyle/>
           <a:p>
             <a:pPr algn="ctr"/>
-            <a:endParaRPr/>
           </a:p>
         </p:txBody>
       </p:sp>
@@ -5882,7 +5575,7 @@
               </a:defRPr>
             </a:pPr>
             <a:r>
-              <a:t>Model Impact and Effectiveness</a:t>
+              <a:t>Tools and Resources</a:t>
             </a:r>
           </a:p>
         </p:txBody>
@@ -5924,7 +5617,7 @@
               </a:defRPr>
             </a:pPr>
             <a:r>
-              <a:t>SDG 3 Core Problem Solving:</a:t>
+              <a:t>Core Development Stack:</a:t>
             </a:r>
           </a:p>
           <a:p>
@@ -5940,7 +5633,39 @@
               </a:defRPr>
             </a:pPr>
             <a:r>
-              <a:t>Offers instant, reliable nutritional templates to users, eliminating barrier of cost for consulting dietitians.</a:t>
+              <a:t>Python: Primary programming language for LangGraph state machine, data processing, and asset generation.</a:t>
+            </a:r>
+          </a:p>
+          <a:p>
+            <a:pPr lvl="1">
+              <a:spcAft>
+                <a:spcPts val="400"/>
+              </a:spcAft>
+              <a:defRPr sz="1500">
+                <a:solidFill>
+                  <a:srgbClr val="475569"/>
+                </a:solidFill>
+                <a:latin typeface="Arial"/>
+              </a:defRPr>
+            </a:pPr>
+            <a:r>
+              <a:t>Streamlit: Open-source app framework for building interactive user dashboards.</a:t>
+            </a:r>
+          </a:p>
+          <a:p>
+            <a:pPr lvl="1">
+              <a:spcAft>
+                <a:spcPts val="400"/>
+              </a:spcAft>
+              <a:defRPr sz="1500">
+                <a:solidFill>
+                  <a:srgbClr val="475569"/>
+                </a:solidFill>
+                <a:latin typeface="Arial"/>
+              </a:defRPr>
+            </a:pPr>
+            <a:r>
+              <a:t>LangGraph &amp; LangChain: Core agentic orchestration SDKs.</a:t>
             </a:r>
           </a:p>
           <a:p>
@@ -5959,7 +5684,7 @@
               </a:defRPr>
             </a:pPr>
             <a:r>
-              <a:t>Preventative Health Management:</a:t>
+              <a:t>IBM Cloud &amp; Watson Studio Integration Concepts:</a:t>
             </a:r>
           </a:p>
           <a:p>
@@ -5975,7 +5700,7 @@
               </a:defRPr>
             </a:pPr>
             <a:r>
-              <a:t>Encourages conscious meal planning, assisting in early intervention and mitigation of diabetes and obesity.</a:t>
+              <a:t>• IBM Cloud Object Storage: Ideal for persisting long-term user logs and recipe history databases.</a:t>
             </a:r>
           </a:p>
           <a:p>
@@ -5991,33 +5716,14 @@
               </a:defRPr>
             </a:pPr>
             <a:r>
-              <a:t>Non-Invasive: Entirely software-based, requiring only simple metabolic inputs from the user.</a:t>
-            </a:r>
-          </a:p>
-          <a:p>
-            <a:pPr>
-              <a:spcBef>
-                <a:spcPts val="800"/>
-              </a:spcBef>
+              <a:t>• IBM Watson Studio: Excellent environment to train custom nutrition regression models (predicting exact BMR).</a:t>
+            </a:r>
+          </a:p>
+          <a:p>
+            <a:pPr lvl="1">
               <a:spcAft>
                 <a:spcPts val="400"/>
               </a:spcAft>
-              <a:defRPr sz="1900" b="1">
-                <a:solidFill>
-                  <a:srgbClr val="10B981"/>
-                </a:solidFill>
-                <a:latin typeface="Arial"/>
-              </a:defRPr>
-            </a:pPr>
-            <a:r>
-              <a:t>Scalability:</a:t>
-            </a:r>
-          </a:p>
-          <a:p>
-            <a:pPr lvl="1">
-              <a:spcAft>
-                <a:spcPts val="400"/>
-              </a:spcAft>
               <a:defRPr sz="1500">
                 <a:solidFill>
                   <a:srgbClr val="475569"/>
@@ -6026,7 +5732,7 @@
               </a:defRPr>
             </a:pPr>
             <a:r>
-              <a:t>Highly scalable architecture capable of supporting thousands of simultaneous requests via Groq's high-speed API.</a:t>
+              <a:t>• IBM Cloud Foundry / Code Engine: Hosting Streamlit application server for high-availability production deployment.</a:t>
             </a:r>
           </a:p>
         </p:txBody>
@@ -6039,8 +5745,8 @@
 </p:sld>
 </file>
 
-<file path=ppt/slides/slide9.xml><?xml version="1.0" encoding="utf-8"?>
-<p:sld xmlns:a="http://schemas.openxmlformats.org/drawingml/2006/main" xmlns:r="http://schemas.openxmlformats.org/officeDocument/2006/relationships" xmlns:p="http://schemas.openxmlformats.org/presentationml/2006/main">
+<file path=ppt/slides/slide8.xml><?xml version="1.0" encoding="utf-8"?>
+<p:sld xmlns:a="http://schemas.openxmlformats.org/drawingml/2006/main" xmlns:p="http://schemas.openxmlformats.org/presentationml/2006/main" xmlns:r="http://schemas.openxmlformats.org/officeDocument/2006/relationships">
   <p:cSld>
     <p:bg>
       <p:bgPr>
@@ -6056,14 +5762,7 @@
         <p:cNvGrpSpPr/>
         <p:nvPr/>
       </p:nvGrpSpPr>
-      <p:grpSpPr>
-        <a:xfrm>
-          <a:off x="0" y="0"/>
-          <a:ext cx="0" cy="0"/>
-          <a:chOff x="0" y="0"/>
-          <a:chExt cx="0" cy="0"/>
-        </a:xfrm>
-      </p:grpSpPr>
+      <p:grpSpPr/>
       <p:sp>
         <p:nvSpPr>
           <p:cNvPr id="2" name="Rectangle 1"/>
@@ -6106,7 +5805,257 @@
           <a:lstStyle/>
           <a:p>
             <a:pPr algn="ctr"/>
-            <a:endParaRPr/>
+          </a:p>
+        </p:txBody>
+      </p:sp>
+      <p:sp>
+        <p:nvSpPr>
+          <p:cNvPr id="3" name="TextBox 2"/>
+          <p:cNvSpPr txBox="1"/>
+          <p:nvPr/>
+        </p:nvSpPr>
+        <p:spPr>
+          <a:xfrm>
+            <a:off x="731520" y="137160"/>
+            <a:ext cx="10728655" cy="731520"/>
+          </a:xfrm>
+          <a:prstGeom prst="rect">
+            <a:avLst/>
+          </a:prstGeom>
+          <a:noFill/>
+        </p:spPr>
+        <p:txBody>
+          <a:bodyPr wrap="square">
+            <a:spAutoFit/>
+          </a:bodyPr>
+          <a:lstStyle/>
+          <a:p>
+            <a:pPr algn="l">
+              <a:defRPr sz="2800" b="1">
+                <a:solidFill>
+                  <a:srgbClr val="10B981"/>
+                </a:solidFill>
+                <a:latin typeface="Arial"/>
+              </a:defRPr>
+            </a:pPr>
+            <a:r>
+              <a:t>Model Impact and Effectiveness</a:t>
+            </a:r>
+          </a:p>
+        </p:txBody>
+      </p:sp>
+      <p:sp>
+        <p:nvSpPr>
+          <p:cNvPr id="4" name="TextBox 3"/>
+          <p:cNvSpPr txBox="1"/>
+          <p:nvPr/>
+        </p:nvSpPr>
+        <p:spPr>
+          <a:xfrm>
+            <a:off x="731520" y="1371600"/>
+            <a:ext cx="10728655" cy="4754880"/>
+          </a:xfrm>
+          <a:prstGeom prst="rect">
+            <a:avLst/>
+          </a:prstGeom>
+          <a:noFill/>
+        </p:spPr>
+        <p:txBody>
+          <a:bodyPr wrap="square">
+            <a:spAutoFit/>
+          </a:bodyPr>
+          <a:lstStyle/>
+          <a:p>
+            <a:pPr>
+              <a:spcBef>
+                <a:spcPts val="800"/>
+              </a:spcBef>
+              <a:spcAft>
+                <a:spcPts val="400"/>
+              </a:spcAft>
+              <a:defRPr sz="1900" b="1">
+                <a:solidFill>
+                  <a:srgbClr val="10B981"/>
+                </a:solidFill>
+                <a:latin typeface="Arial"/>
+              </a:defRPr>
+            </a:pPr>
+            <a:r>
+              <a:t>SDG 3 Core Problem Solving:</a:t>
+            </a:r>
+          </a:p>
+          <a:p>
+            <a:pPr lvl="1">
+              <a:spcAft>
+                <a:spcPts val="400"/>
+              </a:spcAft>
+              <a:defRPr sz="1500">
+                <a:solidFill>
+                  <a:srgbClr val="475569"/>
+                </a:solidFill>
+                <a:latin typeface="Arial"/>
+              </a:defRPr>
+            </a:pPr>
+            <a:r>
+              <a:t>Offers instant, reliable nutritional templates to users, eliminating barrier of cost for consulting dietitians.</a:t>
+            </a:r>
+          </a:p>
+          <a:p>
+            <a:pPr>
+              <a:spcBef>
+                <a:spcPts val="800"/>
+              </a:spcBef>
+              <a:spcAft>
+                <a:spcPts val="400"/>
+              </a:spcAft>
+              <a:defRPr sz="1900" b="1">
+                <a:solidFill>
+                  <a:srgbClr val="10B981"/>
+                </a:solidFill>
+                <a:latin typeface="Arial"/>
+              </a:defRPr>
+            </a:pPr>
+            <a:r>
+              <a:t>Preventative Health Management:</a:t>
+            </a:r>
+          </a:p>
+          <a:p>
+            <a:pPr lvl="1">
+              <a:spcAft>
+                <a:spcPts val="400"/>
+              </a:spcAft>
+              <a:defRPr sz="1500">
+                <a:solidFill>
+                  <a:srgbClr val="475569"/>
+                </a:solidFill>
+                <a:latin typeface="Arial"/>
+              </a:defRPr>
+            </a:pPr>
+            <a:r>
+              <a:t>Encourages conscious meal planning, assisting in early intervention and mitigation of diabetes and obesity.</a:t>
+            </a:r>
+          </a:p>
+          <a:p>
+            <a:pPr lvl="1">
+              <a:spcAft>
+                <a:spcPts val="400"/>
+              </a:spcAft>
+              <a:defRPr sz="1500">
+                <a:solidFill>
+                  <a:srgbClr val="475569"/>
+                </a:solidFill>
+                <a:latin typeface="Arial"/>
+              </a:defRPr>
+            </a:pPr>
+            <a:r>
+              <a:t>Non-Invasive: Entirely software-based, requiring only simple metabolic inputs from the user.</a:t>
+            </a:r>
+          </a:p>
+          <a:p>
+            <a:pPr>
+              <a:spcBef>
+                <a:spcPts val="800"/>
+              </a:spcBef>
+              <a:spcAft>
+                <a:spcPts val="400"/>
+              </a:spcAft>
+              <a:defRPr sz="1900" b="1">
+                <a:solidFill>
+                  <a:srgbClr val="10B981"/>
+                </a:solidFill>
+                <a:latin typeface="Arial"/>
+              </a:defRPr>
+            </a:pPr>
+            <a:r>
+              <a:t>Scalability:</a:t>
+            </a:r>
+          </a:p>
+          <a:p>
+            <a:pPr lvl="1">
+              <a:spcAft>
+                <a:spcPts val="400"/>
+              </a:spcAft>
+              <a:defRPr sz="1500">
+                <a:solidFill>
+                  <a:srgbClr val="475569"/>
+                </a:solidFill>
+                <a:latin typeface="Arial"/>
+              </a:defRPr>
+            </a:pPr>
+            <a:r>
+              <a:t>Highly scalable architecture capable of supporting thousands of simultaneous requests via Groq's high-speed API.</a:t>
+            </a:r>
+          </a:p>
+        </p:txBody>
+      </p:sp>
+    </p:spTree>
+  </p:cSld>
+  <p:clrMapOvr>
+    <a:masterClrMapping/>
+  </p:clrMapOvr>
+</p:sld>
+</file>
+
+<file path=ppt/slides/slide9.xml><?xml version="1.0" encoding="utf-8"?>
+<p:sld xmlns:a="http://schemas.openxmlformats.org/drawingml/2006/main" xmlns:p="http://schemas.openxmlformats.org/presentationml/2006/main" xmlns:r="http://schemas.openxmlformats.org/officeDocument/2006/relationships">
+  <p:cSld>
+    <p:bg>
+      <p:bgPr>
+        <a:solidFill>
+          <a:srgbClr val="F8FAFC"/>
+        </a:solidFill>
+        <a:effectLst/>
+      </p:bgPr>
+    </p:bg>
+    <p:spTree>
+      <p:nvGrpSpPr>
+        <p:cNvPr id="1" name=""/>
+        <p:cNvGrpSpPr/>
+        <p:nvPr/>
+      </p:nvGrpSpPr>
+      <p:grpSpPr/>
+      <p:sp>
+        <p:nvSpPr>
+          <p:cNvPr id="2" name="Rectangle 1"/>
+          <p:cNvSpPr/>
+          <p:nvPr/>
+        </p:nvSpPr>
+        <p:spPr>
+          <a:xfrm>
+            <a:off x="0" y="0"/>
+            <a:ext cx="12191695" cy="1005840"/>
+          </a:xfrm>
+          <a:prstGeom prst="rect">
+            <a:avLst/>
+          </a:prstGeom>
+          <a:solidFill>
+            <a:srgbClr val="0F172A"/>
+          </a:solidFill>
+          <a:ln>
+            <a:solidFill>
+              <a:srgbClr val="0F172A"/>
+            </a:solidFill>
+          </a:ln>
+        </p:spPr>
+        <p:style>
+          <a:lnRef idx="1">
+            <a:schemeClr val="accent1"/>
+          </a:lnRef>
+          <a:fillRef idx="3">
+            <a:schemeClr val="accent1"/>
+          </a:fillRef>
+          <a:effectRef idx="2">
+            <a:schemeClr val="accent1"/>
+          </a:effectRef>
+          <a:fontRef idx="minor">
+            <a:schemeClr val="lt1"/>
+          </a:fontRef>
+        </p:style>
+        <p:txBody>
+          <a:bodyPr rtlCol="0" anchor="ctr"/>
+          <a:lstStyle/>
+          <a:p>
+            <a:pPr algn="ctr"/>
           </a:p>
         </p:txBody>
       </p:sp>

</xml_diff>

<commit_message>
Update project metadata with authors and college name
</commit_message>
<xml_diff>
--- a/Pitch_Deck.pptx
+++ b/Pitch_Deck.pptx
@@ -3236,7 +3236,7 @@
                 </a:solidFill>
                 <a:latin typeface="Arial"/>
               </a:rPr>
-              <a:t>Full Name: </a:t>
+              <a:t>Full Names: </a:t>
             </a:r>
             <a:r>
               <a:rPr sz="1600">
@@ -3245,7 +3245,32 @@
                 </a:solidFill>
                 <a:latin typeface="Arial"/>
               </a:rPr>
-              <a:t>[Your Full Name Here]</a:t>
+              <a:t>soujanya k hegde and mohammed umar F</a:t>
+            </a:r>
+          </a:p>
+          <a:p>
+            <a:pPr>
+              <a:spcAft>
+                <a:spcPts val="800"/>
+              </a:spcAft>
+            </a:pPr>
+            <a:r>
+              <a:rPr sz="1600" b="1">
+                <a:solidFill>
+                  <a:srgbClr val="0F172A"/>
+                </a:solidFill>
+                <a:latin typeface="Arial"/>
+              </a:rPr>
+              <a:t>College Name: </a:t>
+            </a:r>
+            <a:r>
+              <a:rPr sz="1600">
+                <a:solidFill>
+                  <a:srgbClr val="475569"/>
+                </a:solidFill>
+                <a:latin typeface="Arial"/>
+              </a:rPr>
+              <a:t>cambridge institue of technology</a:t>
             </a:r>
           </a:p>
           <a:p>
@@ -3271,31 +3296,6 @@
                 <a:latin typeface="Arial"/>
               </a:rPr>
               <a:t>[Your Registered Mail ID Here]</a:t>
-            </a:r>
-          </a:p>
-          <a:p>
-            <a:pPr>
-              <a:spcAft>
-                <a:spcPts val="800"/>
-              </a:spcAft>
-            </a:pPr>
-            <a:r>
-              <a:rPr sz="1600" b="1">
-                <a:solidFill>
-                  <a:srgbClr val="0F172A"/>
-                </a:solidFill>
-                <a:latin typeface="Arial"/>
-              </a:rPr>
-              <a:t>College Name: </a:t>
-            </a:r>
-            <a:r>
-              <a:rPr sz="1600">
-                <a:solidFill>
-                  <a:srgbClr val="475569"/>
-                </a:solidFill>
-                <a:latin typeface="Arial"/>
-              </a:rPr>
-              <a:t>[Your College Name Here]</a:t>
             </a:r>
           </a:p>
           <a:p>

</xml_diff>

<commit_message>
Add manual updates for final submission
</commit_message>
<xml_diff>
--- a/Pitch_Deck.pptx
+++ b/Pitch_Deck.pptx
@@ -5,21 +5,21 @@
     <p:sldMasterId id="2147483648" r:id="rId1"/>
   </p:sldMasterIdLst>
   <p:sldIdLst>
-    <p:sldId id="256" r:id="rId7"/>
-    <p:sldId id="257" r:id="rId8"/>
-    <p:sldId id="258" r:id="rId9"/>
-    <p:sldId id="259" r:id="rId10"/>
-    <p:sldId id="260" r:id="rId11"/>
-    <p:sldId id="261" r:id="rId12"/>
-    <p:sldId id="262" r:id="rId13"/>
-    <p:sldId id="263" r:id="rId14"/>
-    <p:sldId id="264" r:id="rId15"/>
-    <p:sldId id="265" r:id="rId16"/>
-    <p:sldId id="266" r:id="rId17"/>
-    <p:sldId id="267" r:id="rId18"/>
-    <p:sldId id="268" r:id="rId19"/>
+    <p:sldId id="256" r:id="rId2"/>
+    <p:sldId id="257" r:id="rId3"/>
+    <p:sldId id="258" r:id="rId4"/>
+    <p:sldId id="259" r:id="rId5"/>
+    <p:sldId id="260" r:id="rId6"/>
+    <p:sldId id="261" r:id="rId7"/>
+    <p:sldId id="262" r:id="rId8"/>
+    <p:sldId id="263" r:id="rId9"/>
+    <p:sldId id="264" r:id="rId10"/>
+    <p:sldId id="265" r:id="rId11"/>
+    <p:sldId id="266" r:id="rId12"/>
+    <p:sldId id="267" r:id="rId13"/>
+    <p:sldId id="268" r:id="rId14"/>
   </p:sldIdLst>
-  <p:sldSz cx="12191695" cy="6858000" type="screen4x3"/>
+  <p:sldSz cx="12192000" cy="6858000"/>
   <p:notesSz cx="6858000" cy="9144000"/>
   <p:defaultTextStyle>
     <a:defPPr>
@@ -116,7 +116,170 @@
       </a:defRPr>
     </a:lvl9pPr>
   </p:defaultTextStyle>
+  <p:extLst>
+    <p:ext uri="{EFAFB233-063F-42B5-8137-9DF3F51BA10A}">
+      <p15:sldGuideLst xmlns:p15="http://schemas.microsoft.com/office/powerpoint/2012/main">
+        <p15:guide id="1" orient="horz" pos="2160">
+          <p15:clr>
+            <a:srgbClr val="A4A3A4"/>
+          </p15:clr>
+        </p15:guide>
+        <p15:guide id="2" pos="2880">
+          <p15:clr>
+            <a:srgbClr val="A4A3A4"/>
+          </p15:clr>
+        </p15:guide>
+      </p15:sldGuideLst>
+    </p:ext>
+  </p:extLst>
 </p:presentation>
+</file>
+
+<file path=ppt/revisionInfo.xml><?xml version="1.0" encoding="utf-8"?>
+<p1510:revInfo xmlns:a="http://schemas.openxmlformats.org/drawingml/2006/main" xmlns:r="http://schemas.openxmlformats.org/officeDocument/2006/relationships" xmlns:p1510="http://schemas.microsoft.com/office/powerpoint/2015/10/main">
+  <p1510:revLst>
+    <p1510:client id="{E4859A45-D5CB-456D-87D3-1DAFC14A0D54}" v="7" dt="2026-07-25T14:55:41.952"/>
+  </p1510:revLst>
+</p1510:revInfo>
+</file>
+
+<file path=ppt/changesInfos/changesInfo1.xml><?xml version="1.0" encoding="utf-8"?>
+<pc:chgInfo xmlns:a="http://schemas.openxmlformats.org/drawingml/2006/main" xmlns:r="http://schemas.openxmlformats.org/officeDocument/2006/relationships" xmlns:ac="http://schemas.microsoft.com/office/drawing/2013/main/command" xmlns:pc="http://schemas.microsoft.com/office/powerpoint/2013/main/command">
+  <pc:docChgLst>
+    <pc:chgData name="soujanya hegde" userId="f77445fcd24c4716" providerId="LiveId" clId="{19ACCCFD-CE44-4D36-9959-419B71920180}"/>
+    <pc:docChg chg="undo custSel modSld">
+      <pc:chgData name="soujanya hegde" userId="f77445fcd24c4716" providerId="LiveId" clId="{19ACCCFD-CE44-4D36-9959-419B71920180}" dt="2026-07-25T14:57:44.956" v="67" actId="14100"/>
+      <pc:docMkLst>
+        <pc:docMk/>
+      </pc:docMkLst>
+      <pc:sldChg chg="modSp mod">
+        <pc:chgData name="soujanya hegde" userId="f77445fcd24c4716" providerId="LiveId" clId="{19ACCCFD-CE44-4D36-9959-419B71920180}" dt="2026-07-25T14:50:08.115" v="28"/>
+        <pc:sldMkLst>
+          <pc:docMk/>
+          <pc:sldMk cId="0" sldId="256"/>
+        </pc:sldMkLst>
+        <pc:spChg chg="mod">
+          <ac:chgData name="soujanya hegde" userId="f77445fcd24c4716" providerId="LiveId" clId="{19ACCCFD-CE44-4D36-9959-419B71920180}" dt="2026-07-25T14:50:08.115" v="28"/>
+          <ac:spMkLst>
+            <pc:docMk/>
+            <pc:sldMk cId="0" sldId="256"/>
+            <ac:spMk id="4" creationId="{00000000-0000-0000-0000-000000000000}"/>
+          </ac:spMkLst>
+        </pc:spChg>
+      </pc:sldChg>
+      <pc:sldChg chg="addSp modSp mod">
+        <pc:chgData name="soujanya hegde" userId="f77445fcd24c4716" providerId="LiveId" clId="{19ACCCFD-CE44-4D36-9959-419B71920180}" dt="2026-07-25T14:53:34.705" v="48" actId="14100"/>
+        <pc:sldMkLst>
+          <pc:docMk/>
+          <pc:sldMk cId="0" sldId="265"/>
+        </pc:sldMkLst>
+        <pc:spChg chg="mod">
+          <ac:chgData name="soujanya hegde" userId="f77445fcd24c4716" providerId="LiveId" clId="{19ACCCFD-CE44-4D36-9959-419B71920180}" dt="2026-07-25T14:52:52.919" v="35" actId="20577"/>
+          <ac:spMkLst>
+            <pc:docMk/>
+            <pc:sldMk cId="0" sldId="265"/>
+            <ac:spMk id="4" creationId="{00000000-0000-0000-0000-000000000000}"/>
+          </ac:spMkLst>
+        </pc:spChg>
+        <pc:picChg chg="add mod">
+          <ac:chgData name="soujanya hegde" userId="f77445fcd24c4716" providerId="LiveId" clId="{19ACCCFD-CE44-4D36-9959-419B71920180}" dt="2026-07-25T14:53:34.705" v="48" actId="14100"/>
+          <ac:picMkLst>
+            <pc:docMk/>
+            <pc:sldMk cId="0" sldId="265"/>
+            <ac:picMk id="6" creationId="{2940EDE8-50A1-EDDB-8783-14E56AE72505}"/>
+          </ac:picMkLst>
+        </pc:picChg>
+        <pc:picChg chg="add mod">
+          <ac:chgData name="soujanya hegde" userId="f77445fcd24c4716" providerId="LiveId" clId="{19ACCCFD-CE44-4D36-9959-419B71920180}" dt="2026-07-25T14:53:29.909" v="47" actId="14100"/>
+          <ac:picMkLst>
+            <pc:docMk/>
+            <pc:sldMk cId="0" sldId="265"/>
+            <ac:picMk id="8" creationId="{0C00145C-846A-6C98-A334-E36A6859326C}"/>
+          </ac:picMkLst>
+        </pc:picChg>
+      </pc:sldChg>
+      <pc:sldChg chg="addSp delSp modSp mod">
+        <pc:chgData name="soujanya hegde" userId="f77445fcd24c4716" providerId="LiveId" clId="{19ACCCFD-CE44-4D36-9959-419B71920180}" dt="2026-07-25T14:57:44.956" v="67" actId="14100"/>
+        <pc:sldMkLst>
+          <pc:docMk/>
+          <pc:sldMk cId="0" sldId="268"/>
+        </pc:sldMkLst>
+        <pc:spChg chg="del">
+          <ac:chgData name="soujanya hegde" userId="f77445fcd24c4716" providerId="LiveId" clId="{19ACCCFD-CE44-4D36-9959-419B71920180}" dt="2026-07-25T14:54:55.884" v="52" actId="478"/>
+          <ac:spMkLst>
+            <pc:docMk/>
+            <pc:sldMk cId="0" sldId="268"/>
+            <ac:spMk id="3" creationId="{00000000-0000-0000-0000-000000000000}"/>
+          </ac:spMkLst>
+        </pc:spChg>
+        <pc:spChg chg="del mod">
+          <ac:chgData name="soujanya hegde" userId="f77445fcd24c4716" providerId="LiveId" clId="{19ACCCFD-CE44-4D36-9959-419B71920180}" dt="2026-07-25T14:54:22.413" v="51" actId="478"/>
+          <ac:spMkLst>
+            <pc:docMk/>
+            <pc:sldMk cId="0" sldId="268"/>
+            <ac:spMk id="4" creationId="{00000000-0000-0000-0000-000000000000}"/>
+          </ac:spMkLst>
+        </pc:spChg>
+        <pc:grpChg chg="mod">
+          <ac:chgData name="soujanya hegde" userId="f77445fcd24c4716" providerId="LiveId" clId="{19ACCCFD-CE44-4D36-9959-419B71920180}" dt="2026-07-25T14:55:41.952" v="61"/>
+          <ac:grpSpMkLst>
+            <pc:docMk/>
+            <pc:sldMk cId="0" sldId="268"/>
+            <ac:grpSpMk id="10" creationId="{ABF25A61-7468-F148-8EE0-3B0DBC421C6D}"/>
+          </ac:grpSpMkLst>
+        </pc:grpChg>
+        <pc:picChg chg="add mod">
+          <ac:chgData name="soujanya hegde" userId="f77445fcd24c4716" providerId="LiveId" clId="{19ACCCFD-CE44-4D36-9959-419B71920180}" dt="2026-07-25T14:57:44.956" v="67" actId="14100"/>
+          <ac:picMkLst>
+            <pc:docMk/>
+            <pc:sldMk cId="0" sldId="268"/>
+            <ac:picMk id="12" creationId="{EF3FD05A-36C5-2866-4168-5BDD910CBBFF}"/>
+          </ac:picMkLst>
+        </pc:picChg>
+        <pc:inkChg chg="add del">
+          <ac:chgData name="soujanya hegde" userId="f77445fcd24c4716" providerId="LiveId" clId="{19ACCCFD-CE44-4D36-9959-419B71920180}" dt="2026-07-25T14:55:26.190" v="54" actId="9405"/>
+          <ac:inkMkLst>
+            <pc:docMk/>
+            <pc:sldMk cId="0" sldId="268"/>
+            <ac:inkMk id="5" creationId="{22009843-D448-B01A-A79B-648AC6243F58}"/>
+          </ac:inkMkLst>
+        </pc:inkChg>
+        <pc:inkChg chg="add del mod">
+          <ac:chgData name="soujanya hegde" userId="f77445fcd24c4716" providerId="LiveId" clId="{19ACCCFD-CE44-4D36-9959-419B71920180}" dt="2026-07-25T14:55:55.671" v="64" actId="9405"/>
+          <ac:inkMkLst>
+            <pc:docMk/>
+            <pc:sldMk cId="0" sldId="268"/>
+            <ac:inkMk id="6" creationId="{E80FEB46-041C-E8BB-4651-D103AB851301}"/>
+          </ac:inkMkLst>
+        </pc:inkChg>
+        <pc:inkChg chg="add del mod">
+          <ac:chgData name="soujanya hegde" userId="f77445fcd24c4716" providerId="LiveId" clId="{19ACCCFD-CE44-4D36-9959-419B71920180}" dt="2026-07-25T14:55:51.374" v="63" actId="9405"/>
+          <ac:inkMkLst>
+            <pc:docMk/>
+            <pc:sldMk cId="0" sldId="268"/>
+            <ac:inkMk id="7" creationId="{33408688-1886-68DD-3FF9-71504B6283DF}"/>
+          </ac:inkMkLst>
+        </pc:inkChg>
+        <pc:inkChg chg="add del mod">
+          <ac:chgData name="soujanya hegde" userId="f77445fcd24c4716" providerId="LiveId" clId="{19ACCCFD-CE44-4D36-9959-419B71920180}" dt="2026-07-25T14:55:42.217" v="62" actId="9405"/>
+          <ac:inkMkLst>
+            <pc:docMk/>
+            <pc:sldMk cId="0" sldId="268"/>
+            <ac:inkMk id="8" creationId="{5613396C-890C-AFCD-8E94-74A705BBB3D5}"/>
+          </ac:inkMkLst>
+        </pc:inkChg>
+        <pc:inkChg chg="add del mod">
+          <ac:chgData name="soujanya hegde" userId="f77445fcd24c4716" providerId="LiveId" clId="{19ACCCFD-CE44-4D36-9959-419B71920180}" dt="2026-07-25T14:55:41.952" v="61"/>
+          <ac:inkMkLst>
+            <pc:docMk/>
+            <pc:sldMk cId="0" sldId="268"/>
+            <ac:inkMk id="9" creationId="{319617F3-E94A-573E-2075-18772ADC3B47}"/>
+          </ac:inkMkLst>
+        </pc:inkChg>
+      </pc:sldChg>
+    </pc:docChg>
+  </pc:docChgLst>
+</pc:chgInfo>
 </file>
 
 <file path=ppt/slideLayouts/slideLayout1.xml><?xml version="1.0" encoding="utf-8"?>
@@ -157,10 +320,9 @@
           <a:lstStyle/>
           <a:p>
             <a:r>
-              <a:rPr lang="en-US" smtClean="0"/>
+              <a:rPr lang="en-US"/>
               <a:t>Click to edit Master title style</a:t>
             </a:r>
-            <a:endParaRPr lang="en-US"/>
           </a:p>
         </p:txBody>
       </p:sp>
@@ -276,10 +438,9 @@
           </a:lstStyle>
           <a:p>
             <a:r>
-              <a:rPr lang="en-US" smtClean="0"/>
+              <a:rPr lang="en-US"/>
               <a:t>Click to edit Master subtitle style</a:t>
             </a:r>
-            <a:endParaRPr lang="en-US"/>
           </a:p>
         </p:txBody>
       </p:sp>
@@ -300,7 +461,7 @@
           <a:p>
             <a:fld id="{5BCAD085-E8A6-8845-BD4E-CB4CCA059FC4}" type="datetimeFigureOut">
               <a:rPr lang="en-US" smtClean="0"/>
-              <a:t>1/27/13</a:t>
+              <a:t>7/25/2026</a:t>
             </a:fld>
             <a:endParaRPr lang="en-US"/>
           </a:p>
@@ -394,10 +555,9 @@
           <a:lstStyle/>
           <a:p>
             <a:r>
-              <a:rPr lang="en-US" smtClean="0"/>
+              <a:rPr lang="en-US"/>
               <a:t>Click to edit Master title style</a:t>
             </a:r>
-            <a:endParaRPr lang="en-US"/>
           </a:p>
         </p:txBody>
       </p:sp>
@@ -418,38 +578,37 @@
           <a:p>
             <a:pPr lvl="0"/>
             <a:r>
-              <a:rPr lang="en-US" smtClean="0"/>
+              <a:rPr lang="en-US"/>
               <a:t>Click to edit Master text styles</a:t>
             </a:r>
           </a:p>
           <a:p>
             <a:pPr lvl="1"/>
             <a:r>
-              <a:rPr lang="en-US" smtClean="0"/>
+              <a:rPr lang="en-US"/>
               <a:t>Second level</a:t>
             </a:r>
           </a:p>
           <a:p>
             <a:pPr lvl="2"/>
             <a:r>
-              <a:rPr lang="en-US" smtClean="0"/>
+              <a:rPr lang="en-US"/>
               <a:t>Third level</a:t>
             </a:r>
           </a:p>
           <a:p>
             <a:pPr lvl="3"/>
             <a:r>
-              <a:rPr lang="en-US" smtClean="0"/>
+              <a:rPr lang="en-US"/>
               <a:t>Fourth level</a:t>
             </a:r>
           </a:p>
           <a:p>
             <a:pPr lvl="4"/>
             <a:r>
-              <a:rPr lang="en-US" smtClean="0"/>
+              <a:rPr lang="en-US"/>
               <a:t>Fifth level</a:t>
             </a:r>
-            <a:endParaRPr lang="en-US"/>
           </a:p>
         </p:txBody>
       </p:sp>
@@ -470,7 +629,7 @@
           <a:p>
             <a:fld id="{5BCAD085-E8A6-8845-BD4E-CB4CCA059FC4}" type="datetimeFigureOut">
               <a:rPr lang="en-US" smtClean="0"/>
-              <a:t>1/27/13</a:t>
+              <a:t>7/25/2026</a:t>
             </a:fld>
             <a:endParaRPr lang="en-US"/>
           </a:p>
@@ -569,10 +728,9 @@
           <a:lstStyle/>
           <a:p>
             <a:r>
-              <a:rPr lang="en-US" smtClean="0"/>
+              <a:rPr lang="en-US"/>
               <a:t>Click to edit Master title style</a:t>
             </a:r>
-            <a:endParaRPr lang="en-US"/>
           </a:p>
         </p:txBody>
       </p:sp>
@@ -598,38 +756,37 @@
           <a:p>
             <a:pPr lvl="0"/>
             <a:r>
-              <a:rPr lang="en-US" smtClean="0"/>
+              <a:rPr lang="en-US"/>
               <a:t>Click to edit Master text styles</a:t>
             </a:r>
           </a:p>
           <a:p>
             <a:pPr lvl="1"/>
             <a:r>
-              <a:rPr lang="en-US" smtClean="0"/>
+              <a:rPr lang="en-US"/>
               <a:t>Second level</a:t>
             </a:r>
           </a:p>
           <a:p>
             <a:pPr lvl="2"/>
             <a:r>
-              <a:rPr lang="en-US" smtClean="0"/>
+              <a:rPr lang="en-US"/>
               <a:t>Third level</a:t>
             </a:r>
           </a:p>
           <a:p>
             <a:pPr lvl="3"/>
             <a:r>
-              <a:rPr lang="en-US" smtClean="0"/>
+              <a:rPr lang="en-US"/>
               <a:t>Fourth level</a:t>
             </a:r>
           </a:p>
           <a:p>
             <a:pPr lvl="4"/>
             <a:r>
-              <a:rPr lang="en-US" smtClean="0"/>
+              <a:rPr lang="en-US"/>
               <a:t>Fifth level</a:t>
             </a:r>
-            <a:endParaRPr lang="en-US"/>
           </a:p>
         </p:txBody>
       </p:sp>
@@ -650,7 +807,7 @@
           <a:p>
             <a:fld id="{5BCAD085-E8A6-8845-BD4E-CB4CCA059FC4}" type="datetimeFigureOut">
               <a:rPr lang="en-US" smtClean="0"/>
-              <a:t>1/27/13</a:t>
+              <a:t>7/25/2026</a:t>
             </a:fld>
             <a:endParaRPr lang="en-US"/>
           </a:p>
@@ -744,10 +901,9 @@
           <a:lstStyle/>
           <a:p>
             <a:r>
-              <a:rPr lang="en-US" smtClean="0"/>
+              <a:rPr lang="en-US"/>
               <a:t>Click to edit Master title style</a:t>
             </a:r>
-            <a:endParaRPr lang="en-US"/>
           </a:p>
         </p:txBody>
       </p:sp>
@@ -768,38 +924,37 @@
           <a:p>
             <a:pPr lvl="0"/>
             <a:r>
-              <a:rPr lang="en-US" smtClean="0"/>
+              <a:rPr lang="en-US"/>
               <a:t>Click to edit Master text styles</a:t>
             </a:r>
           </a:p>
           <a:p>
             <a:pPr lvl="1"/>
             <a:r>
-              <a:rPr lang="en-US" smtClean="0"/>
+              <a:rPr lang="en-US"/>
               <a:t>Second level</a:t>
             </a:r>
           </a:p>
           <a:p>
             <a:pPr lvl="2"/>
             <a:r>
-              <a:rPr lang="en-US" smtClean="0"/>
+              <a:rPr lang="en-US"/>
               <a:t>Third level</a:t>
             </a:r>
           </a:p>
           <a:p>
             <a:pPr lvl="3"/>
             <a:r>
-              <a:rPr lang="en-US" smtClean="0"/>
+              <a:rPr lang="en-US"/>
               <a:t>Fourth level</a:t>
             </a:r>
           </a:p>
           <a:p>
             <a:pPr lvl="4"/>
             <a:r>
-              <a:rPr lang="en-US" smtClean="0"/>
+              <a:rPr lang="en-US"/>
               <a:t>Fifth level</a:t>
             </a:r>
-            <a:endParaRPr lang="en-US"/>
           </a:p>
         </p:txBody>
       </p:sp>
@@ -820,7 +975,7 @@
           <a:p>
             <a:fld id="{5BCAD085-E8A6-8845-BD4E-CB4CCA059FC4}" type="datetimeFigureOut">
               <a:rPr lang="en-US" smtClean="0"/>
-              <a:t>1/27/13</a:t>
+              <a:t>7/25/2026</a:t>
             </a:fld>
             <a:endParaRPr lang="en-US"/>
           </a:p>
@@ -923,10 +1078,9 @@
           </a:lstStyle>
           <a:p>
             <a:r>
-              <a:rPr lang="en-US" smtClean="0"/>
+              <a:rPr lang="en-US"/>
               <a:t>Click to edit Master title style</a:t>
             </a:r>
-            <a:endParaRPr lang="en-US"/>
           </a:p>
         </p:txBody>
       </p:sp>
@@ -1043,7 +1197,7 @@
           <a:p>
             <a:pPr lvl="0"/>
             <a:r>
-              <a:rPr lang="en-US" smtClean="0"/>
+              <a:rPr lang="en-US"/>
               <a:t>Click to edit Master text styles</a:t>
             </a:r>
           </a:p>
@@ -1066,7 +1220,7 @@
           <a:p>
             <a:fld id="{5BCAD085-E8A6-8845-BD4E-CB4CCA059FC4}" type="datetimeFigureOut">
               <a:rPr lang="en-US" smtClean="0"/>
-              <a:t>1/27/13</a:t>
+              <a:t>7/25/2026</a:t>
             </a:fld>
             <a:endParaRPr lang="en-US"/>
           </a:p>
@@ -1160,10 +1314,9 @@
           <a:lstStyle/>
           <a:p>
             <a:r>
-              <a:rPr lang="en-US" smtClean="0"/>
+              <a:rPr lang="en-US"/>
               <a:t>Click to edit Master title style</a:t>
             </a:r>
-            <a:endParaRPr lang="en-US"/>
           </a:p>
         </p:txBody>
       </p:sp>
@@ -1217,38 +1370,37 @@
           <a:p>
             <a:pPr lvl="0"/>
             <a:r>
-              <a:rPr lang="en-US" smtClean="0"/>
+              <a:rPr lang="en-US"/>
               <a:t>Click to edit Master text styles</a:t>
             </a:r>
           </a:p>
           <a:p>
             <a:pPr lvl="1"/>
             <a:r>
-              <a:rPr lang="en-US" smtClean="0"/>
+              <a:rPr lang="en-US"/>
               <a:t>Second level</a:t>
             </a:r>
           </a:p>
           <a:p>
             <a:pPr lvl="2"/>
             <a:r>
-              <a:rPr lang="en-US" smtClean="0"/>
+              <a:rPr lang="en-US"/>
               <a:t>Third level</a:t>
             </a:r>
           </a:p>
           <a:p>
             <a:pPr lvl="3"/>
             <a:r>
-              <a:rPr lang="en-US" smtClean="0"/>
+              <a:rPr lang="en-US"/>
               <a:t>Fourth level</a:t>
             </a:r>
           </a:p>
           <a:p>
             <a:pPr lvl="4"/>
             <a:r>
-              <a:rPr lang="en-US" smtClean="0"/>
+              <a:rPr lang="en-US"/>
               <a:t>Fifth level</a:t>
             </a:r>
-            <a:endParaRPr lang="en-US"/>
           </a:p>
         </p:txBody>
       </p:sp>
@@ -1302,38 +1454,37 @@
           <a:p>
             <a:pPr lvl="0"/>
             <a:r>
-              <a:rPr lang="en-US" smtClean="0"/>
+              <a:rPr lang="en-US"/>
               <a:t>Click to edit Master text styles</a:t>
             </a:r>
           </a:p>
           <a:p>
             <a:pPr lvl="1"/>
             <a:r>
-              <a:rPr lang="en-US" smtClean="0"/>
+              <a:rPr lang="en-US"/>
               <a:t>Second level</a:t>
             </a:r>
           </a:p>
           <a:p>
             <a:pPr lvl="2"/>
             <a:r>
-              <a:rPr lang="en-US" smtClean="0"/>
+              <a:rPr lang="en-US"/>
               <a:t>Third level</a:t>
             </a:r>
           </a:p>
           <a:p>
             <a:pPr lvl="3"/>
             <a:r>
-              <a:rPr lang="en-US" smtClean="0"/>
+              <a:rPr lang="en-US"/>
               <a:t>Fourth level</a:t>
             </a:r>
           </a:p>
           <a:p>
             <a:pPr lvl="4"/>
             <a:r>
-              <a:rPr lang="en-US" smtClean="0"/>
+              <a:rPr lang="en-US"/>
               <a:t>Fifth level</a:t>
             </a:r>
-            <a:endParaRPr lang="en-US"/>
           </a:p>
         </p:txBody>
       </p:sp>
@@ -1354,7 +1505,7 @@
           <a:p>
             <a:fld id="{5BCAD085-E8A6-8845-BD4E-CB4CCA059FC4}" type="datetimeFigureOut">
               <a:rPr lang="en-US" smtClean="0"/>
-              <a:t>1/27/13</a:t>
+              <a:t>7/25/2026</a:t>
             </a:fld>
             <a:endParaRPr lang="en-US"/>
           </a:p>
@@ -1452,10 +1603,9 @@
           </a:lstStyle>
           <a:p>
             <a:r>
-              <a:rPr lang="en-US" smtClean="0"/>
+              <a:rPr lang="en-US"/>
               <a:t>Click to edit Master title style</a:t>
             </a:r>
-            <a:endParaRPr lang="en-US"/>
           </a:p>
         </p:txBody>
       </p:sp>
@@ -1518,7 +1668,7 @@
           <a:p>
             <a:pPr lvl="0"/>
             <a:r>
-              <a:rPr lang="en-US" smtClean="0"/>
+              <a:rPr lang="en-US"/>
               <a:t>Click to edit Master text styles</a:t>
             </a:r>
           </a:p>
@@ -1574,38 +1724,37 @@
           <a:p>
             <a:pPr lvl="0"/>
             <a:r>
-              <a:rPr lang="en-US" smtClean="0"/>
+              <a:rPr lang="en-US"/>
               <a:t>Click to edit Master text styles</a:t>
             </a:r>
           </a:p>
           <a:p>
             <a:pPr lvl="1"/>
             <a:r>
-              <a:rPr lang="en-US" smtClean="0"/>
+              <a:rPr lang="en-US"/>
               <a:t>Second level</a:t>
             </a:r>
           </a:p>
           <a:p>
             <a:pPr lvl="2"/>
             <a:r>
-              <a:rPr lang="en-US" smtClean="0"/>
+              <a:rPr lang="en-US"/>
               <a:t>Third level</a:t>
             </a:r>
           </a:p>
           <a:p>
             <a:pPr lvl="3"/>
             <a:r>
-              <a:rPr lang="en-US" smtClean="0"/>
+              <a:rPr lang="en-US"/>
               <a:t>Fourth level</a:t>
             </a:r>
           </a:p>
           <a:p>
             <a:pPr lvl="4"/>
             <a:r>
-              <a:rPr lang="en-US" smtClean="0"/>
+              <a:rPr lang="en-US"/>
               <a:t>Fifth level</a:t>
             </a:r>
-            <a:endParaRPr lang="en-US"/>
           </a:p>
         </p:txBody>
       </p:sp>
@@ -1668,7 +1817,7 @@
           <a:p>
             <a:pPr lvl="0"/>
             <a:r>
-              <a:rPr lang="en-US" smtClean="0"/>
+              <a:rPr lang="en-US"/>
               <a:t>Click to edit Master text styles</a:t>
             </a:r>
           </a:p>
@@ -1724,38 +1873,37 @@
           <a:p>
             <a:pPr lvl="0"/>
             <a:r>
-              <a:rPr lang="en-US" smtClean="0"/>
+              <a:rPr lang="en-US"/>
               <a:t>Click to edit Master text styles</a:t>
             </a:r>
           </a:p>
           <a:p>
             <a:pPr lvl="1"/>
             <a:r>
-              <a:rPr lang="en-US" smtClean="0"/>
+              <a:rPr lang="en-US"/>
               <a:t>Second level</a:t>
             </a:r>
           </a:p>
           <a:p>
             <a:pPr lvl="2"/>
             <a:r>
-              <a:rPr lang="en-US" smtClean="0"/>
+              <a:rPr lang="en-US"/>
               <a:t>Third level</a:t>
             </a:r>
           </a:p>
           <a:p>
             <a:pPr lvl="3"/>
             <a:r>
-              <a:rPr lang="en-US" smtClean="0"/>
+              <a:rPr lang="en-US"/>
               <a:t>Fourth level</a:t>
             </a:r>
           </a:p>
           <a:p>
             <a:pPr lvl="4"/>
             <a:r>
-              <a:rPr lang="en-US" smtClean="0"/>
+              <a:rPr lang="en-US"/>
               <a:t>Fifth level</a:t>
             </a:r>
-            <a:endParaRPr lang="en-US"/>
           </a:p>
         </p:txBody>
       </p:sp>
@@ -1776,7 +1924,7 @@
           <a:p>
             <a:fld id="{5BCAD085-E8A6-8845-BD4E-CB4CCA059FC4}" type="datetimeFigureOut">
               <a:rPr lang="en-US" smtClean="0"/>
-              <a:t>1/27/13</a:t>
+              <a:t>7/25/2026</a:t>
             </a:fld>
             <a:endParaRPr lang="en-US"/>
           </a:p>
@@ -1870,10 +2018,9 @@
           <a:lstStyle/>
           <a:p>
             <a:r>
-              <a:rPr lang="en-US" smtClean="0"/>
+              <a:rPr lang="en-US"/>
               <a:t>Click to edit Master title style</a:t>
             </a:r>
-            <a:endParaRPr lang="en-US"/>
           </a:p>
         </p:txBody>
       </p:sp>
@@ -1894,7 +2041,7 @@
           <a:p>
             <a:fld id="{5BCAD085-E8A6-8845-BD4E-CB4CCA059FC4}" type="datetimeFigureOut">
               <a:rPr lang="en-US" smtClean="0"/>
-              <a:t>1/27/13</a:t>
+              <a:t>7/25/2026</a:t>
             </a:fld>
             <a:endParaRPr lang="en-US"/>
           </a:p>
@@ -1989,7 +2136,7 @@
           <a:p>
             <a:fld id="{5BCAD085-E8A6-8845-BD4E-CB4CCA059FC4}" type="datetimeFigureOut">
               <a:rPr lang="en-US" smtClean="0"/>
-              <a:t>1/27/13</a:t>
+              <a:t>7/25/2026</a:t>
             </a:fld>
             <a:endParaRPr lang="en-US"/>
           </a:p>
@@ -2092,10 +2239,9 @@
           </a:lstStyle>
           <a:p>
             <a:r>
-              <a:rPr lang="en-US" smtClean="0"/>
+              <a:rPr lang="en-US"/>
               <a:t>Click to edit Master title style</a:t>
             </a:r>
-            <a:endParaRPr lang="en-US"/>
           </a:p>
         </p:txBody>
       </p:sp>
@@ -2149,38 +2295,37 @@
           <a:p>
             <a:pPr lvl="0"/>
             <a:r>
-              <a:rPr lang="en-US" smtClean="0"/>
+              <a:rPr lang="en-US"/>
               <a:t>Click to edit Master text styles</a:t>
             </a:r>
           </a:p>
           <a:p>
             <a:pPr lvl="1"/>
             <a:r>
-              <a:rPr lang="en-US" smtClean="0"/>
+              <a:rPr lang="en-US"/>
               <a:t>Second level</a:t>
             </a:r>
           </a:p>
           <a:p>
             <a:pPr lvl="2"/>
             <a:r>
-              <a:rPr lang="en-US" smtClean="0"/>
+              <a:rPr lang="en-US"/>
               <a:t>Third level</a:t>
             </a:r>
           </a:p>
           <a:p>
             <a:pPr lvl="3"/>
             <a:r>
-              <a:rPr lang="en-US" smtClean="0"/>
+              <a:rPr lang="en-US"/>
               <a:t>Fourth level</a:t>
             </a:r>
           </a:p>
           <a:p>
             <a:pPr lvl="4"/>
             <a:r>
-              <a:rPr lang="en-US" smtClean="0"/>
+              <a:rPr lang="en-US"/>
               <a:t>Fifth level</a:t>
             </a:r>
-            <a:endParaRPr lang="en-US"/>
           </a:p>
         </p:txBody>
       </p:sp>
@@ -2243,7 +2388,7 @@
           <a:p>
             <a:pPr lvl="0"/>
             <a:r>
-              <a:rPr lang="en-US" smtClean="0"/>
+              <a:rPr lang="en-US"/>
               <a:t>Click to edit Master text styles</a:t>
             </a:r>
           </a:p>
@@ -2266,7 +2411,7 @@
           <a:p>
             <a:fld id="{5BCAD085-E8A6-8845-BD4E-CB4CCA059FC4}" type="datetimeFigureOut">
               <a:rPr lang="en-US" smtClean="0"/>
-              <a:t>1/27/13</a:t>
+              <a:t>7/25/2026</a:t>
             </a:fld>
             <a:endParaRPr lang="en-US"/>
           </a:p>
@@ -2369,10 +2514,9 @@
           </a:lstStyle>
           <a:p>
             <a:r>
-              <a:rPr lang="en-US" smtClean="0"/>
+              <a:rPr lang="en-US"/>
               <a:t>Click to edit Master title style</a:t>
             </a:r>
-            <a:endParaRPr lang="en-US"/>
           </a:p>
         </p:txBody>
       </p:sp>
@@ -2496,7 +2640,7 @@
           <a:p>
             <a:pPr lvl="0"/>
             <a:r>
-              <a:rPr lang="en-US" smtClean="0"/>
+              <a:rPr lang="en-US"/>
               <a:t>Click to edit Master text styles</a:t>
             </a:r>
           </a:p>
@@ -2519,7 +2663,7 @@
           <a:p>
             <a:fld id="{5BCAD085-E8A6-8845-BD4E-CB4CCA059FC4}" type="datetimeFigureOut">
               <a:rPr lang="en-US" smtClean="0"/>
-              <a:t>1/27/13</a:t>
+              <a:t>7/25/2026</a:t>
             </a:fld>
             <a:endParaRPr lang="en-US"/>
           </a:p>
@@ -2628,10 +2772,9 @@
           <a:lstStyle/>
           <a:p>
             <a:r>
-              <a:rPr lang="en-US" smtClean="0"/>
+              <a:rPr lang="en-US"/>
               <a:t>Click to edit Master title style</a:t>
             </a:r>
-            <a:endParaRPr lang="en-US"/>
           </a:p>
         </p:txBody>
       </p:sp>
@@ -2662,38 +2805,37 @@
           <a:p>
             <a:pPr lvl="0"/>
             <a:r>
-              <a:rPr lang="en-US" smtClean="0"/>
+              <a:rPr lang="en-US"/>
               <a:t>Click to edit Master text styles</a:t>
             </a:r>
           </a:p>
           <a:p>
             <a:pPr lvl="1"/>
             <a:r>
-              <a:rPr lang="en-US" smtClean="0"/>
+              <a:rPr lang="en-US"/>
               <a:t>Second level</a:t>
             </a:r>
           </a:p>
           <a:p>
             <a:pPr lvl="2"/>
             <a:r>
-              <a:rPr lang="en-US" smtClean="0"/>
+              <a:rPr lang="en-US"/>
               <a:t>Third level</a:t>
             </a:r>
           </a:p>
           <a:p>
             <a:pPr lvl="3"/>
             <a:r>
-              <a:rPr lang="en-US" smtClean="0"/>
+              <a:rPr lang="en-US"/>
               <a:t>Fourth level</a:t>
             </a:r>
           </a:p>
           <a:p>
             <a:pPr lvl="4"/>
             <a:r>
-              <a:rPr lang="en-US" smtClean="0"/>
+              <a:rPr lang="en-US"/>
               <a:t>Fifth level</a:t>
             </a:r>
-            <a:endParaRPr lang="en-US"/>
           </a:p>
         </p:txBody>
       </p:sp>
@@ -2732,7 +2874,7 @@
           <a:p>
             <a:fld id="{5BCAD085-E8A6-8845-BD4E-CB4CCA059FC4}" type="datetimeFigureOut">
               <a:rPr lang="en-US" smtClean="0"/>
-              <a:t>1/27/13</a:t>
+              <a:t>7/25/2026</a:t>
             </a:fld>
             <a:endParaRPr lang="en-US"/>
           </a:p>
@@ -3091,7 +3233,7 @@
 </file>
 
 <file path=ppt/slides/slide1.xml><?xml version="1.0" encoding="utf-8"?>
-<p:sld xmlns:a="http://schemas.openxmlformats.org/drawingml/2006/main" xmlns:p="http://schemas.openxmlformats.org/presentationml/2006/main" xmlns:r="http://schemas.openxmlformats.org/officeDocument/2006/relationships">
+<p:sld xmlns:a="http://schemas.openxmlformats.org/drawingml/2006/main" xmlns:r="http://schemas.openxmlformats.org/officeDocument/2006/relationships" xmlns:p="http://schemas.openxmlformats.org/presentationml/2006/main">
   <p:cSld>
     <p:bg>
       <p:bgPr>
@@ -3107,7 +3249,14 @@
         <p:cNvGrpSpPr/>
         <p:nvPr/>
       </p:nvGrpSpPr>
-      <p:grpSpPr/>
+      <p:grpSpPr>
+        <a:xfrm>
+          <a:off x="0" y="0"/>
+          <a:ext cx="0" cy="0"/>
+          <a:chOff x="0" y="0"/>
+          <a:chExt cx="0" cy="0"/>
+        </a:xfrm>
+      </p:grpSpPr>
       <p:sp>
         <p:nvSpPr>
           <p:cNvPr id="2" name="Rectangle 1"/>
@@ -3150,6 +3299,7 @@
           <a:lstStyle/>
           <a:p>
             <a:pPr algn="ctr"/>
+            <a:endParaRPr/>
           </a:p>
         </p:txBody>
       </p:sp>
@@ -3184,6 +3334,7 @@
               </a:defRPr>
             </a:pPr>
             <a:r>
+              <a:rPr dirty="0"/>
               <a:t>Nutritional AI Agent</a:t>
             </a:r>
           </a:p>
@@ -3197,7 +3348,16 @@
               </a:defRPr>
             </a:pPr>
             <a:r>
-              <a:t>IBM SkillsBuild Project Submission | UN SDG 3 (Good Health and Well-being)</a:t>
+              <a:rPr dirty="0"/>
+              <a:t>IBM </a:t>
+            </a:r>
+            <a:r>
+              <a:rPr dirty="0" err="1"/>
+              <a:t>SkillsBuild</a:t>
+            </a:r>
+            <a:r>
+              <a:rPr dirty="0"/>
+              <a:t> Project Submission | UN SDG 3 (Good Health and Well-being)</a:t>
             </a:r>
           </a:p>
         </p:txBody>
@@ -3211,7 +3371,7 @@
         <p:spPr>
           <a:xfrm>
             <a:off x="914400" y="2926080"/>
-            <a:ext cx="10332720" cy="3200400"/>
+            <a:ext cx="10332720" cy="2082621"/>
           </a:xfrm>
           <a:prstGeom prst="rect">
             <a:avLst/>
@@ -3230,7 +3390,7 @@
               </a:spcAft>
             </a:pPr>
             <a:r>
-              <a:rPr sz="1600" b="1">
+              <a:rPr sz="1600" b="1" dirty="0">
                 <a:solidFill>
                   <a:srgbClr val="0F172A"/>
                 </a:solidFill>
@@ -3239,13 +3399,49 @@
               <a:t>Full Names: </a:t>
             </a:r>
             <a:r>
-              <a:rPr sz="1600">
+              <a:rPr sz="1600" dirty="0">
                 <a:solidFill>
                   <a:srgbClr val="475569"/>
                 </a:solidFill>
                 <a:latin typeface="Arial"/>
               </a:rPr>
-              <a:t>soujanya k hegde and mohammed umar F</a:t>
+              <a:t>soujanya k hegde and </a:t>
+            </a:r>
+            <a:r>
+              <a:rPr sz="1600" dirty="0" err="1">
+                <a:solidFill>
+                  <a:srgbClr val="475569"/>
+                </a:solidFill>
+                <a:latin typeface="Arial"/>
+              </a:rPr>
+              <a:t>mohammed</a:t>
+            </a:r>
+            <a:r>
+              <a:rPr sz="1600" dirty="0">
+                <a:solidFill>
+                  <a:srgbClr val="475569"/>
+                </a:solidFill>
+                <a:latin typeface="Arial"/>
+              </a:rPr>
+              <a:t> </a:t>
+            </a:r>
+            <a:r>
+              <a:rPr sz="1600" dirty="0" err="1">
+                <a:solidFill>
+                  <a:srgbClr val="475569"/>
+                </a:solidFill>
+                <a:latin typeface="Arial"/>
+              </a:rPr>
+              <a:t>umar</a:t>
+            </a:r>
+            <a:r>
+              <a:rPr sz="1600" dirty="0">
+                <a:solidFill>
+                  <a:srgbClr val="475569"/>
+                </a:solidFill>
+                <a:latin typeface="Arial"/>
+              </a:rPr>
+              <a:t> F</a:t>
             </a:r>
           </a:p>
           <a:p>
@@ -3255,7 +3451,7 @@
               </a:spcAft>
             </a:pPr>
             <a:r>
-              <a:rPr sz="1600" b="1">
+              <a:rPr sz="1600" b="1" dirty="0">
                 <a:solidFill>
                   <a:srgbClr val="0F172A"/>
                 </a:solidFill>
@@ -3264,13 +3460,40 @@
               <a:t>College Name: </a:t>
             </a:r>
             <a:r>
-              <a:rPr sz="1600">
+              <a:rPr sz="1600" dirty="0" err="1">
                 <a:solidFill>
                   <a:srgbClr val="475569"/>
                 </a:solidFill>
                 <a:latin typeface="Arial"/>
               </a:rPr>
-              <a:t>cambridge institue of technology</a:t>
+              <a:t>cambridge</a:t>
+            </a:r>
+            <a:r>
+              <a:rPr sz="1600" dirty="0">
+                <a:solidFill>
+                  <a:srgbClr val="475569"/>
+                </a:solidFill>
+                <a:latin typeface="Arial"/>
+              </a:rPr>
+              <a:t> </a:t>
+            </a:r>
+            <a:r>
+              <a:rPr sz="1600" dirty="0" err="1">
+                <a:solidFill>
+                  <a:srgbClr val="475569"/>
+                </a:solidFill>
+                <a:latin typeface="Arial"/>
+              </a:rPr>
+              <a:t>institue</a:t>
+            </a:r>
+            <a:r>
+              <a:rPr sz="1600" dirty="0">
+                <a:solidFill>
+                  <a:srgbClr val="475569"/>
+                </a:solidFill>
+                <a:latin typeface="Arial"/>
+              </a:rPr>
+              <a:t> of technology</a:t>
             </a:r>
           </a:p>
           <a:p>
@@ -3280,7 +3503,7 @@
               </a:spcAft>
             </a:pPr>
             <a:r>
-              <a:rPr sz="1600" b="1">
+              <a:rPr sz="1600" b="1" dirty="0">
                 <a:solidFill>
                   <a:srgbClr val="0F172A"/>
                 </a:solidFill>
@@ -3289,13 +3512,14 @@
               <a:t>Registered Mail ID: </a:t>
             </a:r>
             <a:r>
-              <a:rPr sz="1600">
-                <a:solidFill>
-                  <a:srgbClr val="475569"/>
-                </a:solidFill>
-                <a:latin typeface="Arial"/>
+              <a:rPr lang="en-IN" sz="1600" dirty="0">
+                <a:hlinkClick r:id="rId2"/>
               </a:rPr>
-              <a:t>[Your Registered Mail ID Here]</a:t>
+              <a:t>shegde092@gmail.com</a:t>
+            </a:r>
+            <a:r>
+              <a:rPr lang="en-IN" sz="1600" dirty="0"/>
+              <a:t> and mdumr4@gamil.com</a:t>
             </a:r>
           </a:p>
           <a:p>
@@ -3305,7 +3529,7 @@
               </a:spcAft>
             </a:pPr>
             <a:r>
-              <a:rPr sz="1600" b="1">
+              <a:rPr sz="1600" b="1" dirty="0">
                 <a:solidFill>
                   <a:srgbClr val="0F172A"/>
                 </a:solidFill>
@@ -3314,14 +3538,20 @@
               <a:t>Mob No.: </a:t>
             </a:r>
             <a:r>
-              <a:rPr sz="1600">
-                <a:solidFill>
-                  <a:srgbClr val="475569"/>
+              <a:rPr lang="en-IN" sz="1600" b="1" dirty="0">
+                <a:solidFill>
+                  <a:srgbClr val="0F172A"/>
                 </a:solidFill>
                 <a:latin typeface="Arial"/>
               </a:rPr>
-              <a:t>[Your Mobile Number Here]</a:t>
-            </a:r>
+              <a:t>9148165856 and 88925 74137</a:t>
+            </a:r>
+            <a:endParaRPr lang="en-IN" sz="1600" b="1" dirty="0">
+              <a:solidFill>
+                <a:srgbClr val="475569"/>
+              </a:solidFill>
+              <a:latin typeface="Arial"/>
+            </a:endParaRPr>
           </a:p>
           <a:p>
             <a:pPr>
@@ -3330,23 +3560,64 @@
               </a:spcAft>
             </a:pPr>
             <a:r>
-              <a:rPr sz="1600" b="1">
+              <a:rPr sz="1600" b="1" dirty="0">
                 <a:solidFill>
                   <a:srgbClr val="0F172A"/>
                 </a:solidFill>
                 <a:latin typeface="Arial"/>
               </a:rPr>
-              <a:t>IBM SkillsBuild Platform Mail ID: </a:t>
-            </a:r>
-            <a:r>
-              <a:rPr sz="1600">
-                <a:solidFill>
-                  <a:srgbClr val="475569"/>
+              <a:t>IBM </a:t>
+            </a:r>
+            <a:r>
+              <a:rPr sz="1600" b="1" dirty="0" err="1">
+                <a:solidFill>
+                  <a:srgbClr val="0F172A"/>
                 </a:solidFill>
                 <a:latin typeface="Arial"/>
               </a:rPr>
-              <a:t>[Your SkillsBuild Platform Mail ID Here]</a:t>
-            </a:r>
+              <a:t>SkillsBuild</a:t>
+            </a:r>
+            <a:r>
+              <a:rPr sz="1600" b="1" dirty="0">
+                <a:solidFill>
+                  <a:srgbClr val="0F172A"/>
+                </a:solidFill>
+                <a:latin typeface="Arial"/>
+              </a:rPr>
+              <a:t> Platform Mail ID:</a:t>
+            </a:r>
+            <a:r>
+              <a:rPr lang="en-US" sz="1600" b="1" dirty="0">
+                <a:solidFill>
+                  <a:srgbClr val="0F172A"/>
+                </a:solidFill>
+                <a:latin typeface="Arial"/>
+              </a:rPr>
+              <a:t>: </a:t>
+            </a:r>
+            <a:r>
+              <a:rPr lang="en-US" sz="1600" dirty="0">
+                <a:hlinkClick r:id="rId2"/>
+              </a:rPr>
+              <a:t>shegde092@gmail.com</a:t>
+            </a:r>
+            <a:r>
+              <a:rPr lang="en-US" sz="1600" dirty="0"/>
+              <a:t> and mdumr4@gamil.com</a:t>
+            </a:r>
+          </a:p>
+          <a:p>
+            <a:pPr>
+              <a:spcAft>
+                <a:spcPts val="800"/>
+              </a:spcAft>
+            </a:pPr>
+            <a:endParaRPr sz="1600" dirty="0">
+              <a:solidFill>
+                <a:srgbClr val="475569"/>
+              </a:solidFill>
+              <a:latin typeface="Arial"/>
+            </a:endParaRPr>
           </a:p>
         </p:txBody>
       </p:sp>
@@ -3359,7 +3630,7 @@
 </file>
 
 <file path=ppt/slides/slide10.xml><?xml version="1.0" encoding="utf-8"?>
-<p:sld xmlns:a="http://schemas.openxmlformats.org/drawingml/2006/main" xmlns:p="http://schemas.openxmlformats.org/presentationml/2006/main" xmlns:r="http://schemas.openxmlformats.org/officeDocument/2006/relationships">
+<p:sld xmlns:a="http://schemas.openxmlformats.org/drawingml/2006/main" xmlns:r="http://schemas.openxmlformats.org/officeDocument/2006/relationships" xmlns:p="http://schemas.openxmlformats.org/presentationml/2006/main">
   <p:cSld>
     <p:bg>
       <p:bgPr>
@@ -3375,7 +3646,14 @@
         <p:cNvGrpSpPr/>
         <p:nvPr/>
       </p:nvGrpSpPr>
-      <p:grpSpPr/>
+      <p:grpSpPr>
+        <a:xfrm>
+          <a:off x="0" y="0"/>
+          <a:ext cx="0" cy="0"/>
+          <a:chOff x="0" y="0"/>
+          <a:chExt cx="0" cy="0"/>
+        </a:xfrm>
+      </p:grpSpPr>
       <p:sp>
         <p:nvSpPr>
           <p:cNvPr id="2" name="Rectangle 1"/>
@@ -3418,6 +3696,7 @@
           <a:lstStyle/>
           <a:p>
             <a:pPr algn="ctr"/>
+            <a:endParaRPr/>
           </a:p>
         </p:txBody>
       </p:sp>
@@ -3495,7 +3774,7 @@
           </a:fontRef>
         </p:style>
         <p:txBody>
-          <a:bodyPr rtlCol="0" anchor="ctr" wrap="square"/>
+          <a:bodyPr wrap="square" rtlCol="0" anchor="ctr"/>
           <a:lstStyle/>
           <a:p>
             <a:pPr algn="ctr">
@@ -3507,25 +3786,102 @@
               </a:defRPr>
             </a:pPr>
             <a:r>
-              <a:t>[ Insert Streamlit App Screenshot Here ]</a:t>
-            </a:r>
-          </a:p>
-          <a:p>
-            <a:br/>
-            <a:pPr algn="ctr">
-              <a:defRPr sz="1400">
-                <a:solidFill>
-                  <a:srgbClr val="475569"/>
-                </a:solidFill>
-                <a:latin typeface="Arial"/>
-              </a:defRPr>
-            </a:pPr>
-            <a:r>
-              <a:t>(Take a screenshot of the running Streamlit Nutritional AI Agent UI and paste it here.)</a:t>
-            </a:r>
-          </a:p>
-        </p:txBody>
-      </p:sp>
+              <a:rPr dirty="0"/>
+              <a:t>[ Insert </a:t>
+            </a:r>
+            <a:r>
+              <a:rPr dirty="0" err="1"/>
+              <a:t>Streamlit</a:t>
+            </a:r>
+            <a:r>
+              <a:rPr dirty="0"/>
+              <a:t> App Screenshot Here ]</a:t>
+            </a:r>
+          </a:p>
+          <a:p>
+            <a:br>
+              <a:rPr dirty="0"/>
+            </a:br>
+            <a:r>
+              <a:rPr dirty="0"/>
+              <a:t>(Take a screenshot of the running </a:t>
+            </a:r>
+            <a:r>
+              <a:rPr dirty="0" err="1"/>
+              <a:t>Streamlit</a:t>
+            </a:r>
+            <a:r>
+              <a:rPr dirty="0"/>
+              <a:t> Nutritional AI Agent UI and paste it here.)</a:t>
+            </a:r>
+            <a:r>
+              <a:rPr lang="en-IN" dirty="0"/>
+              <a:t>v</a:t>
+            </a:r>
+            <a:endParaRPr dirty="0"/>
+          </a:p>
+        </p:txBody>
+      </p:sp>
+      <p:pic>
+        <p:nvPicPr>
+          <p:cNvPr id="6" name="Picture 5">
+            <a:extLst>
+              <a:ext uri="{FF2B5EF4-FFF2-40B4-BE49-F238E27FC236}">
+                <a16:creationId xmlns:a16="http://schemas.microsoft.com/office/drawing/2014/main" id="{2940EDE8-50A1-EDDB-8783-14E56AE72505}"/>
+              </a:ext>
+            </a:extLst>
+          </p:cNvPr>
+          <p:cNvPicPr>
+            <a:picLocks noChangeAspect="1"/>
+          </p:cNvPicPr>
+          <p:nvPr/>
+        </p:nvPicPr>
+        <p:blipFill>
+          <a:blip r:embed="rId2"/>
+          <a:stretch>
+            <a:fillRect/>
+          </a:stretch>
+        </p:blipFill>
+        <p:spPr>
+          <a:xfrm>
+            <a:off x="0" y="1005840"/>
+            <a:ext cx="6184497" cy="5852159"/>
+          </a:xfrm>
+          <a:prstGeom prst="rect">
+            <a:avLst/>
+          </a:prstGeom>
+        </p:spPr>
+      </p:pic>
+      <p:pic>
+        <p:nvPicPr>
+          <p:cNvPr id="8" name="Picture 7">
+            <a:extLst>
+              <a:ext uri="{FF2B5EF4-FFF2-40B4-BE49-F238E27FC236}">
+                <a16:creationId xmlns:a16="http://schemas.microsoft.com/office/drawing/2014/main" id="{0C00145C-846A-6C98-A334-E36A6859326C}"/>
+              </a:ext>
+            </a:extLst>
+          </p:cNvPr>
+          <p:cNvPicPr>
+            <a:picLocks noChangeAspect="1"/>
+          </p:cNvPicPr>
+          <p:nvPr/>
+        </p:nvPicPr>
+        <p:blipFill>
+          <a:blip r:embed="rId3"/>
+          <a:stretch>
+            <a:fillRect/>
+          </a:stretch>
+        </p:blipFill>
+        <p:spPr>
+          <a:xfrm>
+            <a:off x="6184498" y="1005840"/>
+            <a:ext cx="6007197" cy="5852159"/>
+          </a:xfrm>
+          <a:prstGeom prst="rect">
+            <a:avLst/>
+          </a:prstGeom>
+        </p:spPr>
+      </p:pic>
     </p:spTree>
   </p:cSld>
   <p:clrMapOvr>
@@ -3535,7 +3891,7 @@
 </file>
 
 <file path=ppt/slides/slide11.xml><?xml version="1.0" encoding="utf-8"?>
-<p:sld xmlns:a="http://schemas.openxmlformats.org/drawingml/2006/main" xmlns:p="http://schemas.openxmlformats.org/presentationml/2006/main" xmlns:r="http://schemas.openxmlformats.org/officeDocument/2006/relationships">
+<p:sld xmlns:a="http://schemas.openxmlformats.org/drawingml/2006/main" xmlns:r="http://schemas.openxmlformats.org/officeDocument/2006/relationships" xmlns:p="http://schemas.openxmlformats.org/presentationml/2006/main">
   <p:cSld>
     <p:bg>
       <p:bgPr>
@@ -3551,7 +3907,14 @@
         <p:cNvGrpSpPr/>
         <p:nvPr/>
       </p:nvGrpSpPr>
-      <p:grpSpPr/>
+      <p:grpSpPr>
+        <a:xfrm>
+          <a:off x="0" y="0"/>
+          <a:ext cx="0" cy="0"/>
+          <a:chOff x="0" y="0"/>
+          <a:chExt cx="0" cy="0"/>
+        </a:xfrm>
+      </p:grpSpPr>
       <p:sp>
         <p:nvSpPr>
           <p:cNvPr id="2" name="Rectangle 1"/>
@@ -3594,6 +3957,7 @@
           <a:lstStyle/>
           <a:p>
             <a:pPr algn="ctr"/>
+            <a:endParaRPr/>
           </a:p>
         </p:txBody>
       </p:sp>
@@ -3781,7 +4145,7 @@
 </file>
 
 <file path=ppt/slides/slide12.xml><?xml version="1.0" encoding="utf-8"?>
-<p:sld xmlns:a="http://schemas.openxmlformats.org/drawingml/2006/main" xmlns:p="http://schemas.openxmlformats.org/presentationml/2006/main" xmlns:r="http://schemas.openxmlformats.org/officeDocument/2006/relationships">
+<p:sld xmlns:a="http://schemas.openxmlformats.org/drawingml/2006/main" xmlns:r="http://schemas.openxmlformats.org/officeDocument/2006/relationships" xmlns:p="http://schemas.openxmlformats.org/presentationml/2006/main">
   <p:cSld>
     <p:bg>
       <p:bgPr>
@@ -3797,7 +4161,14 @@
         <p:cNvGrpSpPr/>
         <p:nvPr/>
       </p:nvGrpSpPr>
-      <p:grpSpPr/>
+      <p:grpSpPr>
+        <a:xfrm>
+          <a:off x="0" y="0"/>
+          <a:ext cx="0" cy="0"/>
+          <a:chOff x="0" y="0"/>
+          <a:chExt cx="0" cy="0"/>
+        </a:xfrm>
+      </p:grpSpPr>
       <p:sp>
         <p:nvSpPr>
           <p:cNvPr id="2" name="Rectangle 1"/>
@@ -3840,6 +4211,7 @@
           <a:lstStyle/>
           <a:p>
             <a:pPr algn="ctr"/>
+            <a:endParaRPr/>
           </a:p>
         </p:txBody>
       </p:sp>
@@ -4045,7 +4417,7 @@
 </file>
 
 <file path=ppt/slides/slide13.xml><?xml version="1.0" encoding="utf-8"?>
-<p:sld xmlns:a="http://schemas.openxmlformats.org/drawingml/2006/main" xmlns:p="http://schemas.openxmlformats.org/presentationml/2006/main" xmlns:r="http://schemas.openxmlformats.org/officeDocument/2006/relationships">
+<p:sld xmlns:a="http://schemas.openxmlformats.org/drawingml/2006/main" xmlns:r="http://schemas.openxmlformats.org/officeDocument/2006/relationships" xmlns:p="http://schemas.openxmlformats.org/presentationml/2006/main">
   <p:cSld>
     <p:bg>
       <p:bgPr>
@@ -4061,7 +4433,14 @@
         <p:cNvGrpSpPr/>
         <p:nvPr/>
       </p:nvGrpSpPr>
-      <p:grpSpPr/>
+      <p:grpSpPr>
+        <a:xfrm>
+          <a:off x="0" y="0"/>
+          <a:ext cx="0" cy="0"/>
+          <a:chOff x="0" y="0"/>
+          <a:chExt cx="0" cy="0"/>
+        </a:xfrm>
+      </p:grpSpPr>
       <p:sp>
         <p:nvSpPr>
           <p:cNvPr id="2" name="Rectangle 1"/>
@@ -4104,116 +4483,40 @@
           <a:lstStyle/>
           <a:p>
             <a:pPr algn="ctr"/>
-          </a:p>
-        </p:txBody>
-      </p:sp>
-      <p:sp>
-        <p:nvSpPr>
-          <p:cNvPr id="3" name="TextBox 2"/>
-          <p:cNvSpPr txBox="1"/>
+            <a:endParaRPr/>
+          </a:p>
+        </p:txBody>
+      </p:sp>
+      <p:pic>
+        <p:nvPicPr>
+          <p:cNvPr id="12" name="Picture 11">
+            <a:extLst>
+              <a:ext uri="{FF2B5EF4-FFF2-40B4-BE49-F238E27FC236}">
+                <a16:creationId xmlns:a16="http://schemas.microsoft.com/office/drawing/2014/main" id="{EF3FD05A-36C5-2866-4168-5BDD910CBBFF}"/>
+              </a:ext>
+            </a:extLst>
+          </p:cNvPr>
+          <p:cNvPicPr>
+            <a:picLocks noChangeAspect="1"/>
+          </p:cNvPicPr>
           <p:nvPr/>
-        </p:nvSpPr>
+        </p:nvPicPr>
+        <p:blipFill>
+          <a:blip r:embed="rId2"/>
+          <a:stretch>
+            <a:fillRect/>
+          </a:stretch>
+        </p:blipFill>
         <p:spPr>
           <a:xfrm>
-            <a:off x="731520" y="137160"/>
-            <a:ext cx="10728655" cy="731520"/>
+            <a:off x="2298583" y="2228746"/>
+            <a:ext cx="7633982" cy="2400508"/>
           </a:xfrm>
           <a:prstGeom prst="rect">
             <a:avLst/>
           </a:prstGeom>
-          <a:noFill/>
         </p:spPr>
-        <p:txBody>
-          <a:bodyPr wrap="square">
-            <a:spAutoFit/>
-          </a:bodyPr>
-          <a:lstStyle/>
-          <a:p>
-            <a:pPr algn="l">
-              <a:defRPr sz="2800" b="1">
-                <a:solidFill>
-                  <a:srgbClr val="10B981"/>
-                </a:solidFill>
-                <a:latin typeface="Arial"/>
-              </a:defRPr>
-            </a:pPr>
-            <a:r>
-              <a:t>What to submit ?</a:t>
-            </a:r>
-          </a:p>
-        </p:txBody>
-      </p:sp>
-      <p:sp>
-        <p:nvSpPr>
-          <p:cNvPr id="4" name="TextBox 3"/>
-          <p:cNvSpPr txBox="1"/>
-          <p:nvPr/>
-        </p:nvSpPr>
-        <p:spPr>
-          <a:xfrm>
-            <a:off x="731520" y="2011680"/>
-            <a:ext cx="10728655" cy="4114800"/>
-          </a:xfrm>
-          <a:prstGeom prst="rect">
-            <a:avLst/>
-          </a:prstGeom>
-          <a:noFill/>
-        </p:spPr>
-        <p:txBody>
-          <a:bodyPr wrap="square" tIns="91440" bIns="91440">
-            <a:spAutoFit/>
-          </a:bodyPr>
-          <a:lstStyle/>
-          <a:p>
-            <a:pPr>
-              <a:spcAft>
-                <a:spcPts val="2000"/>
-              </a:spcAft>
-              <a:defRPr sz="2600" b="1">
-                <a:solidFill>
-                  <a:srgbClr val="0F172A"/>
-                </a:solidFill>
-                <a:latin typeface="Arial"/>
-              </a:defRPr>
-            </a:pPr>
-            <a:r>
-              <a:t>• Lean Canvas PDF</a:t>
-            </a:r>
-          </a:p>
-          <a:p>
-            <a:pPr>
-              <a:spcAft>
-                <a:spcPts val="2000"/>
-              </a:spcAft>
-              <a:defRPr sz="2600" b="1">
-                <a:solidFill>
-                  <a:srgbClr val="0F172A"/>
-                </a:solidFill>
-                <a:latin typeface="Arial"/>
-              </a:defRPr>
-            </a:pPr>
-            <a:r>
-              <a:t>• Concept Note</a:t>
-            </a:r>
-          </a:p>
-          <a:p>
-            <a:pPr>
-              <a:spcAft>
-                <a:spcPts val="2000"/>
-              </a:spcAft>
-              <a:defRPr sz="2600" b="1">
-                <a:solidFill>
-                  <a:srgbClr val="0F172A"/>
-                </a:solidFill>
-                <a:latin typeface="Arial"/>
-              </a:defRPr>
-            </a:pPr>
-            <a:r>
-              <a:t>• Power point Presentation</a:t>
-            </a:r>
-          </a:p>
-        </p:txBody>
-      </p:sp>
+      </p:pic>
     </p:spTree>
   </p:cSld>
   <p:clrMapOvr>
@@ -4223,7 +4526,7 @@
 </file>
 
 <file path=ppt/slides/slide2.xml><?xml version="1.0" encoding="utf-8"?>
-<p:sld xmlns:a="http://schemas.openxmlformats.org/drawingml/2006/main" xmlns:p="http://schemas.openxmlformats.org/presentationml/2006/main" xmlns:r="http://schemas.openxmlformats.org/officeDocument/2006/relationships">
+<p:sld xmlns:a="http://schemas.openxmlformats.org/drawingml/2006/main" xmlns:r="http://schemas.openxmlformats.org/officeDocument/2006/relationships" xmlns:p="http://schemas.openxmlformats.org/presentationml/2006/main">
   <p:cSld>
     <p:bg>
       <p:bgPr>
@@ -4239,7 +4542,14 @@
         <p:cNvGrpSpPr/>
         <p:nvPr/>
       </p:nvGrpSpPr>
-      <p:grpSpPr/>
+      <p:grpSpPr>
+        <a:xfrm>
+          <a:off x="0" y="0"/>
+          <a:ext cx="0" cy="0"/>
+          <a:chOff x="0" y="0"/>
+          <a:chExt cx="0" cy="0"/>
+        </a:xfrm>
+      </p:grpSpPr>
       <p:sp>
         <p:nvSpPr>
           <p:cNvPr id="2" name="Rectangle 1"/>
@@ -4282,6 +4592,7 @@
           <a:lstStyle/>
           <a:p>
             <a:pPr algn="ctr"/>
+            <a:endParaRPr/>
           </a:p>
         </p:txBody>
       </p:sp>
@@ -4490,7 +4801,7 @@
 </file>
 
 <file path=ppt/slides/slide3.xml><?xml version="1.0" encoding="utf-8"?>
-<p:sld xmlns:a="http://schemas.openxmlformats.org/drawingml/2006/main" xmlns:p="http://schemas.openxmlformats.org/presentationml/2006/main" xmlns:r="http://schemas.openxmlformats.org/officeDocument/2006/relationships">
+<p:sld xmlns:a="http://schemas.openxmlformats.org/drawingml/2006/main" xmlns:r="http://schemas.openxmlformats.org/officeDocument/2006/relationships" xmlns:p="http://schemas.openxmlformats.org/presentationml/2006/main">
   <p:cSld>
     <p:bg>
       <p:bgPr>
@@ -4506,7 +4817,14 @@
         <p:cNvGrpSpPr/>
         <p:nvPr/>
       </p:nvGrpSpPr>
-      <p:grpSpPr/>
+      <p:grpSpPr>
+        <a:xfrm>
+          <a:off x="0" y="0"/>
+          <a:ext cx="0" cy="0"/>
+          <a:chOff x="0" y="0"/>
+          <a:chExt cx="0" cy="0"/>
+        </a:xfrm>
+      </p:grpSpPr>
       <p:sp>
         <p:nvSpPr>
           <p:cNvPr id="2" name="Rectangle 1"/>
@@ -4549,6 +4867,7 @@
           <a:lstStyle/>
           <a:p>
             <a:pPr algn="ctr"/>
+            <a:endParaRPr/>
           </a:p>
         </p:txBody>
       </p:sp>
@@ -4738,7 +5057,7 @@
 </file>
 
 <file path=ppt/slides/slide4.xml><?xml version="1.0" encoding="utf-8"?>
-<p:sld xmlns:a="http://schemas.openxmlformats.org/drawingml/2006/main" xmlns:p="http://schemas.openxmlformats.org/presentationml/2006/main" xmlns:r="http://schemas.openxmlformats.org/officeDocument/2006/relationships">
+<p:sld xmlns:a="http://schemas.openxmlformats.org/drawingml/2006/main" xmlns:r="http://schemas.openxmlformats.org/officeDocument/2006/relationships" xmlns:p="http://schemas.openxmlformats.org/presentationml/2006/main">
   <p:cSld>
     <p:bg>
       <p:bgPr>
@@ -4754,7 +5073,14 @@
         <p:cNvGrpSpPr/>
         <p:nvPr/>
       </p:nvGrpSpPr>
-      <p:grpSpPr/>
+      <p:grpSpPr>
+        <a:xfrm>
+          <a:off x="0" y="0"/>
+          <a:ext cx="0" cy="0"/>
+          <a:chOff x="0" y="0"/>
+          <a:chExt cx="0" cy="0"/>
+        </a:xfrm>
+      </p:grpSpPr>
       <p:sp>
         <p:nvSpPr>
           <p:cNvPr id="2" name="Rectangle 1"/>
@@ -4797,6 +5123,7 @@
           <a:lstStyle/>
           <a:p>
             <a:pPr algn="ctr"/>
+            <a:endParaRPr/>
           </a:p>
         </p:txBody>
       </p:sp>
@@ -4986,7 +5313,7 @@
 </file>
 
 <file path=ppt/slides/slide5.xml><?xml version="1.0" encoding="utf-8"?>
-<p:sld xmlns:a="http://schemas.openxmlformats.org/drawingml/2006/main" xmlns:p="http://schemas.openxmlformats.org/presentationml/2006/main" xmlns:r="http://schemas.openxmlformats.org/officeDocument/2006/relationships">
+<p:sld xmlns:a="http://schemas.openxmlformats.org/drawingml/2006/main" xmlns:r="http://schemas.openxmlformats.org/officeDocument/2006/relationships" xmlns:p="http://schemas.openxmlformats.org/presentationml/2006/main">
   <p:cSld>
     <p:bg>
       <p:bgPr>
@@ -5002,7 +5329,14 @@
         <p:cNvGrpSpPr/>
         <p:nvPr/>
       </p:nvGrpSpPr>
-      <p:grpSpPr/>
+      <p:grpSpPr>
+        <a:xfrm>
+          <a:off x="0" y="0"/>
+          <a:ext cx="0" cy="0"/>
+          <a:chOff x="0" y="0"/>
+          <a:chExt cx="0" cy="0"/>
+        </a:xfrm>
+      </p:grpSpPr>
       <p:sp>
         <p:nvSpPr>
           <p:cNvPr id="2" name="Rectangle 1"/>
@@ -5045,6 +5379,7 @@
           <a:lstStyle/>
           <a:p>
             <a:pPr algn="ctr"/>
+            <a:endParaRPr/>
           </a:p>
         </p:txBody>
       </p:sp>
@@ -5234,7 +5569,7 @@
 </file>
 
 <file path=ppt/slides/slide6.xml><?xml version="1.0" encoding="utf-8"?>
-<p:sld xmlns:a="http://schemas.openxmlformats.org/drawingml/2006/main" xmlns:p="http://schemas.openxmlformats.org/presentationml/2006/main" xmlns:r="http://schemas.openxmlformats.org/officeDocument/2006/relationships">
+<p:sld xmlns:a="http://schemas.openxmlformats.org/drawingml/2006/main" xmlns:r="http://schemas.openxmlformats.org/officeDocument/2006/relationships" xmlns:p="http://schemas.openxmlformats.org/presentationml/2006/main">
   <p:cSld>
     <p:bg>
       <p:bgPr>
@@ -5250,7 +5585,14 @@
         <p:cNvGrpSpPr/>
         <p:nvPr/>
       </p:nvGrpSpPr>
-      <p:grpSpPr/>
+      <p:grpSpPr>
+        <a:xfrm>
+          <a:off x="0" y="0"/>
+          <a:ext cx="0" cy="0"/>
+          <a:chOff x="0" y="0"/>
+          <a:chExt cx="0" cy="0"/>
+        </a:xfrm>
+      </p:grpSpPr>
       <p:sp>
         <p:nvSpPr>
           <p:cNvPr id="2" name="Rectangle 1"/>
@@ -5293,6 +5635,7 @@
           <a:lstStyle/>
           <a:p>
             <a:pPr algn="ctr"/>
+            <a:endParaRPr/>
           </a:p>
         </p:txBody>
       </p:sp>
@@ -5482,7 +5825,7 @@
 </file>
 
 <file path=ppt/slides/slide7.xml><?xml version="1.0" encoding="utf-8"?>
-<p:sld xmlns:a="http://schemas.openxmlformats.org/drawingml/2006/main" xmlns:p="http://schemas.openxmlformats.org/presentationml/2006/main" xmlns:r="http://schemas.openxmlformats.org/officeDocument/2006/relationships">
+<p:sld xmlns:a="http://schemas.openxmlformats.org/drawingml/2006/main" xmlns:r="http://schemas.openxmlformats.org/officeDocument/2006/relationships" xmlns:p="http://schemas.openxmlformats.org/presentationml/2006/main">
   <p:cSld>
     <p:bg>
       <p:bgPr>
@@ -5498,7 +5841,14 @@
         <p:cNvGrpSpPr/>
         <p:nvPr/>
       </p:nvGrpSpPr>
-      <p:grpSpPr/>
+      <p:grpSpPr>
+        <a:xfrm>
+          <a:off x="0" y="0"/>
+          <a:ext cx="0" cy="0"/>
+          <a:chOff x="0" y="0"/>
+          <a:chExt cx="0" cy="0"/>
+        </a:xfrm>
+      </p:grpSpPr>
       <p:sp>
         <p:nvSpPr>
           <p:cNvPr id="2" name="Rectangle 1"/>
@@ -5541,6 +5891,7 @@
           <a:lstStyle/>
           <a:p>
             <a:pPr algn="ctr"/>
+            <a:endParaRPr/>
           </a:p>
         </p:txBody>
       </p:sp>
@@ -5746,7 +6097,7 @@
 </file>
 
 <file path=ppt/slides/slide8.xml><?xml version="1.0" encoding="utf-8"?>
-<p:sld xmlns:a="http://schemas.openxmlformats.org/drawingml/2006/main" xmlns:p="http://schemas.openxmlformats.org/presentationml/2006/main" xmlns:r="http://schemas.openxmlformats.org/officeDocument/2006/relationships">
+<p:sld xmlns:a="http://schemas.openxmlformats.org/drawingml/2006/main" xmlns:r="http://schemas.openxmlformats.org/officeDocument/2006/relationships" xmlns:p="http://schemas.openxmlformats.org/presentationml/2006/main">
   <p:cSld>
     <p:bg>
       <p:bgPr>
@@ -5762,7 +6113,14 @@
         <p:cNvGrpSpPr/>
         <p:nvPr/>
       </p:nvGrpSpPr>
-      <p:grpSpPr/>
+      <p:grpSpPr>
+        <a:xfrm>
+          <a:off x="0" y="0"/>
+          <a:ext cx="0" cy="0"/>
+          <a:chOff x="0" y="0"/>
+          <a:chExt cx="0" cy="0"/>
+        </a:xfrm>
+      </p:grpSpPr>
       <p:sp>
         <p:nvSpPr>
           <p:cNvPr id="2" name="Rectangle 1"/>
@@ -5805,6 +6163,7 @@
           <a:lstStyle/>
           <a:p>
             <a:pPr algn="ctr"/>
+            <a:endParaRPr/>
           </a:p>
         </p:txBody>
       </p:sp>
@@ -5997,7 +6356,7 @@
 </file>
 
 <file path=ppt/slides/slide9.xml><?xml version="1.0" encoding="utf-8"?>
-<p:sld xmlns:a="http://schemas.openxmlformats.org/drawingml/2006/main" xmlns:p="http://schemas.openxmlformats.org/presentationml/2006/main" xmlns:r="http://schemas.openxmlformats.org/officeDocument/2006/relationships">
+<p:sld xmlns:a="http://schemas.openxmlformats.org/drawingml/2006/main" xmlns:r="http://schemas.openxmlformats.org/officeDocument/2006/relationships" xmlns:p="http://schemas.openxmlformats.org/presentationml/2006/main">
   <p:cSld>
     <p:bg>
       <p:bgPr>
@@ -6013,7 +6372,14 @@
         <p:cNvGrpSpPr/>
         <p:nvPr/>
       </p:nvGrpSpPr>
-      <p:grpSpPr/>
+      <p:grpSpPr>
+        <a:xfrm>
+          <a:off x="0" y="0"/>
+          <a:ext cx="0" cy="0"/>
+          <a:chOff x="0" y="0"/>
+          <a:chExt cx="0" cy="0"/>
+        </a:xfrm>
+      </p:grpSpPr>
       <p:sp>
         <p:nvSpPr>
           <p:cNvPr id="2" name="Rectangle 1"/>
@@ -6056,6 +6422,7 @@
           <a:lstStyle/>
           <a:p>
             <a:pPr algn="ctr"/>
+            <a:endParaRPr/>
           </a:p>
         </p:txBody>
       </p:sp>

</xml_diff>